<commit_message>
feat: dump of figures and first pass on code +caption
</commit_message>
<xml_diff>
--- a/figures/fig2/fig2.pptx
+++ b/figures/fig2/fig2.pptx
@@ -5,9 +5,9 @@
     <p:sldMasterId id="2147483648" r:id="rId1"/>
   </p:sldMasterIdLst>
   <p:sldIdLst>
-    <p:sldId id="256" r:id="rId7"/>
+    <p:sldId id="256" r:id="rId2"/>
   </p:sldIdLst>
-  <p:sldSz cx="5940000" cy="8136000" type="screen4x3"/>
+  <p:sldSz cx="5940425" cy="8135938"/>
   <p:notesSz cx="6858000" cy="9144000"/>
   <p:defaultTextStyle>
     <a:defPPr>
@@ -104,6 +104,22 @@
       </a:defRPr>
     </a:lvl9pPr>
   </p:defaultTextStyle>
+  <p:extLst>
+    <p:ext uri="{EFAFB233-063F-42B5-8137-9DF3F51BA10A}">
+      <p15:sldGuideLst xmlns:p15="http://schemas.microsoft.com/office/powerpoint/2012/main">
+        <p15:guide id="1" orient="horz" pos="2160">
+          <p15:clr>
+            <a:srgbClr val="A4A3A4"/>
+          </p15:clr>
+        </p15:guide>
+        <p15:guide id="2" pos="2880">
+          <p15:clr>
+            <a:srgbClr val="A4A3A4"/>
+          </p15:clr>
+        </p15:guide>
+      </p15:sldGuideLst>
+    </p:ext>
+  </p:extLst>
 </p:presentation>
 </file>
 
@@ -145,10 +161,9 @@
           <a:lstStyle/>
           <a:p>
             <a:r>
-              <a:rPr lang="en-US" smtClean="0"/>
+              <a:rPr lang="en-US"/>
               <a:t>Click to edit Master title style</a:t>
             </a:r>
-            <a:endParaRPr lang="en-US"/>
           </a:p>
         </p:txBody>
       </p:sp>
@@ -264,10 +279,9 @@
           </a:lstStyle>
           <a:p>
             <a:r>
-              <a:rPr lang="en-US" smtClean="0"/>
+              <a:rPr lang="en-US"/>
               <a:t>Click to edit Master subtitle style</a:t>
             </a:r>
-            <a:endParaRPr lang="en-US"/>
           </a:p>
         </p:txBody>
       </p:sp>
@@ -288,7 +302,7 @@
           <a:p>
             <a:fld id="{5BCAD085-E8A6-8845-BD4E-CB4CCA059FC4}" type="datetimeFigureOut">
               <a:rPr lang="en-US" smtClean="0"/>
-              <a:t>1/27/13</a:t>
+              <a:t>10/16/2026</a:t>
             </a:fld>
             <a:endParaRPr lang="en-US"/>
           </a:p>
@@ -382,10 +396,9 @@
           <a:lstStyle/>
           <a:p>
             <a:r>
-              <a:rPr lang="en-US" smtClean="0"/>
+              <a:rPr lang="en-US"/>
               <a:t>Click to edit Master title style</a:t>
             </a:r>
-            <a:endParaRPr lang="en-US"/>
           </a:p>
         </p:txBody>
       </p:sp>
@@ -406,38 +419,37 @@
           <a:p>
             <a:pPr lvl="0"/>
             <a:r>
-              <a:rPr lang="en-US" smtClean="0"/>
+              <a:rPr lang="en-US"/>
               <a:t>Click to edit Master text styles</a:t>
             </a:r>
           </a:p>
           <a:p>
             <a:pPr lvl="1"/>
             <a:r>
-              <a:rPr lang="en-US" smtClean="0"/>
+              <a:rPr lang="en-US"/>
               <a:t>Second level</a:t>
             </a:r>
           </a:p>
           <a:p>
             <a:pPr lvl="2"/>
             <a:r>
-              <a:rPr lang="en-US" smtClean="0"/>
+              <a:rPr lang="en-US"/>
               <a:t>Third level</a:t>
             </a:r>
           </a:p>
           <a:p>
             <a:pPr lvl="3"/>
             <a:r>
-              <a:rPr lang="en-US" smtClean="0"/>
+              <a:rPr lang="en-US"/>
               <a:t>Fourth level</a:t>
             </a:r>
           </a:p>
           <a:p>
             <a:pPr lvl="4"/>
             <a:r>
-              <a:rPr lang="en-US" smtClean="0"/>
+              <a:rPr lang="en-US"/>
               <a:t>Fifth level</a:t>
             </a:r>
-            <a:endParaRPr lang="en-US"/>
           </a:p>
         </p:txBody>
       </p:sp>
@@ -458,7 +470,7 @@
           <a:p>
             <a:fld id="{5BCAD085-E8A6-8845-BD4E-CB4CCA059FC4}" type="datetimeFigureOut">
               <a:rPr lang="en-US" smtClean="0"/>
-              <a:t>1/27/13</a:t>
+              <a:t>10/16/2026</a:t>
             </a:fld>
             <a:endParaRPr lang="en-US"/>
           </a:p>
@@ -557,10 +569,9 @@
           <a:lstStyle/>
           <a:p>
             <a:r>
-              <a:rPr lang="en-US" smtClean="0"/>
+              <a:rPr lang="en-US"/>
               <a:t>Click to edit Master title style</a:t>
             </a:r>
-            <a:endParaRPr lang="en-US"/>
           </a:p>
         </p:txBody>
       </p:sp>
@@ -586,38 +597,37 @@
           <a:p>
             <a:pPr lvl="0"/>
             <a:r>
-              <a:rPr lang="en-US" smtClean="0"/>
+              <a:rPr lang="en-US"/>
               <a:t>Click to edit Master text styles</a:t>
             </a:r>
           </a:p>
           <a:p>
             <a:pPr lvl="1"/>
             <a:r>
-              <a:rPr lang="en-US" smtClean="0"/>
+              <a:rPr lang="en-US"/>
               <a:t>Second level</a:t>
             </a:r>
           </a:p>
           <a:p>
             <a:pPr lvl="2"/>
             <a:r>
-              <a:rPr lang="en-US" smtClean="0"/>
+              <a:rPr lang="en-US"/>
               <a:t>Third level</a:t>
             </a:r>
           </a:p>
           <a:p>
             <a:pPr lvl="3"/>
             <a:r>
-              <a:rPr lang="en-US" smtClean="0"/>
+              <a:rPr lang="en-US"/>
               <a:t>Fourth level</a:t>
             </a:r>
           </a:p>
           <a:p>
             <a:pPr lvl="4"/>
             <a:r>
-              <a:rPr lang="en-US" smtClean="0"/>
+              <a:rPr lang="en-US"/>
               <a:t>Fifth level</a:t>
             </a:r>
-            <a:endParaRPr lang="en-US"/>
           </a:p>
         </p:txBody>
       </p:sp>
@@ -638,7 +648,7 @@
           <a:p>
             <a:fld id="{5BCAD085-E8A6-8845-BD4E-CB4CCA059FC4}" type="datetimeFigureOut">
               <a:rPr lang="en-US" smtClean="0"/>
-              <a:t>1/27/13</a:t>
+              <a:t>10/16/2026</a:t>
             </a:fld>
             <a:endParaRPr lang="en-US"/>
           </a:p>
@@ -732,10 +742,9 @@
           <a:lstStyle/>
           <a:p>
             <a:r>
-              <a:rPr lang="en-US" smtClean="0"/>
+              <a:rPr lang="en-US"/>
               <a:t>Click to edit Master title style</a:t>
             </a:r>
-            <a:endParaRPr lang="en-US"/>
           </a:p>
         </p:txBody>
       </p:sp>
@@ -756,38 +765,37 @@
           <a:p>
             <a:pPr lvl="0"/>
             <a:r>
-              <a:rPr lang="en-US" smtClean="0"/>
+              <a:rPr lang="en-US"/>
               <a:t>Click to edit Master text styles</a:t>
             </a:r>
           </a:p>
           <a:p>
             <a:pPr lvl="1"/>
             <a:r>
-              <a:rPr lang="en-US" smtClean="0"/>
+              <a:rPr lang="en-US"/>
               <a:t>Second level</a:t>
             </a:r>
           </a:p>
           <a:p>
             <a:pPr lvl="2"/>
             <a:r>
-              <a:rPr lang="en-US" smtClean="0"/>
+              <a:rPr lang="en-US"/>
               <a:t>Third level</a:t>
             </a:r>
           </a:p>
           <a:p>
             <a:pPr lvl="3"/>
             <a:r>
-              <a:rPr lang="en-US" smtClean="0"/>
+              <a:rPr lang="en-US"/>
               <a:t>Fourth level</a:t>
             </a:r>
           </a:p>
           <a:p>
             <a:pPr lvl="4"/>
             <a:r>
-              <a:rPr lang="en-US" smtClean="0"/>
+              <a:rPr lang="en-US"/>
               <a:t>Fifth level</a:t>
             </a:r>
-            <a:endParaRPr lang="en-US"/>
           </a:p>
         </p:txBody>
       </p:sp>
@@ -808,7 +816,7 @@
           <a:p>
             <a:fld id="{5BCAD085-E8A6-8845-BD4E-CB4CCA059FC4}" type="datetimeFigureOut">
               <a:rPr lang="en-US" smtClean="0"/>
-              <a:t>1/27/13</a:t>
+              <a:t>10/16/2026</a:t>
             </a:fld>
             <a:endParaRPr lang="en-US"/>
           </a:p>
@@ -911,10 +919,9 @@
           </a:lstStyle>
           <a:p>
             <a:r>
-              <a:rPr lang="en-US" smtClean="0"/>
+              <a:rPr lang="en-US"/>
               <a:t>Click to edit Master title style</a:t>
             </a:r>
-            <a:endParaRPr lang="en-US"/>
           </a:p>
         </p:txBody>
       </p:sp>
@@ -1031,7 +1038,7 @@
           <a:p>
             <a:pPr lvl="0"/>
             <a:r>
-              <a:rPr lang="en-US" smtClean="0"/>
+              <a:rPr lang="en-US"/>
               <a:t>Click to edit Master text styles</a:t>
             </a:r>
           </a:p>
@@ -1054,7 +1061,7 @@
           <a:p>
             <a:fld id="{5BCAD085-E8A6-8845-BD4E-CB4CCA059FC4}" type="datetimeFigureOut">
               <a:rPr lang="en-US" smtClean="0"/>
-              <a:t>1/27/13</a:t>
+              <a:t>10/16/2026</a:t>
             </a:fld>
             <a:endParaRPr lang="en-US"/>
           </a:p>
@@ -1148,10 +1155,9 @@
           <a:lstStyle/>
           <a:p>
             <a:r>
-              <a:rPr lang="en-US" smtClean="0"/>
+              <a:rPr lang="en-US"/>
               <a:t>Click to edit Master title style</a:t>
             </a:r>
-            <a:endParaRPr lang="en-US"/>
           </a:p>
         </p:txBody>
       </p:sp>
@@ -1205,38 +1211,37 @@
           <a:p>
             <a:pPr lvl="0"/>
             <a:r>
-              <a:rPr lang="en-US" smtClean="0"/>
+              <a:rPr lang="en-US"/>
               <a:t>Click to edit Master text styles</a:t>
             </a:r>
           </a:p>
           <a:p>
             <a:pPr lvl="1"/>
             <a:r>
-              <a:rPr lang="en-US" smtClean="0"/>
+              <a:rPr lang="en-US"/>
               <a:t>Second level</a:t>
             </a:r>
           </a:p>
           <a:p>
             <a:pPr lvl="2"/>
             <a:r>
-              <a:rPr lang="en-US" smtClean="0"/>
+              <a:rPr lang="en-US"/>
               <a:t>Third level</a:t>
             </a:r>
           </a:p>
           <a:p>
             <a:pPr lvl="3"/>
             <a:r>
-              <a:rPr lang="en-US" smtClean="0"/>
+              <a:rPr lang="en-US"/>
               <a:t>Fourth level</a:t>
             </a:r>
           </a:p>
           <a:p>
             <a:pPr lvl="4"/>
             <a:r>
-              <a:rPr lang="en-US" smtClean="0"/>
+              <a:rPr lang="en-US"/>
               <a:t>Fifth level</a:t>
             </a:r>
-            <a:endParaRPr lang="en-US"/>
           </a:p>
         </p:txBody>
       </p:sp>
@@ -1290,38 +1295,37 @@
           <a:p>
             <a:pPr lvl="0"/>
             <a:r>
-              <a:rPr lang="en-US" smtClean="0"/>
+              <a:rPr lang="en-US"/>
               <a:t>Click to edit Master text styles</a:t>
             </a:r>
           </a:p>
           <a:p>
             <a:pPr lvl="1"/>
             <a:r>
-              <a:rPr lang="en-US" smtClean="0"/>
+              <a:rPr lang="en-US"/>
               <a:t>Second level</a:t>
             </a:r>
           </a:p>
           <a:p>
             <a:pPr lvl="2"/>
             <a:r>
-              <a:rPr lang="en-US" smtClean="0"/>
+              <a:rPr lang="en-US"/>
               <a:t>Third level</a:t>
             </a:r>
           </a:p>
           <a:p>
             <a:pPr lvl="3"/>
             <a:r>
-              <a:rPr lang="en-US" smtClean="0"/>
+              <a:rPr lang="en-US"/>
               <a:t>Fourth level</a:t>
             </a:r>
           </a:p>
           <a:p>
             <a:pPr lvl="4"/>
             <a:r>
-              <a:rPr lang="en-US" smtClean="0"/>
+              <a:rPr lang="en-US"/>
               <a:t>Fifth level</a:t>
             </a:r>
-            <a:endParaRPr lang="en-US"/>
           </a:p>
         </p:txBody>
       </p:sp>
@@ -1342,7 +1346,7 @@
           <a:p>
             <a:fld id="{5BCAD085-E8A6-8845-BD4E-CB4CCA059FC4}" type="datetimeFigureOut">
               <a:rPr lang="en-US" smtClean="0"/>
-              <a:t>1/27/13</a:t>
+              <a:t>10/16/2026</a:t>
             </a:fld>
             <a:endParaRPr lang="en-US"/>
           </a:p>
@@ -1440,10 +1444,9 @@
           </a:lstStyle>
           <a:p>
             <a:r>
-              <a:rPr lang="en-US" smtClean="0"/>
+              <a:rPr lang="en-US"/>
               <a:t>Click to edit Master title style</a:t>
             </a:r>
-            <a:endParaRPr lang="en-US"/>
           </a:p>
         </p:txBody>
       </p:sp>
@@ -1506,7 +1509,7 @@
           <a:p>
             <a:pPr lvl="0"/>
             <a:r>
-              <a:rPr lang="en-US" smtClean="0"/>
+              <a:rPr lang="en-US"/>
               <a:t>Click to edit Master text styles</a:t>
             </a:r>
           </a:p>
@@ -1562,38 +1565,37 @@
           <a:p>
             <a:pPr lvl="0"/>
             <a:r>
-              <a:rPr lang="en-US" smtClean="0"/>
+              <a:rPr lang="en-US"/>
               <a:t>Click to edit Master text styles</a:t>
             </a:r>
           </a:p>
           <a:p>
             <a:pPr lvl="1"/>
             <a:r>
-              <a:rPr lang="en-US" smtClean="0"/>
+              <a:rPr lang="en-US"/>
               <a:t>Second level</a:t>
             </a:r>
           </a:p>
           <a:p>
             <a:pPr lvl="2"/>
             <a:r>
-              <a:rPr lang="en-US" smtClean="0"/>
+              <a:rPr lang="en-US"/>
               <a:t>Third level</a:t>
             </a:r>
           </a:p>
           <a:p>
             <a:pPr lvl="3"/>
             <a:r>
-              <a:rPr lang="en-US" smtClean="0"/>
+              <a:rPr lang="en-US"/>
               <a:t>Fourth level</a:t>
             </a:r>
           </a:p>
           <a:p>
             <a:pPr lvl="4"/>
             <a:r>
-              <a:rPr lang="en-US" smtClean="0"/>
+              <a:rPr lang="en-US"/>
               <a:t>Fifth level</a:t>
             </a:r>
-            <a:endParaRPr lang="en-US"/>
           </a:p>
         </p:txBody>
       </p:sp>
@@ -1656,7 +1658,7 @@
           <a:p>
             <a:pPr lvl="0"/>
             <a:r>
-              <a:rPr lang="en-US" smtClean="0"/>
+              <a:rPr lang="en-US"/>
               <a:t>Click to edit Master text styles</a:t>
             </a:r>
           </a:p>
@@ -1712,38 +1714,37 @@
           <a:p>
             <a:pPr lvl="0"/>
             <a:r>
-              <a:rPr lang="en-US" smtClean="0"/>
+              <a:rPr lang="en-US"/>
               <a:t>Click to edit Master text styles</a:t>
             </a:r>
           </a:p>
           <a:p>
             <a:pPr lvl="1"/>
             <a:r>
-              <a:rPr lang="en-US" smtClean="0"/>
+              <a:rPr lang="en-US"/>
               <a:t>Second level</a:t>
             </a:r>
           </a:p>
           <a:p>
             <a:pPr lvl="2"/>
             <a:r>
-              <a:rPr lang="en-US" smtClean="0"/>
+              <a:rPr lang="en-US"/>
               <a:t>Third level</a:t>
             </a:r>
           </a:p>
           <a:p>
             <a:pPr lvl="3"/>
             <a:r>
-              <a:rPr lang="en-US" smtClean="0"/>
+              <a:rPr lang="en-US"/>
               <a:t>Fourth level</a:t>
             </a:r>
           </a:p>
           <a:p>
             <a:pPr lvl="4"/>
             <a:r>
-              <a:rPr lang="en-US" smtClean="0"/>
+              <a:rPr lang="en-US"/>
               <a:t>Fifth level</a:t>
             </a:r>
-            <a:endParaRPr lang="en-US"/>
           </a:p>
         </p:txBody>
       </p:sp>
@@ -1764,7 +1765,7 @@
           <a:p>
             <a:fld id="{5BCAD085-E8A6-8845-BD4E-CB4CCA059FC4}" type="datetimeFigureOut">
               <a:rPr lang="en-US" smtClean="0"/>
-              <a:t>1/27/13</a:t>
+              <a:t>10/16/2026</a:t>
             </a:fld>
             <a:endParaRPr lang="en-US"/>
           </a:p>
@@ -1858,10 +1859,9 @@
           <a:lstStyle/>
           <a:p>
             <a:r>
-              <a:rPr lang="en-US" smtClean="0"/>
+              <a:rPr lang="en-US"/>
               <a:t>Click to edit Master title style</a:t>
             </a:r>
-            <a:endParaRPr lang="en-US"/>
           </a:p>
         </p:txBody>
       </p:sp>
@@ -1882,7 +1882,7 @@
           <a:p>
             <a:fld id="{5BCAD085-E8A6-8845-BD4E-CB4CCA059FC4}" type="datetimeFigureOut">
               <a:rPr lang="en-US" smtClean="0"/>
-              <a:t>1/27/13</a:t>
+              <a:t>10/16/2026</a:t>
             </a:fld>
             <a:endParaRPr lang="en-US"/>
           </a:p>
@@ -1977,7 +1977,7 @@
           <a:p>
             <a:fld id="{5BCAD085-E8A6-8845-BD4E-CB4CCA059FC4}" type="datetimeFigureOut">
               <a:rPr lang="en-US" smtClean="0"/>
-              <a:t>1/27/13</a:t>
+              <a:t>10/16/2026</a:t>
             </a:fld>
             <a:endParaRPr lang="en-US"/>
           </a:p>
@@ -2080,10 +2080,9 @@
           </a:lstStyle>
           <a:p>
             <a:r>
-              <a:rPr lang="en-US" smtClean="0"/>
+              <a:rPr lang="en-US"/>
               <a:t>Click to edit Master title style</a:t>
             </a:r>
-            <a:endParaRPr lang="en-US"/>
           </a:p>
         </p:txBody>
       </p:sp>
@@ -2137,38 +2136,37 @@
           <a:p>
             <a:pPr lvl="0"/>
             <a:r>
-              <a:rPr lang="en-US" smtClean="0"/>
+              <a:rPr lang="en-US"/>
               <a:t>Click to edit Master text styles</a:t>
             </a:r>
           </a:p>
           <a:p>
             <a:pPr lvl="1"/>
             <a:r>
-              <a:rPr lang="en-US" smtClean="0"/>
+              <a:rPr lang="en-US"/>
               <a:t>Second level</a:t>
             </a:r>
           </a:p>
           <a:p>
             <a:pPr lvl="2"/>
             <a:r>
-              <a:rPr lang="en-US" smtClean="0"/>
+              <a:rPr lang="en-US"/>
               <a:t>Third level</a:t>
             </a:r>
           </a:p>
           <a:p>
             <a:pPr lvl="3"/>
             <a:r>
-              <a:rPr lang="en-US" smtClean="0"/>
+              <a:rPr lang="en-US"/>
               <a:t>Fourth level</a:t>
             </a:r>
           </a:p>
           <a:p>
             <a:pPr lvl="4"/>
             <a:r>
-              <a:rPr lang="en-US" smtClean="0"/>
+              <a:rPr lang="en-US"/>
               <a:t>Fifth level</a:t>
             </a:r>
-            <a:endParaRPr lang="en-US"/>
           </a:p>
         </p:txBody>
       </p:sp>
@@ -2231,7 +2229,7 @@
           <a:p>
             <a:pPr lvl="0"/>
             <a:r>
-              <a:rPr lang="en-US" smtClean="0"/>
+              <a:rPr lang="en-US"/>
               <a:t>Click to edit Master text styles</a:t>
             </a:r>
           </a:p>
@@ -2254,7 +2252,7 @@
           <a:p>
             <a:fld id="{5BCAD085-E8A6-8845-BD4E-CB4CCA059FC4}" type="datetimeFigureOut">
               <a:rPr lang="en-US" smtClean="0"/>
-              <a:t>1/27/13</a:t>
+              <a:t>10/16/2026</a:t>
             </a:fld>
             <a:endParaRPr lang="en-US"/>
           </a:p>
@@ -2357,10 +2355,9 @@
           </a:lstStyle>
           <a:p>
             <a:r>
-              <a:rPr lang="en-US" smtClean="0"/>
+              <a:rPr lang="en-US"/>
               <a:t>Click to edit Master title style</a:t>
             </a:r>
-            <a:endParaRPr lang="en-US"/>
           </a:p>
         </p:txBody>
       </p:sp>
@@ -2484,7 +2481,7 @@
           <a:p>
             <a:pPr lvl="0"/>
             <a:r>
-              <a:rPr lang="en-US" smtClean="0"/>
+              <a:rPr lang="en-US"/>
               <a:t>Click to edit Master text styles</a:t>
             </a:r>
           </a:p>
@@ -2507,7 +2504,7 @@
           <a:p>
             <a:fld id="{5BCAD085-E8A6-8845-BD4E-CB4CCA059FC4}" type="datetimeFigureOut">
               <a:rPr lang="en-US" smtClean="0"/>
-              <a:t>1/27/13</a:t>
+              <a:t>10/16/2026</a:t>
             </a:fld>
             <a:endParaRPr lang="en-US"/>
           </a:p>
@@ -2616,10 +2613,9 @@
           <a:lstStyle/>
           <a:p>
             <a:r>
-              <a:rPr lang="en-US" smtClean="0"/>
+              <a:rPr lang="en-US"/>
               <a:t>Click to edit Master title style</a:t>
             </a:r>
-            <a:endParaRPr lang="en-US"/>
           </a:p>
         </p:txBody>
       </p:sp>
@@ -2650,38 +2646,37 @@
           <a:p>
             <a:pPr lvl="0"/>
             <a:r>
-              <a:rPr lang="en-US" smtClean="0"/>
+              <a:rPr lang="en-US"/>
               <a:t>Click to edit Master text styles</a:t>
             </a:r>
           </a:p>
           <a:p>
             <a:pPr lvl="1"/>
             <a:r>
-              <a:rPr lang="en-US" smtClean="0"/>
+              <a:rPr lang="en-US"/>
               <a:t>Second level</a:t>
             </a:r>
           </a:p>
           <a:p>
             <a:pPr lvl="2"/>
             <a:r>
-              <a:rPr lang="en-US" smtClean="0"/>
+              <a:rPr lang="en-US"/>
               <a:t>Third level</a:t>
             </a:r>
           </a:p>
           <a:p>
             <a:pPr lvl="3"/>
             <a:r>
-              <a:rPr lang="en-US" smtClean="0"/>
+              <a:rPr lang="en-US"/>
               <a:t>Fourth level</a:t>
             </a:r>
           </a:p>
           <a:p>
             <a:pPr lvl="4"/>
             <a:r>
-              <a:rPr lang="en-US" smtClean="0"/>
+              <a:rPr lang="en-US"/>
               <a:t>Fifth level</a:t>
             </a:r>
-            <a:endParaRPr lang="en-US"/>
           </a:p>
         </p:txBody>
       </p:sp>
@@ -2720,7 +2715,7 @@
           <a:p>
             <a:fld id="{5BCAD085-E8A6-8845-BD4E-CB4CCA059FC4}" type="datetimeFigureOut">
               <a:rPr lang="en-US" smtClean="0"/>
-              <a:t>1/27/13</a:t>
+              <a:t>10/16/2026</a:t>
             </a:fld>
             <a:endParaRPr lang="en-US"/>
           </a:p>
@@ -3079,7 +3074,7 @@
 </file>
 
 <file path=ppt/slides/slide1.xml><?xml version="1.0" encoding="utf-8"?>
-<p:sld xmlns:a="http://schemas.openxmlformats.org/drawingml/2006/main" xmlns:p="http://schemas.openxmlformats.org/presentationml/2006/main" xmlns:r="http://schemas.openxmlformats.org/officeDocument/2006/relationships">
+<p:sld xmlns:a="http://schemas.openxmlformats.org/drawingml/2006/main" xmlns:r="http://schemas.openxmlformats.org/officeDocument/2006/relationships" xmlns:p="http://schemas.openxmlformats.org/presentationml/2006/main">
   <p:cSld>
     <p:spTree>
       <p:nvGrpSpPr>
@@ -3087,7 +3082,1012 @@
         <p:cNvGrpSpPr/>
         <p:nvPr/>
       </p:nvGrpSpPr>
-      <p:grpSpPr/>
+      <p:grpSpPr>
+        <a:xfrm>
+          <a:off x="0" y="0"/>
+          <a:ext cx="0" cy="0"/>
+          <a:chOff x="0" y="0"/>
+          <a:chExt cx="0" cy="0"/>
+        </a:xfrm>
+      </p:grpSpPr>
+      <p:sp>
+        <p:nvSpPr>
+          <p:cNvPr id="16" name="fig2_E">
+            <a:extLst>
+              <a:ext uri="{FF2B5EF4-FFF2-40B4-BE49-F238E27FC236}">
+                <a16:creationId xmlns:a16="http://schemas.microsoft.com/office/drawing/2014/main" id="{CA95EF0E-DF3A-1A8B-009B-6C4C8C120264}"/>
+              </a:ext>
+            </a:extLst>
+          </p:cNvPr>
+          <p:cNvSpPr/>
+          <p:nvPr/>
+        </p:nvSpPr>
+        <p:spPr>
+          <a:xfrm>
+            <a:off x="2970212" y="1408061"/>
+            <a:ext cx="1398181" cy="1398935"/>
+          </a:xfrm>
+          <a:prstGeom prst="rect">
+            <a:avLst/>
+          </a:prstGeom>
+          <a:solidFill>
+            <a:srgbClr val="F5E8D0"/>
+          </a:solidFill>
+          <a:ln w="6350">
+            <a:solidFill>
+              <a:srgbClr val="808080"/>
+            </a:solidFill>
+          </a:ln>
+        </p:spPr>
+        <p:style>
+          <a:lnRef idx="1">
+            <a:schemeClr val="accent1"/>
+          </a:lnRef>
+          <a:fillRef idx="3">
+            <a:schemeClr val="accent1"/>
+          </a:fillRef>
+          <a:effectRef idx="2">
+            <a:schemeClr val="accent1"/>
+          </a:effectRef>
+          <a:fontRef idx="minor">
+            <a:schemeClr val="lt1"/>
+          </a:fontRef>
+        </p:style>
+        <p:txBody>
+          <a:bodyPr wrap="none" rtlCol="0" anchor="ctr"/>
+          <a:lstStyle/>
+          <a:p>
+            <a:pPr algn="ctr"/>
+            <a:r>
+              <a:rPr lang="en-US" sz="1000" b="1" dirty="0">
+                <a:solidFill>
+                  <a:srgbClr val="333333"/>
+                </a:solidFill>
+              </a:rPr>
+              <a:t>E</a:t>
+            </a:r>
+            <a:r>
+              <a:rPr sz="1000" b="1" dirty="0">
+                <a:solidFill>
+                  <a:srgbClr val="333333"/>
+                </a:solidFill>
+              </a:rPr>
+              <a:t>
+51×52 mm</a:t>
+            </a:r>
+          </a:p>
+        </p:txBody>
+      </p:sp>
+      <p:sp>
+        <p:nvSpPr>
+          <p:cNvPr id="18" name="fig2_F">
+            <a:extLst>
+              <a:ext uri="{FF2B5EF4-FFF2-40B4-BE49-F238E27FC236}">
+                <a16:creationId xmlns:a16="http://schemas.microsoft.com/office/drawing/2014/main" id="{4A3AC555-CC08-7C9F-5508-2473A4703C7C}"/>
+              </a:ext>
+            </a:extLst>
+          </p:cNvPr>
+          <p:cNvSpPr/>
+          <p:nvPr/>
+        </p:nvSpPr>
+        <p:spPr>
+          <a:xfrm>
+            <a:off x="4455318" y="1408060"/>
+            <a:ext cx="1398181" cy="1398935"/>
+          </a:xfrm>
+          <a:prstGeom prst="rect">
+            <a:avLst/>
+          </a:prstGeom>
+          <a:solidFill>
+            <a:srgbClr val="F5E8D0"/>
+          </a:solidFill>
+          <a:ln w="6350">
+            <a:solidFill>
+              <a:srgbClr val="808080"/>
+            </a:solidFill>
+          </a:ln>
+        </p:spPr>
+        <p:style>
+          <a:lnRef idx="1">
+            <a:schemeClr val="accent1"/>
+          </a:lnRef>
+          <a:fillRef idx="3">
+            <a:schemeClr val="accent1"/>
+          </a:fillRef>
+          <a:effectRef idx="2">
+            <a:schemeClr val="accent1"/>
+          </a:effectRef>
+          <a:fontRef idx="minor">
+            <a:schemeClr val="lt1"/>
+          </a:fontRef>
+        </p:style>
+        <p:txBody>
+          <a:bodyPr wrap="none" rtlCol="0" anchor="ctr"/>
+          <a:lstStyle/>
+          <a:p>
+            <a:pPr algn="ctr"/>
+            <a:r>
+              <a:rPr lang="en-US" sz="1000" b="1" dirty="0">
+                <a:solidFill>
+                  <a:srgbClr val="333333"/>
+                </a:solidFill>
+              </a:rPr>
+              <a:t>F</a:t>
+            </a:r>
+            <a:r>
+              <a:rPr sz="1000" b="1" dirty="0">
+                <a:solidFill>
+                  <a:srgbClr val="333333"/>
+                </a:solidFill>
+              </a:rPr>
+              <a:t>
+51×52 mm</a:t>
+            </a:r>
+          </a:p>
+        </p:txBody>
+      </p:sp>
+      <p:sp>
+        <p:nvSpPr>
+          <p:cNvPr id="20" name="fig2_G">
+            <a:extLst>
+              <a:ext uri="{FF2B5EF4-FFF2-40B4-BE49-F238E27FC236}">
+                <a16:creationId xmlns:a16="http://schemas.microsoft.com/office/drawing/2014/main" id="{0CA36138-F1FC-0BC1-8EEB-DBBEE0088383}"/>
+              </a:ext>
+            </a:extLst>
+          </p:cNvPr>
+          <p:cNvSpPr/>
+          <p:nvPr/>
+        </p:nvSpPr>
+        <p:spPr>
+          <a:xfrm>
+            <a:off x="-1" y="2894846"/>
+            <a:ext cx="1398181" cy="1398935"/>
+          </a:xfrm>
+          <a:prstGeom prst="rect">
+            <a:avLst/>
+          </a:prstGeom>
+          <a:solidFill>
+            <a:srgbClr val="F5E8D0"/>
+          </a:solidFill>
+          <a:ln w="6350">
+            <a:solidFill>
+              <a:srgbClr val="808080"/>
+            </a:solidFill>
+          </a:ln>
+        </p:spPr>
+        <p:style>
+          <a:lnRef idx="1">
+            <a:schemeClr val="accent1"/>
+          </a:lnRef>
+          <a:fillRef idx="3">
+            <a:schemeClr val="accent1"/>
+          </a:fillRef>
+          <a:effectRef idx="2">
+            <a:schemeClr val="accent1"/>
+          </a:effectRef>
+          <a:fontRef idx="minor">
+            <a:schemeClr val="lt1"/>
+          </a:fontRef>
+        </p:style>
+        <p:txBody>
+          <a:bodyPr wrap="none" rtlCol="0" anchor="ctr"/>
+          <a:lstStyle/>
+          <a:p>
+            <a:pPr algn="ctr"/>
+            <a:r>
+              <a:rPr lang="en-US" sz="1000" b="1" dirty="0">
+                <a:solidFill>
+                  <a:srgbClr val="333333"/>
+                </a:solidFill>
+              </a:rPr>
+              <a:t>G</a:t>
+            </a:r>
+            <a:r>
+              <a:rPr sz="1000" b="1" dirty="0">
+                <a:solidFill>
+                  <a:srgbClr val="333333"/>
+                </a:solidFill>
+              </a:rPr>
+              <a:t>
+51×52 mm</a:t>
+            </a:r>
+          </a:p>
+        </p:txBody>
+      </p:sp>
+      <p:sp>
+        <p:nvSpPr>
+          <p:cNvPr id="22" name="fig2_H">
+            <a:extLst>
+              <a:ext uri="{FF2B5EF4-FFF2-40B4-BE49-F238E27FC236}">
+                <a16:creationId xmlns:a16="http://schemas.microsoft.com/office/drawing/2014/main" id="{112CC553-7965-2DB1-9C5A-02B00F3F9A86}"/>
+              </a:ext>
+            </a:extLst>
+          </p:cNvPr>
+          <p:cNvSpPr/>
+          <p:nvPr/>
+        </p:nvSpPr>
+        <p:spPr>
+          <a:xfrm>
+            <a:off x="1485105" y="2898388"/>
+            <a:ext cx="1398181" cy="1398935"/>
+          </a:xfrm>
+          <a:prstGeom prst="rect">
+            <a:avLst/>
+          </a:prstGeom>
+          <a:solidFill>
+            <a:srgbClr val="F5E8D0"/>
+          </a:solidFill>
+          <a:ln w="6350">
+            <a:solidFill>
+              <a:srgbClr val="808080"/>
+            </a:solidFill>
+          </a:ln>
+        </p:spPr>
+        <p:style>
+          <a:lnRef idx="1">
+            <a:schemeClr val="accent1"/>
+          </a:lnRef>
+          <a:fillRef idx="3">
+            <a:schemeClr val="accent1"/>
+          </a:fillRef>
+          <a:effectRef idx="2">
+            <a:schemeClr val="accent1"/>
+          </a:effectRef>
+          <a:fontRef idx="minor">
+            <a:schemeClr val="lt1"/>
+          </a:fontRef>
+        </p:style>
+        <p:txBody>
+          <a:bodyPr wrap="none" rtlCol="0" anchor="ctr"/>
+          <a:lstStyle/>
+          <a:p>
+            <a:pPr algn="ctr"/>
+            <a:r>
+              <a:rPr lang="en-US" sz="1000" b="1" dirty="0">
+                <a:solidFill>
+                  <a:srgbClr val="333333"/>
+                </a:solidFill>
+              </a:rPr>
+              <a:t>H</a:t>
+            </a:r>
+            <a:r>
+              <a:rPr sz="1000" b="1" dirty="0">
+                <a:solidFill>
+                  <a:srgbClr val="333333"/>
+                </a:solidFill>
+              </a:rPr>
+              <a:t>
+51×52 mm</a:t>
+            </a:r>
+          </a:p>
+        </p:txBody>
+      </p:sp>
+      <p:sp>
+        <p:nvSpPr>
+          <p:cNvPr id="24" name="fig2_I">
+            <a:extLst>
+              <a:ext uri="{FF2B5EF4-FFF2-40B4-BE49-F238E27FC236}">
+                <a16:creationId xmlns:a16="http://schemas.microsoft.com/office/drawing/2014/main" id="{33FA2E5E-893D-E5AB-7CD8-9A095BA4F5B9}"/>
+              </a:ext>
+            </a:extLst>
+          </p:cNvPr>
+          <p:cNvSpPr/>
+          <p:nvPr/>
+        </p:nvSpPr>
+        <p:spPr>
+          <a:xfrm>
+            <a:off x="2970212" y="2898388"/>
+            <a:ext cx="1398181" cy="1398935"/>
+          </a:xfrm>
+          <a:prstGeom prst="rect">
+            <a:avLst/>
+          </a:prstGeom>
+          <a:solidFill>
+            <a:srgbClr val="F5E8D0"/>
+          </a:solidFill>
+          <a:ln w="6350">
+            <a:solidFill>
+              <a:srgbClr val="808080"/>
+            </a:solidFill>
+          </a:ln>
+        </p:spPr>
+        <p:style>
+          <a:lnRef idx="1">
+            <a:schemeClr val="accent1"/>
+          </a:lnRef>
+          <a:fillRef idx="3">
+            <a:schemeClr val="accent1"/>
+          </a:fillRef>
+          <a:effectRef idx="2">
+            <a:schemeClr val="accent1"/>
+          </a:effectRef>
+          <a:fontRef idx="minor">
+            <a:schemeClr val="lt1"/>
+          </a:fontRef>
+        </p:style>
+        <p:txBody>
+          <a:bodyPr wrap="none" rtlCol="0" anchor="ctr"/>
+          <a:lstStyle/>
+          <a:p>
+            <a:pPr algn="ctr"/>
+            <a:r>
+              <a:rPr lang="en-US" sz="1000" b="1" dirty="0">
+                <a:solidFill>
+                  <a:srgbClr val="333333"/>
+                </a:solidFill>
+              </a:rPr>
+              <a:t>I</a:t>
+            </a:r>
+            <a:r>
+              <a:rPr sz="1000" b="1" dirty="0">
+                <a:solidFill>
+                  <a:srgbClr val="333333"/>
+                </a:solidFill>
+              </a:rPr>
+              <a:t>
+51×52 mm</a:t>
+            </a:r>
+          </a:p>
+        </p:txBody>
+      </p:sp>
+      <p:sp>
+        <p:nvSpPr>
+          <p:cNvPr id="26" name="fig2_J">
+            <a:extLst>
+              <a:ext uri="{FF2B5EF4-FFF2-40B4-BE49-F238E27FC236}">
+                <a16:creationId xmlns:a16="http://schemas.microsoft.com/office/drawing/2014/main" id="{91F3CB8E-0647-5B0A-623B-BAA61F0E536E}"/>
+              </a:ext>
+            </a:extLst>
+          </p:cNvPr>
+          <p:cNvSpPr/>
+          <p:nvPr/>
+        </p:nvSpPr>
+        <p:spPr>
+          <a:xfrm>
+            <a:off x="4455317" y="2896616"/>
+            <a:ext cx="1398181" cy="1398935"/>
+          </a:xfrm>
+          <a:prstGeom prst="rect">
+            <a:avLst/>
+          </a:prstGeom>
+          <a:solidFill>
+            <a:srgbClr val="F5E8D0"/>
+          </a:solidFill>
+          <a:ln w="6350">
+            <a:solidFill>
+              <a:srgbClr val="808080"/>
+            </a:solidFill>
+          </a:ln>
+        </p:spPr>
+        <p:style>
+          <a:lnRef idx="1">
+            <a:schemeClr val="accent1"/>
+          </a:lnRef>
+          <a:fillRef idx="3">
+            <a:schemeClr val="accent1"/>
+          </a:fillRef>
+          <a:effectRef idx="2">
+            <a:schemeClr val="accent1"/>
+          </a:effectRef>
+          <a:fontRef idx="minor">
+            <a:schemeClr val="lt1"/>
+          </a:fontRef>
+        </p:style>
+        <p:txBody>
+          <a:bodyPr wrap="none" rtlCol="0" anchor="ctr"/>
+          <a:lstStyle/>
+          <a:p>
+            <a:pPr algn="ctr"/>
+            <a:r>
+              <a:rPr lang="en-US" sz="1000" b="1" dirty="0">
+                <a:solidFill>
+                  <a:srgbClr val="333333"/>
+                </a:solidFill>
+              </a:rPr>
+              <a:t>J</a:t>
+            </a:r>
+            <a:r>
+              <a:rPr sz="1000" b="1" dirty="0">
+                <a:solidFill>
+                  <a:srgbClr val="333333"/>
+                </a:solidFill>
+              </a:rPr>
+              <a:t>
+51×52 mm</a:t>
+            </a:r>
+          </a:p>
+        </p:txBody>
+      </p:sp>
+      <p:sp>
+        <p:nvSpPr>
+          <p:cNvPr id="28" name="fig2_K">
+            <a:extLst>
+              <a:ext uri="{FF2B5EF4-FFF2-40B4-BE49-F238E27FC236}">
+                <a16:creationId xmlns:a16="http://schemas.microsoft.com/office/drawing/2014/main" id="{D7826737-5DF9-A565-B6D9-D613D4EDECCE}"/>
+              </a:ext>
+            </a:extLst>
+          </p:cNvPr>
+          <p:cNvSpPr/>
+          <p:nvPr/>
+        </p:nvSpPr>
+        <p:spPr>
+          <a:xfrm>
+            <a:off x="-2" y="4378088"/>
+            <a:ext cx="1398181" cy="1398935"/>
+          </a:xfrm>
+          <a:prstGeom prst="rect">
+            <a:avLst/>
+          </a:prstGeom>
+          <a:solidFill>
+            <a:srgbClr val="F5E8D0"/>
+          </a:solidFill>
+          <a:ln w="6350">
+            <a:solidFill>
+              <a:srgbClr val="808080"/>
+            </a:solidFill>
+          </a:ln>
+        </p:spPr>
+        <p:style>
+          <a:lnRef idx="1">
+            <a:schemeClr val="accent1"/>
+          </a:lnRef>
+          <a:fillRef idx="3">
+            <a:schemeClr val="accent1"/>
+          </a:fillRef>
+          <a:effectRef idx="2">
+            <a:schemeClr val="accent1"/>
+          </a:effectRef>
+          <a:fontRef idx="minor">
+            <a:schemeClr val="lt1"/>
+          </a:fontRef>
+        </p:style>
+        <p:txBody>
+          <a:bodyPr wrap="none" rtlCol="0" anchor="ctr"/>
+          <a:lstStyle/>
+          <a:p>
+            <a:pPr algn="ctr"/>
+            <a:r>
+              <a:rPr lang="en-US" sz="1000" b="1" dirty="0">
+                <a:solidFill>
+                  <a:srgbClr val="333333"/>
+                </a:solidFill>
+              </a:rPr>
+              <a:t>K</a:t>
+            </a:r>
+            <a:r>
+              <a:rPr sz="1000" b="1" dirty="0">
+                <a:solidFill>
+                  <a:srgbClr val="333333"/>
+                </a:solidFill>
+              </a:rPr>
+              <a:t>
+51×52 mm</a:t>
+            </a:r>
+          </a:p>
+        </p:txBody>
+      </p:sp>
+      <p:sp>
+        <p:nvSpPr>
+          <p:cNvPr id="30" name="fig2_N">
+            <a:extLst>
+              <a:ext uri="{FF2B5EF4-FFF2-40B4-BE49-F238E27FC236}">
+                <a16:creationId xmlns:a16="http://schemas.microsoft.com/office/drawing/2014/main" id="{4B9BEAF1-E32B-18AC-71C5-7973920C7D76}"/>
+              </a:ext>
+            </a:extLst>
+          </p:cNvPr>
+          <p:cNvSpPr/>
+          <p:nvPr/>
+        </p:nvSpPr>
+        <p:spPr>
+          <a:xfrm>
+            <a:off x="-15951" y="5893981"/>
+            <a:ext cx="1398181" cy="1398935"/>
+          </a:xfrm>
+          <a:prstGeom prst="rect">
+            <a:avLst/>
+          </a:prstGeom>
+          <a:solidFill>
+            <a:srgbClr val="F5E8D0"/>
+          </a:solidFill>
+          <a:ln w="6350">
+            <a:solidFill>
+              <a:srgbClr val="808080"/>
+            </a:solidFill>
+          </a:ln>
+        </p:spPr>
+        <p:style>
+          <a:lnRef idx="1">
+            <a:schemeClr val="accent1"/>
+          </a:lnRef>
+          <a:fillRef idx="3">
+            <a:schemeClr val="accent1"/>
+          </a:fillRef>
+          <a:effectRef idx="2">
+            <a:schemeClr val="accent1"/>
+          </a:effectRef>
+          <a:fontRef idx="minor">
+            <a:schemeClr val="lt1"/>
+          </a:fontRef>
+        </p:style>
+        <p:txBody>
+          <a:bodyPr wrap="none" rtlCol="0" anchor="ctr"/>
+          <a:lstStyle/>
+          <a:p>
+            <a:pPr algn="ctr"/>
+            <a:r>
+              <a:rPr lang="en-US" sz="1000" b="1" dirty="0">
+                <a:solidFill>
+                  <a:srgbClr val="333333"/>
+                </a:solidFill>
+              </a:rPr>
+              <a:t>N</a:t>
+            </a:r>
+            <a:r>
+              <a:rPr sz="1000" b="1" dirty="0">
+                <a:solidFill>
+                  <a:srgbClr val="333333"/>
+                </a:solidFill>
+              </a:rPr>
+              <a:t>
+51×52 mm</a:t>
+            </a:r>
+          </a:p>
+        </p:txBody>
+      </p:sp>
+      <p:sp>
+        <p:nvSpPr>
+          <p:cNvPr id="32" name="fig2_L">
+            <a:extLst>
+              <a:ext uri="{FF2B5EF4-FFF2-40B4-BE49-F238E27FC236}">
+                <a16:creationId xmlns:a16="http://schemas.microsoft.com/office/drawing/2014/main" id="{4697FDE0-95F9-683B-0261-CD3656EB6C5F}"/>
+              </a:ext>
+            </a:extLst>
+          </p:cNvPr>
+          <p:cNvSpPr/>
+          <p:nvPr/>
+        </p:nvSpPr>
+        <p:spPr>
+          <a:xfrm>
+            <a:off x="1468222" y="4388717"/>
+            <a:ext cx="1398181" cy="1398935"/>
+          </a:xfrm>
+          <a:prstGeom prst="rect">
+            <a:avLst/>
+          </a:prstGeom>
+          <a:solidFill>
+            <a:srgbClr val="F5E8D0"/>
+          </a:solidFill>
+          <a:ln w="6350">
+            <a:solidFill>
+              <a:srgbClr val="808080"/>
+            </a:solidFill>
+          </a:ln>
+        </p:spPr>
+        <p:style>
+          <a:lnRef idx="1">
+            <a:schemeClr val="accent1"/>
+          </a:lnRef>
+          <a:fillRef idx="3">
+            <a:schemeClr val="accent1"/>
+          </a:fillRef>
+          <a:effectRef idx="2">
+            <a:schemeClr val="accent1"/>
+          </a:effectRef>
+          <a:fontRef idx="minor">
+            <a:schemeClr val="lt1"/>
+          </a:fontRef>
+        </p:style>
+        <p:txBody>
+          <a:bodyPr wrap="none" rtlCol="0" anchor="ctr"/>
+          <a:lstStyle/>
+          <a:p>
+            <a:pPr algn="ctr"/>
+            <a:r>
+              <a:rPr lang="en-US" sz="1000" b="1" dirty="0">
+                <a:solidFill>
+                  <a:srgbClr val="333333"/>
+                </a:solidFill>
+              </a:rPr>
+              <a:t>L</a:t>
+            </a:r>
+            <a:r>
+              <a:rPr sz="1000" b="1" dirty="0">
+                <a:solidFill>
+                  <a:srgbClr val="333333"/>
+                </a:solidFill>
+              </a:rPr>
+              <a:t>
+51×52 mm</a:t>
+            </a:r>
+          </a:p>
+        </p:txBody>
+      </p:sp>
+      <p:sp>
+        <p:nvSpPr>
+          <p:cNvPr id="34" name="fig2_M">
+            <a:extLst>
+              <a:ext uri="{FF2B5EF4-FFF2-40B4-BE49-F238E27FC236}">
+                <a16:creationId xmlns:a16="http://schemas.microsoft.com/office/drawing/2014/main" id="{2DC4DE53-0BDF-CD07-C7F9-5FA97F0CDF3D}"/>
+              </a:ext>
+            </a:extLst>
+          </p:cNvPr>
+          <p:cNvSpPr/>
+          <p:nvPr/>
+        </p:nvSpPr>
+        <p:spPr>
+          <a:xfrm>
+            <a:off x="2970212" y="4401121"/>
+            <a:ext cx="1398181" cy="1398935"/>
+          </a:xfrm>
+          <a:prstGeom prst="rect">
+            <a:avLst/>
+          </a:prstGeom>
+          <a:solidFill>
+            <a:srgbClr val="F5E8D0"/>
+          </a:solidFill>
+          <a:ln w="6350">
+            <a:solidFill>
+              <a:srgbClr val="808080"/>
+            </a:solidFill>
+          </a:ln>
+        </p:spPr>
+        <p:style>
+          <a:lnRef idx="1">
+            <a:schemeClr val="accent1"/>
+          </a:lnRef>
+          <a:fillRef idx="3">
+            <a:schemeClr val="accent1"/>
+          </a:fillRef>
+          <a:effectRef idx="2">
+            <a:schemeClr val="accent1"/>
+          </a:effectRef>
+          <a:fontRef idx="minor">
+            <a:schemeClr val="lt1"/>
+          </a:fontRef>
+        </p:style>
+        <p:txBody>
+          <a:bodyPr wrap="none" rtlCol="0" anchor="ctr"/>
+          <a:lstStyle/>
+          <a:p>
+            <a:pPr algn="ctr"/>
+            <a:r>
+              <a:rPr lang="en-US" sz="1000" b="1" dirty="0">
+                <a:solidFill>
+                  <a:srgbClr val="333333"/>
+                </a:solidFill>
+              </a:rPr>
+              <a:t>M</a:t>
+            </a:r>
+            <a:r>
+              <a:rPr sz="1000" b="1" dirty="0">
+                <a:solidFill>
+                  <a:srgbClr val="333333"/>
+                </a:solidFill>
+              </a:rPr>
+              <a:t>
+51×52 mm</a:t>
+            </a:r>
+          </a:p>
+        </p:txBody>
+      </p:sp>
+      <p:sp>
+        <p:nvSpPr>
+          <p:cNvPr id="36" name="fig2_O">
+            <a:extLst>
+              <a:ext uri="{FF2B5EF4-FFF2-40B4-BE49-F238E27FC236}">
+                <a16:creationId xmlns:a16="http://schemas.microsoft.com/office/drawing/2014/main" id="{0F09EC13-CEF1-2761-6318-FDF663E79161}"/>
+              </a:ext>
+            </a:extLst>
+          </p:cNvPr>
+          <p:cNvSpPr/>
+          <p:nvPr/>
+        </p:nvSpPr>
+        <p:spPr>
+          <a:xfrm>
+            <a:off x="1468222" y="5893980"/>
+            <a:ext cx="1398181" cy="1398935"/>
+          </a:xfrm>
+          <a:prstGeom prst="rect">
+            <a:avLst/>
+          </a:prstGeom>
+          <a:solidFill>
+            <a:srgbClr val="F5E8D0"/>
+          </a:solidFill>
+          <a:ln w="6350">
+            <a:solidFill>
+              <a:srgbClr val="808080"/>
+            </a:solidFill>
+          </a:ln>
+        </p:spPr>
+        <p:style>
+          <a:lnRef idx="1">
+            <a:schemeClr val="accent1"/>
+          </a:lnRef>
+          <a:fillRef idx="3">
+            <a:schemeClr val="accent1"/>
+          </a:fillRef>
+          <a:effectRef idx="2">
+            <a:schemeClr val="accent1"/>
+          </a:effectRef>
+          <a:fontRef idx="minor">
+            <a:schemeClr val="lt1"/>
+          </a:fontRef>
+        </p:style>
+        <p:txBody>
+          <a:bodyPr wrap="none" rtlCol="0" anchor="ctr"/>
+          <a:lstStyle/>
+          <a:p>
+            <a:pPr algn="ctr"/>
+            <a:r>
+              <a:rPr lang="en-US" sz="1000" b="1" dirty="0">
+                <a:solidFill>
+                  <a:srgbClr val="333333"/>
+                </a:solidFill>
+              </a:rPr>
+              <a:t>O</a:t>
+            </a:r>
+            <a:r>
+              <a:rPr sz="1000" b="1" dirty="0">
+                <a:solidFill>
+                  <a:srgbClr val="333333"/>
+                </a:solidFill>
+              </a:rPr>
+              <a:t>
+51×52 mm</a:t>
+            </a:r>
+          </a:p>
+        </p:txBody>
+      </p:sp>
+      <p:sp>
+        <p:nvSpPr>
+          <p:cNvPr id="38" name="fig2_P">
+            <a:extLst>
+              <a:ext uri="{FF2B5EF4-FFF2-40B4-BE49-F238E27FC236}">
+                <a16:creationId xmlns:a16="http://schemas.microsoft.com/office/drawing/2014/main" id="{E73FA2B4-191E-3521-7B6F-6569D721D403}"/>
+              </a:ext>
+            </a:extLst>
+          </p:cNvPr>
+          <p:cNvSpPr/>
+          <p:nvPr/>
+        </p:nvSpPr>
+        <p:spPr>
+          <a:xfrm>
+            <a:off x="2970212" y="5903854"/>
+            <a:ext cx="1398181" cy="1398935"/>
+          </a:xfrm>
+          <a:prstGeom prst="rect">
+            <a:avLst/>
+          </a:prstGeom>
+          <a:solidFill>
+            <a:srgbClr val="F5E8D0"/>
+          </a:solidFill>
+          <a:ln w="6350">
+            <a:solidFill>
+              <a:srgbClr val="808080"/>
+            </a:solidFill>
+          </a:ln>
+        </p:spPr>
+        <p:style>
+          <a:lnRef idx="1">
+            <a:schemeClr val="accent1"/>
+          </a:lnRef>
+          <a:fillRef idx="3">
+            <a:schemeClr val="accent1"/>
+          </a:fillRef>
+          <a:effectRef idx="2">
+            <a:schemeClr val="accent1"/>
+          </a:effectRef>
+          <a:fontRef idx="minor">
+            <a:schemeClr val="lt1"/>
+          </a:fontRef>
+        </p:style>
+        <p:txBody>
+          <a:bodyPr wrap="none" rtlCol="0" anchor="ctr"/>
+          <a:lstStyle/>
+          <a:p>
+            <a:pPr algn="ctr"/>
+            <a:r>
+              <a:rPr lang="en-US" sz="1000" b="1" dirty="0">
+                <a:solidFill>
+                  <a:srgbClr val="333333"/>
+                </a:solidFill>
+              </a:rPr>
+              <a:t>P</a:t>
+            </a:r>
+            <a:r>
+              <a:rPr sz="1000" b="1" dirty="0">
+                <a:solidFill>
+                  <a:srgbClr val="333333"/>
+                </a:solidFill>
+              </a:rPr>
+              <a:t>
+51×52 mm</a:t>
+            </a:r>
+          </a:p>
+        </p:txBody>
+      </p:sp>
+      <p:sp>
+        <p:nvSpPr>
+          <p:cNvPr id="14" name="fig2_D">
+            <a:extLst>
+              <a:ext uri="{FF2B5EF4-FFF2-40B4-BE49-F238E27FC236}">
+                <a16:creationId xmlns:a16="http://schemas.microsoft.com/office/drawing/2014/main" id="{79992732-9DF7-35AE-2F1C-B7DDCF062859}"/>
+              </a:ext>
+            </a:extLst>
+          </p:cNvPr>
+          <p:cNvSpPr/>
+          <p:nvPr/>
+        </p:nvSpPr>
+        <p:spPr>
+          <a:xfrm>
+            <a:off x="1485106" y="1408059"/>
+            <a:ext cx="1398181" cy="1398935"/>
+          </a:xfrm>
+          <a:prstGeom prst="rect">
+            <a:avLst/>
+          </a:prstGeom>
+          <a:solidFill>
+            <a:srgbClr val="F5E8D0"/>
+          </a:solidFill>
+          <a:ln w="6350">
+            <a:solidFill>
+              <a:srgbClr val="808080"/>
+            </a:solidFill>
+          </a:ln>
+        </p:spPr>
+        <p:style>
+          <a:lnRef idx="1">
+            <a:schemeClr val="accent1"/>
+          </a:lnRef>
+          <a:fillRef idx="3">
+            <a:schemeClr val="accent1"/>
+          </a:fillRef>
+          <a:effectRef idx="2">
+            <a:schemeClr val="accent1"/>
+          </a:effectRef>
+          <a:fontRef idx="minor">
+            <a:schemeClr val="lt1"/>
+          </a:fontRef>
+        </p:style>
+        <p:txBody>
+          <a:bodyPr wrap="none" rtlCol="0" anchor="ctr"/>
+          <a:lstStyle/>
+          <a:p>
+            <a:pPr algn="ctr"/>
+            <a:r>
+              <a:rPr lang="en-US" sz="1000" b="1" dirty="0">
+                <a:solidFill>
+                  <a:srgbClr val="333333"/>
+                </a:solidFill>
+              </a:rPr>
+              <a:t>D</a:t>
+            </a:r>
+            <a:r>
+              <a:rPr sz="1000" b="1" dirty="0">
+                <a:solidFill>
+                  <a:srgbClr val="333333"/>
+                </a:solidFill>
+              </a:rPr>
+              <a:t>
+51×52 mm</a:t>
+            </a:r>
+          </a:p>
+        </p:txBody>
+      </p:sp>
+      <p:sp>
+        <p:nvSpPr>
+          <p:cNvPr id="12" name="fig2_C">
+            <a:extLst>
+              <a:ext uri="{FF2B5EF4-FFF2-40B4-BE49-F238E27FC236}">
+                <a16:creationId xmlns:a16="http://schemas.microsoft.com/office/drawing/2014/main" id="{CAA566B7-B833-6B71-2A3B-8EA11E44DBF6}"/>
+              </a:ext>
+            </a:extLst>
+          </p:cNvPr>
+          <p:cNvSpPr/>
+          <p:nvPr/>
+        </p:nvSpPr>
+        <p:spPr>
+          <a:xfrm>
+            <a:off x="0" y="1408060"/>
+            <a:ext cx="1398181" cy="1398935"/>
+          </a:xfrm>
+          <a:prstGeom prst="rect">
+            <a:avLst/>
+          </a:prstGeom>
+          <a:solidFill>
+            <a:srgbClr val="F5E8D0"/>
+          </a:solidFill>
+          <a:ln w="6350">
+            <a:solidFill>
+              <a:srgbClr val="808080"/>
+            </a:solidFill>
+          </a:ln>
+        </p:spPr>
+        <p:style>
+          <a:lnRef idx="1">
+            <a:schemeClr val="accent1"/>
+          </a:lnRef>
+          <a:fillRef idx="3">
+            <a:schemeClr val="accent1"/>
+          </a:fillRef>
+          <a:effectRef idx="2">
+            <a:schemeClr val="accent1"/>
+          </a:effectRef>
+          <a:fontRef idx="minor">
+            <a:schemeClr val="lt1"/>
+          </a:fontRef>
+        </p:style>
+        <p:txBody>
+          <a:bodyPr wrap="none" rtlCol="0" anchor="ctr"/>
+          <a:lstStyle/>
+          <a:p>
+            <a:pPr algn="ctr"/>
+            <a:r>
+              <a:rPr sz="1000" b="1" dirty="0">
+                <a:solidFill>
+                  <a:srgbClr val="333333"/>
+                </a:solidFill>
+              </a:rPr>
+              <a:t>C
+51×52 mm</a:t>
+            </a:r>
+          </a:p>
+        </p:txBody>
+      </p:sp>
+      <p:sp>
+        <p:nvSpPr>
+          <p:cNvPr id="3" name="fig2_B"/>
+          <p:cNvSpPr/>
+          <p:nvPr/>
+        </p:nvSpPr>
+        <p:spPr>
+          <a:xfrm>
+            <a:off x="2970212" y="0"/>
+            <a:ext cx="2856430" cy="1323753"/>
+          </a:xfrm>
+          <a:prstGeom prst="rect">
+            <a:avLst/>
+          </a:prstGeom>
+          <a:solidFill>
+            <a:srgbClr val="D0F0E0"/>
+          </a:solidFill>
+          <a:ln w="6350">
+            <a:solidFill>
+              <a:srgbClr val="808080"/>
+            </a:solidFill>
+          </a:ln>
+        </p:spPr>
+        <p:style>
+          <a:lnRef idx="1">
+            <a:schemeClr val="accent1"/>
+          </a:lnRef>
+          <a:fillRef idx="3">
+            <a:schemeClr val="accent1"/>
+          </a:fillRef>
+          <a:effectRef idx="2">
+            <a:schemeClr val="accent1"/>
+          </a:effectRef>
+          <a:fontRef idx="minor">
+            <a:schemeClr val="lt1"/>
+          </a:fontRef>
+        </p:style>
+        <p:txBody>
+          <a:bodyPr wrap="none" rtlCol="0" anchor="ctr"/>
+          <a:lstStyle/>
+          <a:p>
+            <a:pPr algn="ctr"/>
+            <a:r>
+              <a:rPr sz="1000" b="1" dirty="0">
+                <a:solidFill>
+                  <a:srgbClr val="333333"/>
+                </a:solidFill>
+              </a:rPr>
+              <a:t>B
+52×52 mm</a:t>
+            </a:r>
+          </a:p>
+        </p:txBody>
+      </p:sp>
       <p:sp>
         <p:nvSpPr>
           <p:cNvPr id="2" name="fig2_A"/>
@@ -3097,7 +4097,7 @@
         <p:spPr>
           <a:xfrm>
             <a:off x="0" y="0"/>
-            <a:ext cx="1872000" cy="1872000"/>
+            <a:ext cx="2883287" cy="1323753"/>
           </a:xfrm>
           <a:prstGeom prst="rect">
             <a:avLst/>
@@ -3126,7 +4126,7 @@
           </a:fontRef>
         </p:style>
         <p:txBody>
-          <a:bodyPr rtlCol="0" anchor="ctr" wrap="none"/>
+          <a:bodyPr wrap="none" rtlCol="0" anchor="ctr"/>
           <a:lstStyle/>
           <a:p>
             <a:pPr algn="ctr"/>
@@ -3138,438 +4138,6 @@
               </a:rPr>
               <a:t>A
 52×52 mm</a:t>
-            </a:r>
-          </a:p>
-        </p:txBody>
-      </p:sp>
-      <p:sp>
-        <p:nvSpPr>
-          <p:cNvPr id="3" name="fig2_B"/>
-          <p:cNvSpPr/>
-          <p:nvPr/>
-        </p:nvSpPr>
-        <p:spPr>
-          <a:xfrm>
-            <a:off x="2052000" y="0"/>
-            <a:ext cx="1872000" cy="1872000"/>
-          </a:xfrm>
-          <a:prstGeom prst="rect">
-            <a:avLst/>
-          </a:prstGeom>
-          <a:solidFill>
-            <a:srgbClr val="D0F0E0"/>
-          </a:solidFill>
-          <a:ln w="6350">
-            <a:solidFill>
-              <a:srgbClr val="808080"/>
-            </a:solidFill>
-          </a:ln>
-        </p:spPr>
-        <p:style>
-          <a:lnRef idx="1">
-            <a:schemeClr val="accent1"/>
-          </a:lnRef>
-          <a:fillRef idx="3">
-            <a:schemeClr val="accent1"/>
-          </a:fillRef>
-          <a:effectRef idx="2">
-            <a:schemeClr val="accent1"/>
-          </a:effectRef>
-          <a:fontRef idx="minor">
-            <a:schemeClr val="lt1"/>
-          </a:fontRef>
-        </p:style>
-        <p:txBody>
-          <a:bodyPr rtlCol="0" anchor="ctr" wrap="none"/>
-          <a:lstStyle/>
-          <a:p>
-            <a:pPr algn="ctr"/>
-            <a:r>
-              <a:rPr sz="1000" b="1">
-                <a:solidFill>
-                  <a:srgbClr val="333333"/>
-                </a:solidFill>
-              </a:rPr>
-              <a:t>B
-52×52 mm</a:t>
-            </a:r>
-          </a:p>
-        </p:txBody>
-      </p:sp>
-      <p:sp>
-        <p:nvSpPr>
-          <p:cNvPr id="4" name="fig2_C"/>
-          <p:cNvSpPr/>
-          <p:nvPr/>
-        </p:nvSpPr>
-        <p:spPr>
-          <a:xfrm>
-            <a:off x="4104000" y="0"/>
-            <a:ext cx="1836000" cy="1872000"/>
-          </a:xfrm>
-          <a:prstGeom prst="rect">
-            <a:avLst/>
-          </a:prstGeom>
-          <a:solidFill>
-            <a:srgbClr val="F5E8D0"/>
-          </a:solidFill>
-          <a:ln w="6350">
-            <a:solidFill>
-              <a:srgbClr val="808080"/>
-            </a:solidFill>
-          </a:ln>
-        </p:spPr>
-        <p:style>
-          <a:lnRef idx="1">
-            <a:schemeClr val="accent1"/>
-          </a:lnRef>
-          <a:fillRef idx="3">
-            <a:schemeClr val="accent1"/>
-          </a:fillRef>
-          <a:effectRef idx="2">
-            <a:schemeClr val="accent1"/>
-          </a:effectRef>
-          <a:fontRef idx="minor">
-            <a:schemeClr val="lt1"/>
-          </a:fontRef>
-        </p:style>
-        <p:txBody>
-          <a:bodyPr rtlCol="0" anchor="ctr" wrap="none"/>
-          <a:lstStyle/>
-          <a:p>
-            <a:pPr algn="ctr"/>
-            <a:r>
-              <a:rPr sz="1000" b="1">
-                <a:solidFill>
-                  <a:srgbClr val="333333"/>
-                </a:solidFill>
-              </a:rPr>
-              <a:t>C
-51×52 mm</a:t>
-            </a:r>
-          </a:p>
-        </p:txBody>
-      </p:sp>
-      <p:sp>
-        <p:nvSpPr>
-          <p:cNvPr id="5" name="fig2_D"/>
-          <p:cNvSpPr/>
-          <p:nvPr/>
-        </p:nvSpPr>
-        <p:spPr>
-          <a:xfrm>
-            <a:off x="0" y="2052000"/>
-            <a:ext cx="2880000" cy="1980000"/>
-          </a:xfrm>
-          <a:prstGeom prst="rect">
-            <a:avLst/>
-          </a:prstGeom>
-          <a:solidFill>
-            <a:srgbClr val="F0D0F0"/>
-          </a:solidFill>
-          <a:ln w="6350">
-            <a:solidFill>
-              <a:srgbClr val="808080"/>
-            </a:solidFill>
-          </a:ln>
-        </p:spPr>
-        <p:style>
-          <a:lnRef idx="1">
-            <a:schemeClr val="accent1"/>
-          </a:lnRef>
-          <a:fillRef idx="3">
-            <a:schemeClr val="accent1"/>
-          </a:fillRef>
-          <a:effectRef idx="2">
-            <a:schemeClr val="accent1"/>
-          </a:effectRef>
-          <a:fontRef idx="minor">
-            <a:schemeClr val="lt1"/>
-          </a:fontRef>
-        </p:style>
-        <p:txBody>
-          <a:bodyPr rtlCol="0" anchor="ctr" wrap="none"/>
-          <a:lstStyle/>
-          <a:p>
-            <a:pPr algn="ctr"/>
-            <a:r>
-              <a:rPr sz="1000" b="1">
-                <a:solidFill>
-                  <a:srgbClr val="333333"/>
-                </a:solidFill>
-              </a:rPr>
-              <a:t>D
-80×55 mm</a:t>
-            </a:r>
-          </a:p>
-        </p:txBody>
-      </p:sp>
-      <p:sp>
-        <p:nvSpPr>
-          <p:cNvPr id="6" name="fig2_E"/>
-          <p:cNvSpPr/>
-          <p:nvPr/>
-        </p:nvSpPr>
-        <p:spPr>
-          <a:xfrm>
-            <a:off x="3060000" y="2052000"/>
-            <a:ext cx="2880000" cy="1980000"/>
-          </a:xfrm>
-          <a:prstGeom prst="rect">
-            <a:avLst/>
-          </a:prstGeom>
-          <a:solidFill>
-            <a:srgbClr val="F5F0D0"/>
-          </a:solidFill>
-          <a:ln w="6350">
-            <a:solidFill>
-              <a:srgbClr val="808080"/>
-            </a:solidFill>
-          </a:ln>
-        </p:spPr>
-        <p:style>
-          <a:lnRef idx="1">
-            <a:schemeClr val="accent1"/>
-          </a:lnRef>
-          <a:fillRef idx="3">
-            <a:schemeClr val="accent1"/>
-          </a:fillRef>
-          <a:effectRef idx="2">
-            <a:schemeClr val="accent1"/>
-          </a:effectRef>
-          <a:fontRef idx="minor">
-            <a:schemeClr val="lt1"/>
-          </a:fontRef>
-        </p:style>
-        <p:txBody>
-          <a:bodyPr rtlCol="0" anchor="ctr" wrap="none"/>
-          <a:lstStyle/>
-          <a:p>
-            <a:pPr algn="ctr"/>
-            <a:r>
-              <a:rPr sz="1000" b="1">
-                <a:solidFill>
-                  <a:srgbClr val="333333"/>
-                </a:solidFill>
-              </a:rPr>
-              <a:t>E
-80×55 mm</a:t>
-            </a:r>
-          </a:p>
-        </p:txBody>
-      </p:sp>
-      <p:sp>
-        <p:nvSpPr>
-          <p:cNvPr id="7" name="fig2_F"/>
-          <p:cNvSpPr/>
-          <p:nvPr/>
-        </p:nvSpPr>
-        <p:spPr>
-          <a:xfrm>
-            <a:off x="0" y="4212000"/>
-            <a:ext cx="1872000" cy="1872000"/>
-          </a:xfrm>
-          <a:prstGeom prst="rect">
-            <a:avLst/>
-          </a:prstGeom>
-          <a:solidFill>
-            <a:srgbClr val="D0F5F5"/>
-          </a:solidFill>
-          <a:ln w="6350">
-            <a:solidFill>
-              <a:srgbClr val="808080"/>
-            </a:solidFill>
-          </a:ln>
-        </p:spPr>
-        <p:style>
-          <a:lnRef idx="1">
-            <a:schemeClr val="accent1"/>
-          </a:lnRef>
-          <a:fillRef idx="3">
-            <a:schemeClr val="accent1"/>
-          </a:fillRef>
-          <a:effectRef idx="2">
-            <a:schemeClr val="accent1"/>
-          </a:effectRef>
-          <a:fontRef idx="minor">
-            <a:schemeClr val="lt1"/>
-          </a:fontRef>
-        </p:style>
-        <p:txBody>
-          <a:bodyPr rtlCol="0" anchor="ctr" wrap="none"/>
-          <a:lstStyle/>
-          <a:p>
-            <a:pPr algn="ctr"/>
-            <a:r>
-              <a:rPr sz="1000" b="1">
-                <a:solidFill>
-                  <a:srgbClr val="333333"/>
-                </a:solidFill>
-              </a:rPr>
-              <a:t>F
-52×52 mm</a:t>
-            </a:r>
-          </a:p>
-        </p:txBody>
-      </p:sp>
-      <p:sp>
-        <p:nvSpPr>
-          <p:cNvPr id="8" name="fig2_G"/>
-          <p:cNvSpPr/>
-          <p:nvPr/>
-        </p:nvSpPr>
-        <p:spPr>
-          <a:xfrm>
-            <a:off x="2052000" y="4212000"/>
-            <a:ext cx="1872000" cy="1872000"/>
-          </a:xfrm>
-          <a:prstGeom prst="rect">
-            <a:avLst/>
-          </a:prstGeom>
-          <a:solidFill>
-            <a:srgbClr val="F5D0D8"/>
-          </a:solidFill>
-          <a:ln w="6350">
-            <a:solidFill>
-              <a:srgbClr val="808080"/>
-            </a:solidFill>
-          </a:ln>
-        </p:spPr>
-        <p:style>
-          <a:lnRef idx="1">
-            <a:schemeClr val="accent1"/>
-          </a:lnRef>
-          <a:fillRef idx="3">
-            <a:schemeClr val="accent1"/>
-          </a:fillRef>
-          <a:effectRef idx="2">
-            <a:schemeClr val="accent1"/>
-          </a:effectRef>
-          <a:fontRef idx="minor">
-            <a:schemeClr val="lt1"/>
-          </a:fontRef>
-        </p:style>
-        <p:txBody>
-          <a:bodyPr rtlCol="0" anchor="ctr" wrap="none"/>
-          <a:lstStyle/>
-          <a:p>
-            <a:pPr algn="ctr"/>
-            <a:r>
-              <a:rPr sz="1000" b="1">
-                <a:solidFill>
-                  <a:srgbClr val="333333"/>
-                </a:solidFill>
-              </a:rPr>
-              <a:t>G
-52×52 mm</a:t>
-            </a:r>
-          </a:p>
-        </p:txBody>
-      </p:sp>
-      <p:sp>
-        <p:nvSpPr>
-          <p:cNvPr id="9" name="fig2_H"/>
-          <p:cNvSpPr/>
-          <p:nvPr/>
-        </p:nvSpPr>
-        <p:spPr>
-          <a:xfrm>
-            <a:off x="4104000" y="4212000"/>
-            <a:ext cx="1836000" cy="1872000"/>
-          </a:xfrm>
-          <a:prstGeom prst="rect">
-            <a:avLst/>
-          </a:prstGeom>
-          <a:solidFill>
-            <a:srgbClr val="E8E8E8"/>
-          </a:solidFill>
-          <a:ln w="6350">
-            <a:solidFill>
-              <a:srgbClr val="808080"/>
-            </a:solidFill>
-          </a:ln>
-        </p:spPr>
-        <p:style>
-          <a:lnRef idx="1">
-            <a:schemeClr val="accent1"/>
-          </a:lnRef>
-          <a:fillRef idx="3">
-            <a:schemeClr val="accent1"/>
-          </a:fillRef>
-          <a:effectRef idx="2">
-            <a:schemeClr val="accent1"/>
-          </a:effectRef>
-          <a:fontRef idx="minor">
-            <a:schemeClr val="lt1"/>
-          </a:fontRef>
-        </p:style>
-        <p:txBody>
-          <a:bodyPr rtlCol="0" anchor="ctr" wrap="none"/>
-          <a:lstStyle/>
-          <a:p>
-            <a:pPr algn="ctr"/>
-            <a:r>
-              <a:rPr sz="1000" b="1">
-                <a:solidFill>
-                  <a:srgbClr val="333333"/>
-                </a:solidFill>
-              </a:rPr>
-              <a:t>H
-51×52 mm</a:t>
-            </a:r>
-          </a:p>
-        </p:txBody>
-      </p:sp>
-      <p:sp>
-        <p:nvSpPr>
-          <p:cNvPr id="10" name="fig2_I"/>
-          <p:cNvSpPr/>
-          <p:nvPr/>
-        </p:nvSpPr>
-        <p:spPr>
-          <a:xfrm>
-            <a:off x="0" y="6264000"/>
-            <a:ext cx="5940000" cy="1872000"/>
-          </a:xfrm>
-          <a:prstGeom prst="rect">
-            <a:avLst/>
-          </a:prstGeom>
-          <a:solidFill>
-            <a:srgbClr val="D8F0D8"/>
-          </a:solidFill>
-          <a:ln w="6350">
-            <a:solidFill>
-              <a:srgbClr val="808080"/>
-            </a:solidFill>
-          </a:ln>
-        </p:spPr>
-        <p:style>
-          <a:lnRef idx="1">
-            <a:schemeClr val="accent1"/>
-          </a:lnRef>
-          <a:fillRef idx="3">
-            <a:schemeClr val="accent1"/>
-          </a:fillRef>
-          <a:effectRef idx="2">
-            <a:schemeClr val="accent1"/>
-          </a:effectRef>
-          <a:fontRef idx="minor">
-            <a:schemeClr val="lt1"/>
-          </a:fontRef>
-        </p:style>
-        <p:txBody>
-          <a:bodyPr rtlCol="0" anchor="ctr" wrap="none"/>
-          <a:lstStyle/>
-          <a:p>
-            <a:pPr algn="ctr"/>
-            <a:r>
-              <a:rPr sz="1000" b="1">
-                <a:solidFill>
-                  <a:srgbClr val="333333"/>
-                </a:solidFill>
-              </a:rPr>
-              <a:t>I
-165×52 mm</a:t>
             </a:r>
           </a:p>
         </p:txBody>

</xml_diff>

<commit_message>
feat: update panels and layout for fig2
</commit_message>
<xml_diff>
--- a/figures/fig2/fig2.pptx
+++ b/figures/fig2/fig2.pptx
@@ -3104,8 +3104,8 @@
         </p:nvSpPr>
         <p:spPr>
           <a:xfrm>
-            <a:off x="2970212" y="1408061"/>
-            <a:ext cx="1398181" cy="1398935"/>
+            <a:off x="1460674" y="986057"/>
+            <a:ext cx="898526" cy="901109"/>
           </a:xfrm>
           <a:prstGeom prst="rect">
             <a:avLst/>
@@ -3172,8 +3172,8 @@
         </p:nvSpPr>
         <p:spPr>
           <a:xfrm>
-            <a:off x="4455318" y="1408060"/>
-            <a:ext cx="1398181" cy="1398935"/>
+            <a:off x="2412854" y="988337"/>
+            <a:ext cx="462307" cy="896547"/>
           </a:xfrm>
           <a:prstGeom prst="rect">
             <a:avLst/>
@@ -3240,8 +3240,8 @@
         </p:nvSpPr>
         <p:spPr>
           <a:xfrm>
-            <a:off x="-1" y="2894846"/>
-            <a:ext cx="1398181" cy="1398935"/>
+            <a:off x="30453" y="1922590"/>
+            <a:ext cx="742978" cy="923926"/>
           </a:xfrm>
           <a:prstGeom prst="rect">
             <a:avLst/>
@@ -3308,8 +3308,8 @@
         </p:nvSpPr>
         <p:spPr>
           <a:xfrm>
-            <a:off x="1485105" y="2898388"/>
-            <a:ext cx="1398181" cy="1398935"/>
+            <a:off x="816516" y="1927153"/>
+            <a:ext cx="742978" cy="914799"/>
           </a:xfrm>
           <a:prstGeom prst="rect">
             <a:avLst/>
@@ -3376,8 +3376,8 @@
         </p:nvSpPr>
         <p:spPr>
           <a:xfrm>
-            <a:off x="2970212" y="2898388"/>
-            <a:ext cx="1398181" cy="1398935"/>
+            <a:off x="1589440" y="1939085"/>
+            <a:ext cx="769760" cy="901109"/>
           </a:xfrm>
           <a:prstGeom prst="rect">
             <a:avLst/>
@@ -3444,8 +3444,8 @@
         </p:nvSpPr>
         <p:spPr>
           <a:xfrm>
-            <a:off x="4455317" y="2896616"/>
-            <a:ext cx="1398181" cy="1398935"/>
+            <a:off x="2389147" y="1945205"/>
+            <a:ext cx="681714" cy="896747"/>
           </a:xfrm>
           <a:prstGeom prst="rect">
             <a:avLst/>
@@ -3512,8 +3512,8 @@
         </p:nvSpPr>
         <p:spPr>
           <a:xfrm>
-            <a:off x="-2" y="4378088"/>
-            <a:ext cx="1398181" cy="1398935"/>
+            <a:off x="41498" y="2881939"/>
+            <a:ext cx="903215" cy="923926"/>
           </a:xfrm>
           <a:prstGeom prst="rect">
             <a:avLst/>
@@ -3580,8 +3580,8 @@
         </p:nvSpPr>
         <p:spPr>
           <a:xfrm>
-            <a:off x="-15951" y="5893981"/>
-            <a:ext cx="1398181" cy="1398935"/>
+            <a:off x="41498" y="3845852"/>
+            <a:ext cx="903215" cy="891764"/>
           </a:xfrm>
           <a:prstGeom prst="rect">
             <a:avLst/>
@@ -3648,8 +3648,8 @@
         </p:nvSpPr>
         <p:spPr>
           <a:xfrm>
-            <a:off x="1468222" y="4388717"/>
-            <a:ext cx="1398181" cy="1398935"/>
+            <a:off x="980447" y="2889764"/>
+            <a:ext cx="1004563" cy="923926"/>
           </a:xfrm>
           <a:prstGeom prst="rect">
             <a:avLst/>
@@ -3716,8 +3716,8 @@
         </p:nvSpPr>
         <p:spPr>
           <a:xfrm>
-            <a:off x="2970212" y="4401121"/>
-            <a:ext cx="1398181" cy="1398935"/>
+            <a:off x="2037415" y="2891065"/>
+            <a:ext cx="1031770" cy="905673"/>
           </a:xfrm>
           <a:prstGeom prst="rect">
             <a:avLst/>
@@ -3784,8 +3784,8 @@
         </p:nvSpPr>
         <p:spPr>
           <a:xfrm>
-            <a:off x="1468222" y="5893980"/>
-            <a:ext cx="1398181" cy="1398935"/>
+            <a:off x="983796" y="3842792"/>
+            <a:ext cx="1001214" cy="894824"/>
           </a:xfrm>
           <a:prstGeom prst="rect">
             <a:avLst/>
@@ -3852,8 +3852,8 @@
         </p:nvSpPr>
         <p:spPr>
           <a:xfrm>
-            <a:off x="2970212" y="5903854"/>
-            <a:ext cx="1398181" cy="1398935"/>
+            <a:off x="2024093" y="3857396"/>
+            <a:ext cx="1046768" cy="865615"/>
           </a:xfrm>
           <a:prstGeom prst="rect">
             <a:avLst/>
@@ -3920,8 +3920,8 @@
         </p:nvSpPr>
         <p:spPr>
           <a:xfrm>
-            <a:off x="1485106" y="1408059"/>
-            <a:ext cx="1398181" cy="1398935"/>
+            <a:off x="980447" y="974649"/>
+            <a:ext cx="444493" cy="910235"/>
           </a:xfrm>
           <a:prstGeom prst="rect">
             <a:avLst/>
@@ -3988,8 +3988,8 @@
         </p:nvSpPr>
         <p:spPr>
           <a:xfrm>
-            <a:off x="0" y="1408060"/>
-            <a:ext cx="1398181" cy="1398935"/>
+            <a:off x="19957" y="970085"/>
+            <a:ext cx="924756" cy="914799"/>
           </a:xfrm>
           <a:prstGeom prst="rect">
             <a:avLst/>
@@ -4042,8 +4042,8 @@
         </p:nvSpPr>
         <p:spPr>
           <a:xfrm>
-            <a:off x="2970212" y="0"/>
-            <a:ext cx="2856430" cy="1323753"/>
+            <a:off x="980447" y="9125"/>
+            <a:ext cx="1904359" cy="905673"/>
           </a:xfrm>
           <a:prstGeom prst="rect">
             <a:avLst/>
@@ -4096,8 +4096,8 @@
         </p:nvSpPr>
         <p:spPr>
           <a:xfrm>
-            <a:off x="0" y="0"/>
-            <a:ext cx="2883287" cy="1323753"/>
+            <a:off x="1" y="0"/>
+            <a:ext cx="924756" cy="923925"/>
           </a:xfrm>
           <a:prstGeom prst="rect">
             <a:avLst/>

</xml_diff>

<commit_message>
feat: changes in style and plot labels
</commit_message>
<xml_diff>
--- a/figures/fig2/fig2.pptx
+++ b/figures/fig2/fig2.pptx
@@ -3104,8 +3104,8 @@
         </p:nvSpPr>
         <p:spPr>
           <a:xfrm>
-            <a:off x="1460674" y="986057"/>
-            <a:ext cx="898526" cy="901109"/>
+            <a:off x="1916711" y="1278329"/>
+            <a:ext cx="1183246" cy="1186647"/>
           </a:xfrm>
           <a:prstGeom prst="rect">
             <a:avLst/>
@@ -3172,8 +3172,8 @@
         </p:nvSpPr>
         <p:spPr>
           <a:xfrm>
-            <a:off x="2412854" y="988337"/>
-            <a:ext cx="462307" cy="896547"/>
+            <a:off x="3155889" y="1293351"/>
+            <a:ext cx="608800" cy="1180640"/>
           </a:xfrm>
           <a:prstGeom prst="rect">
             <a:avLst/>
@@ -3240,8 +3240,8 @@
         </p:nvSpPr>
         <p:spPr>
           <a:xfrm>
-            <a:off x="30453" y="1922590"/>
-            <a:ext cx="742978" cy="923926"/>
+            <a:off x="0" y="2500102"/>
+            <a:ext cx="978408" cy="1216694"/>
           </a:xfrm>
           <a:prstGeom prst="rect">
             <a:avLst/>
@@ -3308,8 +3308,8 @@
         </p:nvSpPr>
         <p:spPr>
           <a:xfrm>
-            <a:off x="816516" y="1927153"/>
-            <a:ext cx="742978" cy="914799"/>
+            <a:off x="997778" y="2506111"/>
+            <a:ext cx="978408" cy="1204675"/>
           </a:xfrm>
           <a:prstGeom prst="rect">
             <a:avLst/>
@@ -3376,8 +3376,8 @@
         </p:nvSpPr>
         <p:spPr>
           <a:xfrm>
-            <a:off x="1589440" y="1939085"/>
-            <a:ext cx="769760" cy="901109"/>
+            <a:off x="1996820" y="2515124"/>
+            <a:ext cx="1013677" cy="1186647"/>
           </a:xfrm>
           <a:prstGeom prst="rect">
             <a:avLst/>
@@ -3444,8 +3444,8 @@
         </p:nvSpPr>
         <p:spPr>
           <a:xfrm>
-            <a:off x="2389147" y="1945205"/>
-            <a:ext cx="681714" cy="896747"/>
+            <a:off x="3031131" y="2520868"/>
+            <a:ext cx="897732" cy="1180903"/>
           </a:xfrm>
           <a:prstGeom prst="rect">
             <a:avLst/>
@@ -3512,8 +3512,8 @@
         </p:nvSpPr>
         <p:spPr>
           <a:xfrm>
-            <a:off x="41498" y="2881939"/>
-            <a:ext cx="903215" cy="923926"/>
+            <a:off x="0" y="3741201"/>
+            <a:ext cx="1189420" cy="1216694"/>
           </a:xfrm>
           <a:prstGeom prst="rect">
             <a:avLst/>
@@ -3580,8 +3580,8 @@
         </p:nvSpPr>
         <p:spPr>
           <a:xfrm>
-            <a:off x="41498" y="3845852"/>
-            <a:ext cx="903215" cy="891764"/>
+            <a:off x="0" y="5000204"/>
+            <a:ext cx="1189421" cy="1174341"/>
           </a:xfrm>
           <a:prstGeom prst="rect">
             <a:avLst/>
@@ -3648,8 +3648,8 @@
         </p:nvSpPr>
         <p:spPr>
           <a:xfrm>
-            <a:off x="980447" y="2889764"/>
-            <a:ext cx="1004563" cy="923926"/>
+            <a:off x="1221088" y="3741201"/>
+            <a:ext cx="1322883" cy="1216694"/>
           </a:xfrm>
           <a:prstGeom prst="rect">
             <a:avLst/>
@@ -3716,8 +3716,8 @@
         </p:nvSpPr>
         <p:spPr>
           <a:xfrm>
-            <a:off x="2037415" y="2891065"/>
-            <a:ext cx="1031770" cy="905673"/>
+            <a:off x="2563722" y="3753220"/>
+            <a:ext cx="1365141" cy="1204675"/>
           </a:xfrm>
           <a:prstGeom prst="rect">
             <a:avLst/>
@@ -3784,8 +3784,8 @@
         </p:nvSpPr>
         <p:spPr>
           <a:xfrm>
-            <a:off x="983796" y="3842792"/>
-            <a:ext cx="1001214" cy="894824"/>
+            <a:off x="1224008" y="5006596"/>
+            <a:ext cx="1318473" cy="1178371"/>
           </a:xfrm>
           <a:prstGeom prst="rect">
             <a:avLst/>
@@ -3852,8 +3852,8 @@
         </p:nvSpPr>
         <p:spPr>
           <a:xfrm>
-            <a:off x="2024093" y="3857396"/>
-            <a:ext cx="1046768" cy="865615"/>
+            <a:off x="2577068" y="5006596"/>
+            <a:ext cx="1378462" cy="1167949"/>
           </a:xfrm>
           <a:prstGeom prst="rect">
             <a:avLst/>
@@ -3920,8 +3920,8 @@
         </p:nvSpPr>
         <p:spPr>
           <a:xfrm>
-            <a:off x="980447" y="974649"/>
-            <a:ext cx="444493" cy="910235"/>
+            <a:off x="1275438" y="1275326"/>
+            <a:ext cx="585341" cy="1198665"/>
           </a:xfrm>
           <a:prstGeom prst="rect">
             <a:avLst/>
@@ -3988,8 +3988,8 @@
         </p:nvSpPr>
         <p:spPr>
           <a:xfrm>
-            <a:off x="19957" y="970085"/>
-            <a:ext cx="924756" cy="914799"/>
+            <a:off x="0" y="1269316"/>
+            <a:ext cx="1217787" cy="1204675"/>
           </a:xfrm>
           <a:prstGeom prst="rect">
             <a:avLst/>
@@ -4042,8 +4042,8 @@
         </p:nvSpPr>
         <p:spPr>
           <a:xfrm>
-            <a:off x="980447" y="9125"/>
-            <a:ext cx="1904359" cy="905673"/>
+            <a:off x="1256889" y="24036"/>
+            <a:ext cx="2507800" cy="1192657"/>
           </a:xfrm>
           <a:prstGeom prst="rect">
             <a:avLst/>
@@ -4096,8 +4096,8 @@
         </p:nvSpPr>
         <p:spPr>
           <a:xfrm>
-            <a:off x="1" y="0"/>
-            <a:ext cx="924756" cy="923925"/>
+            <a:off x="0" y="0"/>
+            <a:ext cx="1217787" cy="1216693"/>
           </a:xfrm>
           <a:prstGeom prst="rect">
             <a:avLst/>

</xml_diff>

<commit_message>
feat: update panels for fig2
</commit_message>
<xml_diff>
--- a/figures/fig2/fig2.pptx
+++ b/figures/fig2/fig2.pptx
@@ -4,6 +4,9 @@
   <p:sldMasterIdLst>
     <p:sldMasterId id="2147483648" r:id="rId1"/>
   </p:sldMasterIdLst>
+  <p:notesMasterIdLst>
+    <p:notesMasterId r:id="rId3"/>
+  </p:notesMasterIdLst>
   <p:sldIdLst>
     <p:sldId id="256" r:id="rId2"/>
   </p:sldIdLst>
@@ -121,6 +124,439 @@
     </p:ext>
   </p:extLst>
 </p:presentation>
+</file>
+
+<file path=ppt/notesMasters/notesMaster1.xml><?xml version="1.0" encoding="utf-8"?>
+<p:notesMaster xmlns:a="http://schemas.openxmlformats.org/drawingml/2006/main" xmlns:r="http://schemas.openxmlformats.org/officeDocument/2006/relationships" xmlns:p="http://schemas.openxmlformats.org/presentationml/2006/main">
+  <p:cSld>
+    <p:bg>
+      <p:bgRef idx="1001">
+        <a:schemeClr val="bg1"/>
+      </p:bgRef>
+    </p:bg>
+    <p:spTree>
+      <p:nvGrpSpPr>
+        <p:cNvPr id="1" name=""/>
+        <p:cNvGrpSpPr/>
+        <p:nvPr/>
+      </p:nvGrpSpPr>
+      <p:grpSpPr>
+        <a:xfrm>
+          <a:off x="0" y="0"/>
+          <a:ext cx="0" cy="0"/>
+          <a:chOff x="0" y="0"/>
+          <a:chExt cx="0" cy="0"/>
+        </a:xfrm>
+      </p:grpSpPr>
+      <p:sp>
+        <p:nvSpPr>
+          <p:cNvPr id="2" name="Header Placeholder 1"/>
+          <p:cNvSpPr>
+            <a:spLocks noGrp="1"/>
+          </p:cNvSpPr>
+          <p:nvPr>
+            <p:ph type="hdr" sz="quarter"/>
+          </p:nvPr>
+        </p:nvSpPr>
+        <p:spPr>
+          <a:xfrm>
+            <a:off x="0" y="0"/>
+            <a:ext cx="2971800" cy="458788"/>
+          </a:xfrm>
+          <a:prstGeom prst="rect">
+            <a:avLst/>
+          </a:prstGeom>
+        </p:spPr>
+        <p:txBody>
+          <a:bodyPr vert="horz" lIns="91440" tIns="45720" rIns="91440" bIns="45720" rtlCol="0"/>
+          <a:lstStyle>
+            <a:lvl1pPr algn="l">
+              <a:defRPr sz="1200"/>
+            </a:lvl1pPr>
+          </a:lstStyle>
+          <a:p>
+            <a:endParaRPr lang="en-US"/>
+          </a:p>
+        </p:txBody>
+      </p:sp>
+      <p:sp>
+        <p:nvSpPr>
+          <p:cNvPr id="3" name="Date Placeholder 2"/>
+          <p:cNvSpPr>
+            <a:spLocks noGrp="1"/>
+          </p:cNvSpPr>
+          <p:nvPr>
+            <p:ph type="dt" idx="1"/>
+          </p:nvPr>
+        </p:nvSpPr>
+        <p:spPr>
+          <a:xfrm>
+            <a:off x="3884613" y="0"/>
+            <a:ext cx="2971800" cy="458788"/>
+          </a:xfrm>
+          <a:prstGeom prst="rect">
+            <a:avLst/>
+          </a:prstGeom>
+        </p:spPr>
+        <p:txBody>
+          <a:bodyPr vert="horz" lIns="91440" tIns="45720" rIns="91440" bIns="45720" rtlCol="0"/>
+          <a:lstStyle>
+            <a:lvl1pPr algn="r">
+              <a:defRPr sz="1200"/>
+            </a:lvl1pPr>
+          </a:lstStyle>
+          <a:p>
+            <a:fld id="{2C601304-D772-4F92-A532-14E02F17E99D}" type="datetimeFigureOut">
+              <a:rPr lang="en-US" smtClean="0"/>
+              <a:t>10/16/2026</a:t>
+            </a:fld>
+            <a:endParaRPr lang="en-US"/>
+          </a:p>
+        </p:txBody>
+      </p:sp>
+      <p:sp>
+        <p:nvSpPr>
+          <p:cNvPr id="4" name="Slide Image Placeholder 3"/>
+          <p:cNvSpPr>
+            <a:spLocks noGrp="1" noRot="1" noChangeAspect="1"/>
+          </p:cNvSpPr>
+          <p:nvPr>
+            <p:ph type="sldImg" idx="2"/>
+          </p:nvPr>
+        </p:nvSpPr>
+        <p:spPr>
+          <a:xfrm>
+            <a:off x="2301875" y="1143000"/>
+            <a:ext cx="2254250" cy="3086100"/>
+          </a:xfrm>
+          <a:prstGeom prst="rect">
+            <a:avLst/>
+          </a:prstGeom>
+          <a:noFill/>
+          <a:ln w="12700">
+            <a:solidFill>
+              <a:prstClr val="black"/>
+            </a:solidFill>
+          </a:ln>
+        </p:spPr>
+        <p:txBody>
+          <a:bodyPr vert="horz" lIns="91440" tIns="45720" rIns="91440" bIns="45720" rtlCol="0" anchor="ctr"/>
+          <a:lstStyle/>
+          <a:p>
+            <a:endParaRPr lang="en-US"/>
+          </a:p>
+        </p:txBody>
+      </p:sp>
+      <p:sp>
+        <p:nvSpPr>
+          <p:cNvPr id="5" name="Notes Placeholder 4"/>
+          <p:cNvSpPr>
+            <a:spLocks noGrp="1"/>
+          </p:cNvSpPr>
+          <p:nvPr>
+            <p:ph type="body" sz="quarter" idx="3"/>
+          </p:nvPr>
+        </p:nvSpPr>
+        <p:spPr>
+          <a:xfrm>
+            <a:off x="685800" y="4400550"/>
+            <a:ext cx="5486400" cy="3600450"/>
+          </a:xfrm>
+          <a:prstGeom prst="rect">
+            <a:avLst/>
+          </a:prstGeom>
+        </p:spPr>
+        <p:txBody>
+          <a:bodyPr vert="horz" lIns="91440" tIns="45720" rIns="91440" bIns="45720" rtlCol="0"/>
+          <a:lstStyle/>
+          <a:p>
+            <a:pPr lvl="0"/>
+            <a:r>
+              <a:rPr lang="en-US"/>
+              <a:t>Click to edit Master text styles</a:t>
+            </a:r>
+          </a:p>
+          <a:p>
+            <a:pPr lvl="1"/>
+            <a:r>
+              <a:rPr lang="en-US"/>
+              <a:t>Second level</a:t>
+            </a:r>
+          </a:p>
+          <a:p>
+            <a:pPr lvl="2"/>
+            <a:r>
+              <a:rPr lang="en-US"/>
+              <a:t>Third level</a:t>
+            </a:r>
+          </a:p>
+          <a:p>
+            <a:pPr lvl="3"/>
+            <a:r>
+              <a:rPr lang="en-US"/>
+              <a:t>Fourth level</a:t>
+            </a:r>
+          </a:p>
+          <a:p>
+            <a:pPr lvl="4"/>
+            <a:r>
+              <a:rPr lang="en-US"/>
+              <a:t>Fifth level</a:t>
+            </a:r>
+          </a:p>
+        </p:txBody>
+      </p:sp>
+      <p:sp>
+        <p:nvSpPr>
+          <p:cNvPr id="6" name="Footer Placeholder 5"/>
+          <p:cNvSpPr>
+            <a:spLocks noGrp="1"/>
+          </p:cNvSpPr>
+          <p:nvPr>
+            <p:ph type="ftr" sz="quarter" idx="4"/>
+          </p:nvPr>
+        </p:nvSpPr>
+        <p:spPr>
+          <a:xfrm>
+            <a:off x="0" y="8685213"/>
+            <a:ext cx="2971800" cy="458787"/>
+          </a:xfrm>
+          <a:prstGeom prst="rect">
+            <a:avLst/>
+          </a:prstGeom>
+        </p:spPr>
+        <p:txBody>
+          <a:bodyPr vert="horz" lIns="91440" tIns="45720" rIns="91440" bIns="45720" rtlCol="0" anchor="b"/>
+          <a:lstStyle>
+            <a:lvl1pPr algn="l">
+              <a:defRPr sz="1200"/>
+            </a:lvl1pPr>
+          </a:lstStyle>
+          <a:p>
+            <a:endParaRPr lang="en-US"/>
+          </a:p>
+        </p:txBody>
+      </p:sp>
+      <p:sp>
+        <p:nvSpPr>
+          <p:cNvPr id="7" name="Slide Number Placeholder 6"/>
+          <p:cNvSpPr>
+            <a:spLocks noGrp="1"/>
+          </p:cNvSpPr>
+          <p:nvPr>
+            <p:ph type="sldNum" sz="quarter" idx="5"/>
+          </p:nvPr>
+        </p:nvSpPr>
+        <p:spPr>
+          <a:xfrm>
+            <a:off x="3884613" y="8685213"/>
+            <a:ext cx="2971800" cy="458787"/>
+          </a:xfrm>
+          <a:prstGeom prst="rect">
+            <a:avLst/>
+          </a:prstGeom>
+        </p:spPr>
+        <p:txBody>
+          <a:bodyPr vert="horz" lIns="91440" tIns="45720" rIns="91440" bIns="45720" rtlCol="0" anchor="b"/>
+          <a:lstStyle>
+            <a:lvl1pPr algn="r">
+              <a:defRPr sz="1200"/>
+            </a:lvl1pPr>
+          </a:lstStyle>
+          <a:p>
+            <a:fld id="{A5762387-17C4-40CA-BB68-CE74AA26FAE6}" type="slidenum">
+              <a:rPr lang="en-US" smtClean="0"/>
+              <a:t>‹#›</a:t>
+            </a:fld>
+            <a:endParaRPr lang="en-US"/>
+          </a:p>
+        </p:txBody>
+      </p:sp>
+    </p:spTree>
+    <p:extLst>
+      <p:ext uri="{BB962C8B-B14F-4D97-AF65-F5344CB8AC3E}">
+        <p14:creationId xmlns:p14="http://schemas.microsoft.com/office/powerpoint/2010/main" val="1893832500"/>
+      </p:ext>
+    </p:extLst>
+  </p:cSld>
+  <p:clrMap bg1="lt1" tx1="dk1" bg2="lt2" tx2="dk2" accent1="accent1" accent2="accent2" accent3="accent3" accent4="accent4" accent5="accent5" accent6="accent6" hlink="hlink" folHlink="folHlink"/>
+  <p:notesStyle>
+    <a:lvl1pPr marL="0" algn="l" defTabSz="914400" rtl="0" eaLnBrk="1" latinLnBrk="0" hangingPunct="1">
+      <a:defRPr sz="1200" kern="1200">
+        <a:solidFill>
+          <a:schemeClr val="tx1"/>
+        </a:solidFill>
+        <a:latin typeface="+mn-lt"/>
+        <a:ea typeface="+mn-ea"/>
+        <a:cs typeface="+mn-cs"/>
+      </a:defRPr>
+    </a:lvl1pPr>
+    <a:lvl2pPr marL="457200" algn="l" defTabSz="914400" rtl="0" eaLnBrk="1" latinLnBrk="0" hangingPunct="1">
+      <a:defRPr sz="1200" kern="1200">
+        <a:solidFill>
+          <a:schemeClr val="tx1"/>
+        </a:solidFill>
+        <a:latin typeface="+mn-lt"/>
+        <a:ea typeface="+mn-ea"/>
+        <a:cs typeface="+mn-cs"/>
+      </a:defRPr>
+    </a:lvl2pPr>
+    <a:lvl3pPr marL="914400" algn="l" defTabSz="914400" rtl="0" eaLnBrk="1" latinLnBrk="0" hangingPunct="1">
+      <a:defRPr sz="1200" kern="1200">
+        <a:solidFill>
+          <a:schemeClr val="tx1"/>
+        </a:solidFill>
+        <a:latin typeface="+mn-lt"/>
+        <a:ea typeface="+mn-ea"/>
+        <a:cs typeface="+mn-cs"/>
+      </a:defRPr>
+    </a:lvl3pPr>
+    <a:lvl4pPr marL="1371600" algn="l" defTabSz="914400" rtl="0" eaLnBrk="1" latinLnBrk="0" hangingPunct="1">
+      <a:defRPr sz="1200" kern="1200">
+        <a:solidFill>
+          <a:schemeClr val="tx1"/>
+        </a:solidFill>
+        <a:latin typeface="+mn-lt"/>
+        <a:ea typeface="+mn-ea"/>
+        <a:cs typeface="+mn-cs"/>
+      </a:defRPr>
+    </a:lvl4pPr>
+    <a:lvl5pPr marL="1828800" algn="l" defTabSz="914400" rtl="0" eaLnBrk="1" latinLnBrk="0" hangingPunct="1">
+      <a:defRPr sz="1200" kern="1200">
+        <a:solidFill>
+          <a:schemeClr val="tx1"/>
+        </a:solidFill>
+        <a:latin typeface="+mn-lt"/>
+        <a:ea typeface="+mn-ea"/>
+        <a:cs typeface="+mn-cs"/>
+      </a:defRPr>
+    </a:lvl5pPr>
+    <a:lvl6pPr marL="2286000" algn="l" defTabSz="914400" rtl="0" eaLnBrk="1" latinLnBrk="0" hangingPunct="1">
+      <a:defRPr sz="1200" kern="1200">
+        <a:solidFill>
+          <a:schemeClr val="tx1"/>
+        </a:solidFill>
+        <a:latin typeface="+mn-lt"/>
+        <a:ea typeface="+mn-ea"/>
+        <a:cs typeface="+mn-cs"/>
+      </a:defRPr>
+    </a:lvl6pPr>
+    <a:lvl7pPr marL="2743200" algn="l" defTabSz="914400" rtl="0" eaLnBrk="1" latinLnBrk="0" hangingPunct="1">
+      <a:defRPr sz="1200" kern="1200">
+        <a:solidFill>
+          <a:schemeClr val="tx1"/>
+        </a:solidFill>
+        <a:latin typeface="+mn-lt"/>
+        <a:ea typeface="+mn-ea"/>
+        <a:cs typeface="+mn-cs"/>
+      </a:defRPr>
+    </a:lvl7pPr>
+    <a:lvl8pPr marL="3200400" algn="l" defTabSz="914400" rtl="0" eaLnBrk="1" latinLnBrk="0" hangingPunct="1">
+      <a:defRPr sz="1200" kern="1200">
+        <a:solidFill>
+          <a:schemeClr val="tx1"/>
+        </a:solidFill>
+        <a:latin typeface="+mn-lt"/>
+        <a:ea typeface="+mn-ea"/>
+        <a:cs typeface="+mn-cs"/>
+      </a:defRPr>
+    </a:lvl8pPr>
+    <a:lvl9pPr marL="3657600" algn="l" defTabSz="914400" rtl="0" eaLnBrk="1" latinLnBrk="0" hangingPunct="1">
+      <a:defRPr sz="1200" kern="1200">
+        <a:solidFill>
+          <a:schemeClr val="tx1"/>
+        </a:solidFill>
+        <a:latin typeface="+mn-lt"/>
+        <a:ea typeface="+mn-ea"/>
+        <a:cs typeface="+mn-cs"/>
+      </a:defRPr>
+    </a:lvl9pPr>
+  </p:notesStyle>
+</p:notesMaster>
+</file>
+
+<file path=ppt/notesSlides/notesSlide1.xml><?xml version="1.0" encoding="utf-8"?>
+<p:notes xmlns:a="http://schemas.openxmlformats.org/drawingml/2006/main" xmlns:r="http://schemas.openxmlformats.org/officeDocument/2006/relationships" xmlns:p="http://schemas.openxmlformats.org/presentationml/2006/main">
+  <p:cSld>
+    <p:spTree>
+      <p:nvGrpSpPr>
+        <p:cNvPr id="1" name=""/>
+        <p:cNvGrpSpPr/>
+        <p:nvPr/>
+      </p:nvGrpSpPr>
+      <p:grpSpPr>
+        <a:xfrm>
+          <a:off x="0" y="0"/>
+          <a:ext cx="0" cy="0"/>
+          <a:chOff x="0" y="0"/>
+          <a:chExt cx="0" cy="0"/>
+        </a:xfrm>
+      </p:grpSpPr>
+      <p:sp>
+        <p:nvSpPr>
+          <p:cNvPr id="2" name="Slide Image Placeholder 1"/>
+          <p:cNvSpPr>
+            <a:spLocks noGrp="1" noRot="1" noChangeAspect="1"/>
+          </p:cNvSpPr>
+          <p:nvPr>
+            <p:ph type="sldImg"/>
+          </p:nvPr>
+        </p:nvSpPr>
+        <p:spPr/>
+      </p:sp>
+      <p:sp>
+        <p:nvSpPr>
+          <p:cNvPr id="3" name="Notes Placeholder 2"/>
+          <p:cNvSpPr>
+            <a:spLocks noGrp="1"/>
+          </p:cNvSpPr>
+          <p:nvPr>
+            <p:ph type="body" idx="1"/>
+          </p:nvPr>
+        </p:nvSpPr>
+        <p:spPr/>
+        <p:txBody>
+          <a:bodyPr/>
+          <a:lstStyle/>
+          <a:p>
+            <a:endParaRPr lang="en-US" dirty="0"/>
+          </a:p>
+        </p:txBody>
+      </p:sp>
+      <p:sp>
+        <p:nvSpPr>
+          <p:cNvPr id="4" name="Slide Number Placeholder 3"/>
+          <p:cNvSpPr>
+            <a:spLocks noGrp="1"/>
+          </p:cNvSpPr>
+          <p:nvPr>
+            <p:ph type="sldNum" sz="quarter" idx="5"/>
+          </p:nvPr>
+        </p:nvSpPr>
+        <p:spPr/>
+        <p:txBody>
+          <a:bodyPr/>
+          <a:lstStyle/>
+          <a:p>
+            <a:fld id="{A5762387-17C4-40CA-BB68-CE74AA26FAE6}" type="slidenum">
+              <a:rPr lang="en-US" smtClean="0"/>
+              <a:t>1</a:t>
+            </a:fld>
+            <a:endParaRPr lang="en-US"/>
+          </a:p>
+        </p:txBody>
+      </p:sp>
+    </p:spTree>
+    <p:extLst>
+      <p:ext uri="{BB962C8B-B14F-4D97-AF65-F5344CB8AC3E}">
+        <p14:creationId xmlns:p14="http://schemas.microsoft.com/office/powerpoint/2010/main" val="2762319329"/>
+      </p:ext>
+    </p:extLst>
+  </p:cSld>
+  <p:clrMapOvr>
+    <a:masterClrMapping/>
+  </p:clrMapOvr>
+</p:notes>
 </file>
 
 <file path=ppt/slideLayouts/slideLayout1.xml><?xml version="1.0" encoding="utf-8"?>
@@ -3104,8 +3540,8 @@
         </p:nvSpPr>
         <p:spPr>
           <a:xfrm>
-            <a:off x="1916711" y="1278329"/>
-            <a:ext cx="1183246" cy="1186647"/>
+            <a:off x="4580148" y="43982"/>
+            <a:ext cx="1116000" cy="1116000"/>
           </a:xfrm>
           <a:prstGeom prst="rect">
             <a:avLst/>
@@ -3172,8 +3608,8 @@
         </p:nvSpPr>
         <p:spPr>
           <a:xfrm>
-            <a:off x="3155889" y="1293351"/>
-            <a:ext cx="608800" cy="1180640"/>
+            <a:off x="122357" y="1177138"/>
+            <a:ext cx="1544822" cy="1116000"/>
           </a:xfrm>
           <a:prstGeom prst="rect">
             <a:avLst/>
@@ -3240,8 +3676,8 @@
         </p:nvSpPr>
         <p:spPr>
           <a:xfrm>
-            <a:off x="0" y="2500102"/>
-            <a:ext cx="978408" cy="1216694"/>
+            <a:off x="1694221" y="1177138"/>
+            <a:ext cx="1116000" cy="1116000"/>
           </a:xfrm>
           <a:prstGeom prst="rect">
             <a:avLst/>
@@ -3308,8 +3744,8 @@
         </p:nvSpPr>
         <p:spPr>
           <a:xfrm>
-            <a:off x="997778" y="2506111"/>
-            <a:ext cx="978408" cy="1204675"/>
+            <a:off x="2834084" y="1176788"/>
+            <a:ext cx="1548000" cy="1116000"/>
           </a:xfrm>
           <a:prstGeom prst="rect">
             <a:avLst/>
@@ -3376,8 +3812,8 @@
         </p:nvSpPr>
         <p:spPr>
           <a:xfrm>
-            <a:off x="1996820" y="2515124"/>
-            <a:ext cx="1013677" cy="1186647"/>
+            <a:off x="4580148" y="1174050"/>
+            <a:ext cx="1116000" cy="1116000"/>
           </a:xfrm>
           <a:prstGeom prst="rect">
             <a:avLst/>
@@ -3444,8 +3880,8 @@
         </p:nvSpPr>
         <p:spPr>
           <a:xfrm>
-            <a:off x="3031131" y="2520868"/>
-            <a:ext cx="897732" cy="1180903"/>
+            <a:off x="122358" y="2311739"/>
+            <a:ext cx="1548000" cy="1116000"/>
           </a:xfrm>
           <a:prstGeom prst="rect">
             <a:avLst/>
@@ -3512,8 +3948,8 @@
         </p:nvSpPr>
         <p:spPr>
           <a:xfrm>
-            <a:off x="0" y="3741201"/>
-            <a:ext cx="1189420" cy="1216694"/>
+            <a:off x="1694221" y="2311739"/>
+            <a:ext cx="1116000" cy="1116193"/>
           </a:xfrm>
           <a:prstGeom prst="rect">
             <a:avLst/>
@@ -3568,7 +4004,7 @@
       </p:sp>
       <p:sp>
         <p:nvSpPr>
-          <p:cNvPr id="30" name="fig2_N">
+          <p:cNvPr id="30" name="fig2_P">
             <a:extLst>
               <a:ext uri="{FF2B5EF4-FFF2-40B4-BE49-F238E27FC236}">
                 <a16:creationId xmlns:a16="http://schemas.microsoft.com/office/drawing/2014/main" id="{4B9BEAF1-E32B-18AC-71C5-7973920C7D76}"/>
@@ -3580,8 +4016,8 @@
         </p:nvSpPr>
         <p:spPr>
           <a:xfrm>
-            <a:off x="0" y="5000204"/>
-            <a:ext cx="1189421" cy="1174341"/>
+            <a:off x="1694221" y="3459672"/>
+            <a:ext cx="1116000" cy="1116000"/>
           </a:xfrm>
           <a:prstGeom prst="rect">
             <a:avLst/>
@@ -3620,7 +4056,8 @@
                   <a:srgbClr val="333333"/>
                 </a:solidFill>
               </a:rPr>
-              <a:t>N</a:t>
+              <a:t>P
+</a:t>
             </a:r>
             <a:r>
               <a:rPr sz="1000" b="1" dirty="0">
@@ -3628,8 +4065,7 @@
                   <a:srgbClr val="333333"/>
                 </a:solidFill>
               </a:rPr>
-              <a:t>
-51×52 mm</a:t>
+              <a:t>51×52 mm</a:t>
             </a:r>
           </a:p>
         </p:txBody>
@@ -3648,8 +4084,8 @@
         </p:nvSpPr>
         <p:spPr>
           <a:xfrm>
-            <a:off x="1221088" y="3741201"/>
-            <a:ext cx="1322883" cy="1216694"/>
+            <a:off x="2834084" y="2311739"/>
+            <a:ext cx="576000" cy="1116193"/>
           </a:xfrm>
           <a:prstGeom prst="rect">
             <a:avLst/>
@@ -3716,8 +4152,8 @@
         </p:nvSpPr>
         <p:spPr>
           <a:xfrm>
-            <a:off x="2563722" y="3753220"/>
-            <a:ext cx="1365141" cy="1204675"/>
+            <a:off x="3430083" y="2311739"/>
+            <a:ext cx="1116000" cy="1116193"/>
           </a:xfrm>
           <a:prstGeom prst="rect">
             <a:avLst/>
@@ -3772,7 +4208,7 @@
       </p:sp>
       <p:sp>
         <p:nvSpPr>
-          <p:cNvPr id="36" name="fig2_O">
+          <p:cNvPr id="36" name="fig2_N">
             <a:extLst>
               <a:ext uri="{FF2B5EF4-FFF2-40B4-BE49-F238E27FC236}">
                 <a16:creationId xmlns:a16="http://schemas.microsoft.com/office/drawing/2014/main" id="{0F09EC13-CEF1-2761-6318-FDF663E79161}"/>
@@ -3784,8 +4220,8 @@
         </p:nvSpPr>
         <p:spPr>
           <a:xfrm>
-            <a:off x="1224008" y="5006596"/>
-            <a:ext cx="1318473" cy="1178371"/>
+            <a:off x="4580148" y="2311739"/>
+            <a:ext cx="1116000" cy="1116000"/>
           </a:xfrm>
           <a:prstGeom prst="rect">
             <a:avLst/>
@@ -3824,7 +4260,7 @@
                   <a:srgbClr val="333333"/>
                 </a:solidFill>
               </a:rPr>
-              <a:t>O</a:t>
+              <a:t>N</a:t>
             </a:r>
             <a:r>
               <a:rPr sz="1000" b="1" dirty="0">
@@ -3840,7 +4276,7 @@
       </p:sp>
       <p:sp>
         <p:nvSpPr>
-          <p:cNvPr id="38" name="fig2_P">
+          <p:cNvPr id="38" name="fig2_O">
             <a:extLst>
               <a:ext uri="{FF2B5EF4-FFF2-40B4-BE49-F238E27FC236}">
                 <a16:creationId xmlns:a16="http://schemas.microsoft.com/office/drawing/2014/main" id="{E73FA2B4-191E-3521-7B6F-6569D721D403}"/>
@@ -3852,8 +4288,8 @@
         </p:nvSpPr>
         <p:spPr>
           <a:xfrm>
-            <a:off x="2577068" y="5006596"/>
-            <a:ext cx="1378462" cy="1167949"/>
+            <a:off x="122358" y="3459672"/>
+            <a:ext cx="1548000" cy="1116000"/>
           </a:xfrm>
           <a:prstGeom prst="rect">
             <a:avLst/>
@@ -3892,7 +4328,8 @@
                   <a:srgbClr val="333333"/>
                 </a:solidFill>
               </a:rPr>
-              <a:t>P</a:t>
+              <a:t>O
+</a:t>
             </a:r>
             <a:r>
               <a:rPr sz="1000" b="1" dirty="0">
@@ -3900,8 +4337,7 @@
                   <a:srgbClr val="333333"/>
                 </a:solidFill>
               </a:rPr>
-              <a:t>
-51×52 mm</a:t>
+              <a:t>51×52 mm</a:t>
             </a:r>
           </a:p>
         </p:txBody>
@@ -3920,8 +4356,8 @@
         </p:nvSpPr>
         <p:spPr>
           <a:xfrm>
-            <a:off x="1275438" y="1275326"/>
-            <a:ext cx="585341" cy="1198665"/>
+            <a:off x="3433893" y="43982"/>
+            <a:ext cx="1116000" cy="1116000"/>
           </a:xfrm>
           <a:prstGeom prst="rect">
             <a:avLst/>
@@ -3988,8 +4424,8 @@
         </p:nvSpPr>
         <p:spPr>
           <a:xfrm>
-            <a:off x="0" y="1269316"/>
-            <a:ext cx="1217787" cy="1204675"/>
+            <a:off x="2834084" y="39123"/>
+            <a:ext cx="576000" cy="1116000"/>
           </a:xfrm>
           <a:prstGeom prst="rect">
             <a:avLst/>
@@ -4042,8 +4478,8 @@
         </p:nvSpPr>
         <p:spPr>
           <a:xfrm>
-            <a:off x="1256889" y="24036"/>
-            <a:ext cx="2507800" cy="1192657"/>
+            <a:off x="1694221" y="36000"/>
+            <a:ext cx="1116000" cy="1116000"/>
           </a:xfrm>
           <a:prstGeom prst="rect">
             <a:avLst/>
@@ -4096,8 +4532,8 @@
         </p:nvSpPr>
         <p:spPr>
           <a:xfrm>
-            <a:off x="0" y="0"/>
-            <a:ext cx="1217787" cy="1216693"/>
+            <a:off x="122358" y="36000"/>
+            <a:ext cx="1548000" cy="1116000"/>
           </a:xfrm>
           <a:prstGeom prst="rect">
             <a:avLst/>
@@ -4131,13 +4567,149 @@
           <a:p>
             <a:pPr algn="ctr"/>
             <a:r>
-              <a:rPr sz="1000" b="1">
+              <a:rPr sz="1000" b="1" dirty="0">
                 <a:solidFill>
                   <a:srgbClr val="333333"/>
                 </a:solidFill>
               </a:rPr>
               <a:t>A
 52×52 mm</a:t>
+            </a:r>
+          </a:p>
+        </p:txBody>
+      </p:sp>
+      <p:sp>
+        <p:nvSpPr>
+          <p:cNvPr id="5" name="fig2_Q">
+            <a:extLst>
+              <a:ext uri="{FF2B5EF4-FFF2-40B4-BE49-F238E27FC236}">
+                <a16:creationId xmlns:a16="http://schemas.microsoft.com/office/drawing/2014/main" id="{6282A2EC-B6E0-9DEB-A898-7D27C466D0B7}"/>
+              </a:ext>
+            </a:extLst>
+          </p:cNvPr>
+          <p:cNvSpPr/>
+          <p:nvPr/>
+        </p:nvSpPr>
+        <p:spPr>
+          <a:xfrm>
+            <a:off x="2834083" y="3459672"/>
+            <a:ext cx="1548000" cy="1116000"/>
+          </a:xfrm>
+          <a:prstGeom prst="rect">
+            <a:avLst/>
+          </a:prstGeom>
+          <a:solidFill>
+            <a:srgbClr val="F5E8D0"/>
+          </a:solidFill>
+          <a:ln w="6350">
+            <a:solidFill>
+              <a:srgbClr val="808080"/>
+            </a:solidFill>
+          </a:ln>
+        </p:spPr>
+        <p:style>
+          <a:lnRef idx="1">
+            <a:schemeClr val="accent1"/>
+          </a:lnRef>
+          <a:fillRef idx="3">
+            <a:schemeClr val="accent1"/>
+          </a:fillRef>
+          <a:effectRef idx="2">
+            <a:schemeClr val="accent1"/>
+          </a:effectRef>
+          <a:fontRef idx="minor">
+            <a:schemeClr val="lt1"/>
+          </a:fontRef>
+        </p:style>
+        <p:txBody>
+          <a:bodyPr wrap="none" rtlCol="0" anchor="ctr"/>
+          <a:lstStyle/>
+          <a:p>
+            <a:pPr algn="ctr"/>
+            <a:r>
+              <a:rPr lang="en-US" sz="1000" b="1" dirty="0">
+                <a:solidFill>
+                  <a:srgbClr val="333333"/>
+                </a:solidFill>
+              </a:rPr>
+              <a:t>Q</a:t>
+            </a:r>
+            <a:r>
+              <a:rPr sz="1000" b="1" dirty="0">
+                <a:solidFill>
+                  <a:srgbClr val="333333"/>
+                </a:solidFill>
+              </a:rPr>
+              <a:t>
+51×52 mm</a:t>
+            </a:r>
+          </a:p>
+        </p:txBody>
+      </p:sp>
+      <p:sp>
+        <p:nvSpPr>
+          <p:cNvPr id="7" name="fig2_R">
+            <a:extLst>
+              <a:ext uri="{FF2B5EF4-FFF2-40B4-BE49-F238E27FC236}">
+                <a16:creationId xmlns:a16="http://schemas.microsoft.com/office/drawing/2014/main" id="{CC47702C-B2D9-29E2-3969-B426BF1240A8}"/>
+              </a:ext>
+            </a:extLst>
+          </p:cNvPr>
+          <p:cNvSpPr/>
+          <p:nvPr/>
+        </p:nvSpPr>
+        <p:spPr>
+          <a:xfrm>
+            <a:off x="4580148" y="3459672"/>
+            <a:ext cx="1116000" cy="1116000"/>
+          </a:xfrm>
+          <a:prstGeom prst="rect">
+            <a:avLst/>
+          </a:prstGeom>
+          <a:solidFill>
+            <a:srgbClr val="F5E8D0"/>
+          </a:solidFill>
+          <a:ln w="6350">
+            <a:solidFill>
+              <a:srgbClr val="808080"/>
+            </a:solidFill>
+          </a:ln>
+        </p:spPr>
+        <p:style>
+          <a:lnRef idx="1">
+            <a:schemeClr val="accent1"/>
+          </a:lnRef>
+          <a:fillRef idx="3">
+            <a:schemeClr val="accent1"/>
+          </a:fillRef>
+          <a:effectRef idx="2">
+            <a:schemeClr val="accent1"/>
+          </a:effectRef>
+          <a:fontRef idx="minor">
+            <a:schemeClr val="lt1"/>
+          </a:fontRef>
+        </p:style>
+        <p:txBody>
+          <a:bodyPr wrap="none" rtlCol="0" anchor="ctr"/>
+          <a:lstStyle/>
+          <a:p>
+            <a:pPr algn="ctr"/>
+            <a:r>
+              <a:rPr lang="en-US" sz="1000" b="1" dirty="0">
+                <a:solidFill>
+                  <a:srgbClr val="333333"/>
+                </a:solidFill>
+              </a:rPr>
+              <a:t>R</a:t>
+            </a:r>
+            <a:r>
+              <a:rPr sz="1000" b="1" dirty="0">
+                <a:solidFill>
+                  <a:srgbClr val="333333"/>
+                </a:solidFill>
+              </a:rPr>
+              <a:t>
+51×52 mm</a:t>
             </a:r>
           </a:p>
         </p:txBody>
@@ -4468,4 +5040,319 @@
   </a:objectDefaults>
   <a:extraClrSchemeLst/>
 </a:theme>
+</file>
+
+<file path=ppt/theme/theme2.xml><?xml version="1.0" encoding="utf-8"?>
+<a:theme xmlns:a="http://schemas.openxmlformats.org/drawingml/2006/main" name="Office Theme">
+  <a:themeElements>
+    <a:clrScheme name="Office">
+      <a:dk1>
+        <a:sysClr val="windowText" lastClr="000000"/>
+      </a:dk1>
+      <a:lt1>
+        <a:sysClr val="window" lastClr="FFFFFF"/>
+      </a:lt1>
+      <a:dk2>
+        <a:srgbClr val="0E2841"/>
+      </a:dk2>
+      <a:lt2>
+        <a:srgbClr val="E8E8E8"/>
+      </a:lt2>
+      <a:accent1>
+        <a:srgbClr val="156082"/>
+      </a:accent1>
+      <a:accent2>
+        <a:srgbClr val="E97132"/>
+      </a:accent2>
+      <a:accent3>
+        <a:srgbClr val="196B24"/>
+      </a:accent3>
+      <a:accent4>
+        <a:srgbClr val="0F9ED5"/>
+      </a:accent4>
+      <a:accent5>
+        <a:srgbClr val="A02B93"/>
+      </a:accent5>
+      <a:accent6>
+        <a:srgbClr val="4EA72E"/>
+      </a:accent6>
+      <a:hlink>
+        <a:srgbClr val="467886"/>
+      </a:hlink>
+      <a:folHlink>
+        <a:srgbClr val="96607D"/>
+      </a:folHlink>
+    </a:clrScheme>
+    <a:fontScheme name="Office">
+      <a:majorFont>
+        <a:latin typeface="Aptos Display" panose="02110004020202020204"/>
+        <a:ea typeface=""/>
+        <a:cs typeface=""/>
+        <a:font script="Jpan" typeface="游ゴシック Light"/>
+        <a:font script="Hang" typeface="맑은 고딕"/>
+        <a:font script="Hans" typeface="等线 Light"/>
+        <a:font script="Hant" typeface="新細明體"/>
+        <a:font script="Arab" typeface="Times New Roman"/>
+        <a:font script="Hebr" typeface="Times New Roman"/>
+        <a:font script="Thai" typeface="Angsana New"/>
+        <a:font script="Ethi" typeface="Nyala"/>
+        <a:font script="Beng" typeface="Vrinda"/>
+        <a:font script="Gujr" typeface="Shruti"/>
+        <a:font script="Khmr" typeface="MoolBoran"/>
+        <a:font script="Knda" typeface="Tunga"/>
+        <a:font script="Guru" typeface="Raavi"/>
+        <a:font script="Cans" typeface="Euphemia"/>
+        <a:font script="Cher" typeface="Plantagenet Cherokee"/>
+        <a:font script="Yiii" typeface="Microsoft Yi Baiti"/>
+        <a:font script="Tibt" typeface="Microsoft Himalaya"/>
+        <a:font script="Thaa" typeface="MV Boli"/>
+        <a:font script="Deva" typeface="Mangal"/>
+        <a:font script="Telu" typeface="Gautami"/>
+        <a:font script="Taml" typeface="Latha"/>
+        <a:font script="Syrc" typeface="Estrangelo Edessa"/>
+        <a:font script="Orya" typeface="Kalinga"/>
+        <a:font script="Mlym" typeface="Kartika"/>
+        <a:font script="Laoo" typeface="DokChampa"/>
+        <a:font script="Sinh" typeface="Iskoola Pota"/>
+        <a:font script="Mong" typeface="Mongolian Baiti"/>
+        <a:font script="Viet" typeface="Times New Roman"/>
+        <a:font script="Uigh" typeface="Microsoft Uighur"/>
+        <a:font script="Geor" typeface="Sylfaen"/>
+        <a:font script="Armn" typeface="Arial"/>
+        <a:font script="Bugi" typeface="Leelawadee UI"/>
+        <a:font script="Bopo" typeface="Microsoft JhengHei"/>
+        <a:font script="Java" typeface="Javanese Text"/>
+        <a:font script="Lisu" typeface="Segoe UI"/>
+        <a:font script="Mymr" typeface="Myanmar Text"/>
+        <a:font script="Nkoo" typeface="Ebrima"/>
+        <a:font script="Olck" typeface="Nirmala UI"/>
+        <a:font script="Osma" typeface="Ebrima"/>
+        <a:font script="Phag" typeface="Phagspa"/>
+        <a:font script="Syrn" typeface="Estrangelo Edessa"/>
+        <a:font script="Syrj" typeface="Estrangelo Edessa"/>
+        <a:font script="Syre" typeface="Estrangelo Edessa"/>
+        <a:font script="Sora" typeface="Nirmala UI"/>
+        <a:font script="Tale" typeface="Microsoft Tai Le"/>
+        <a:font script="Talu" typeface="Microsoft New Tai Lue"/>
+        <a:font script="Tfng" typeface="Ebrima"/>
+      </a:majorFont>
+      <a:minorFont>
+        <a:latin typeface="Aptos" panose="02110004020202020204"/>
+        <a:ea typeface=""/>
+        <a:cs typeface=""/>
+        <a:font script="Jpan" typeface="游ゴシック"/>
+        <a:font script="Hang" typeface="맑은 고딕"/>
+        <a:font script="Hans" typeface="等线"/>
+        <a:font script="Hant" typeface="新細明體"/>
+        <a:font script="Arab" typeface="Arial"/>
+        <a:font script="Hebr" typeface="Arial"/>
+        <a:font script="Thai" typeface="Cordia New"/>
+        <a:font script="Ethi" typeface="Nyala"/>
+        <a:font script="Beng" typeface="Vrinda"/>
+        <a:font script="Gujr" typeface="Shruti"/>
+        <a:font script="Khmr" typeface="DaunPenh"/>
+        <a:font script="Knda" typeface="Tunga"/>
+        <a:font script="Guru" typeface="Raavi"/>
+        <a:font script="Cans" typeface="Euphemia"/>
+        <a:font script="Cher" typeface="Plantagenet Cherokee"/>
+        <a:font script="Yiii" typeface="Microsoft Yi Baiti"/>
+        <a:font script="Tibt" typeface="Microsoft Himalaya"/>
+        <a:font script="Thaa" typeface="MV Boli"/>
+        <a:font script="Deva" typeface="Mangal"/>
+        <a:font script="Telu" typeface="Gautami"/>
+        <a:font script="Taml" typeface="Latha"/>
+        <a:font script="Syrc" typeface="Estrangelo Edessa"/>
+        <a:font script="Orya" typeface="Kalinga"/>
+        <a:font script="Mlym" typeface="Kartika"/>
+        <a:font script="Laoo" typeface="DokChampa"/>
+        <a:font script="Sinh" typeface="Iskoola Pota"/>
+        <a:font script="Mong" typeface="Mongolian Baiti"/>
+        <a:font script="Viet" typeface="Arial"/>
+        <a:font script="Uigh" typeface="Microsoft Uighur"/>
+        <a:font script="Geor" typeface="Sylfaen"/>
+        <a:font script="Armn" typeface="Arial"/>
+        <a:font script="Bugi" typeface="Leelawadee UI"/>
+        <a:font script="Bopo" typeface="Microsoft JhengHei"/>
+        <a:font script="Java" typeface="Javanese Text"/>
+        <a:font script="Lisu" typeface="Segoe UI"/>
+        <a:font script="Mymr" typeface="Myanmar Text"/>
+        <a:font script="Nkoo" typeface="Ebrima"/>
+        <a:font script="Olck" typeface="Nirmala UI"/>
+        <a:font script="Osma" typeface="Ebrima"/>
+        <a:font script="Phag" typeface="Phagspa"/>
+        <a:font script="Syrn" typeface="Estrangelo Edessa"/>
+        <a:font script="Syrj" typeface="Estrangelo Edessa"/>
+        <a:font script="Syre" typeface="Estrangelo Edessa"/>
+        <a:font script="Sora" typeface="Nirmala UI"/>
+        <a:font script="Tale" typeface="Microsoft Tai Le"/>
+        <a:font script="Talu" typeface="Microsoft New Tai Lue"/>
+        <a:font script="Tfng" typeface="Ebrima"/>
+      </a:minorFont>
+    </a:fontScheme>
+    <a:fmtScheme name="Office">
+      <a:fillStyleLst>
+        <a:solidFill>
+          <a:schemeClr val="phClr"/>
+        </a:solidFill>
+        <a:gradFill rotWithShape="1">
+          <a:gsLst>
+            <a:gs pos="0">
+              <a:schemeClr val="phClr">
+                <a:lumMod val="110000"/>
+                <a:satMod val="105000"/>
+                <a:tint val="67000"/>
+              </a:schemeClr>
+            </a:gs>
+            <a:gs pos="50000">
+              <a:schemeClr val="phClr">
+                <a:lumMod val="105000"/>
+                <a:satMod val="103000"/>
+                <a:tint val="73000"/>
+              </a:schemeClr>
+            </a:gs>
+            <a:gs pos="100000">
+              <a:schemeClr val="phClr">
+                <a:lumMod val="105000"/>
+                <a:satMod val="109000"/>
+                <a:tint val="81000"/>
+              </a:schemeClr>
+            </a:gs>
+          </a:gsLst>
+          <a:lin ang="5400000" scaled="0"/>
+        </a:gradFill>
+        <a:gradFill rotWithShape="1">
+          <a:gsLst>
+            <a:gs pos="0">
+              <a:schemeClr val="phClr">
+                <a:satMod val="103000"/>
+                <a:lumMod val="102000"/>
+                <a:tint val="94000"/>
+              </a:schemeClr>
+            </a:gs>
+            <a:gs pos="50000">
+              <a:schemeClr val="phClr">
+                <a:satMod val="110000"/>
+                <a:lumMod val="100000"/>
+                <a:shade val="100000"/>
+              </a:schemeClr>
+            </a:gs>
+            <a:gs pos="100000">
+              <a:schemeClr val="phClr">
+                <a:lumMod val="99000"/>
+                <a:satMod val="120000"/>
+                <a:shade val="78000"/>
+              </a:schemeClr>
+            </a:gs>
+          </a:gsLst>
+          <a:lin ang="5400000" scaled="0"/>
+        </a:gradFill>
+      </a:fillStyleLst>
+      <a:lnStyleLst>
+        <a:ln w="12700" cap="flat" cmpd="sng" algn="ctr">
+          <a:solidFill>
+            <a:schemeClr val="phClr"/>
+          </a:solidFill>
+          <a:prstDash val="solid"/>
+          <a:miter lim="800000"/>
+        </a:ln>
+        <a:ln w="19050" cap="flat" cmpd="sng" algn="ctr">
+          <a:solidFill>
+            <a:schemeClr val="phClr"/>
+          </a:solidFill>
+          <a:prstDash val="solid"/>
+          <a:miter lim="800000"/>
+        </a:ln>
+        <a:ln w="25400" cap="flat" cmpd="sng" algn="ctr">
+          <a:solidFill>
+            <a:schemeClr val="phClr"/>
+          </a:solidFill>
+          <a:prstDash val="solid"/>
+          <a:miter lim="800000"/>
+        </a:ln>
+      </a:lnStyleLst>
+      <a:effectStyleLst>
+        <a:effectStyle>
+          <a:effectLst/>
+        </a:effectStyle>
+        <a:effectStyle>
+          <a:effectLst/>
+        </a:effectStyle>
+        <a:effectStyle>
+          <a:effectLst>
+            <a:outerShdw blurRad="57150" dist="19050" dir="5400000" algn="ctr" rotWithShape="0">
+              <a:srgbClr val="000000">
+                <a:alpha val="63000"/>
+              </a:srgbClr>
+            </a:outerShdw>
+          </a:effectLst>
+        </a:effectStyle>
+      </a:effectStyleLst>
+      <a:bgFillStyleLst>
+        <a:solidFill>
+          <a:schemeClr val="phClr"/>
+        </a:solidFill>
+        <a:solidFill>
+          <a:schemeClr val="phClr">
+            <a:tint val="95000"/>
+            <a:satMod val="170000"/>
+          </a:schemeClr>
+        </a:solidFill>
+        <a:gradFill rotWithShape="1">
+          <a:gsLst>
+            <a:gs pos="0">
+              <a:schemeClr val="phClr">
+                <a:tint val="93000"/>
+                <a:satMod val="150000"/>
+                <a:shade val="98000"/>
+                <a:lumMod val="102000"/>
+              </a:schemeClr>
+            </a:gs>
+            <a:gs pos="50000">
+              <a:schemeClr val="phClr">
+                <a:tint val="98000"/>
+                <a:satMod val="130000"/>
+                <a:shade val="90000"/>
+                <a:lumMod val="103000"/>
+              </a:schemeClr>
+            </a:gs>
+            <a:gs pos="100000">
+              <a:schemeClr val="phClr">
+                <a:shade val="63000"/>
+                <a:satMod val="120000"/>
+              </a:schemeClr>
+            </a:gs>
+          </a:gsLst>
+          <a:lin ang="5400000" scaled="0"/>
+        </a:gradFill>
+      </a:bgFillStyleLst>
+    </a:fmtScheme>
+  </a:themeElements>
+  <a:objectDefaults>
+    <a:lnDef>
+      <a:spPr/>
+      <a:bodyPr/>
+      <a:lstStyle/>
+      <a:style>
+        <a:lnRef idx="2">
+          <a:schemeClr val="accent1"/>
+        </a:lnRef>
+        <a:fillRef idx="0">
+          <a:schemeClr val="accent1"/>
+        </a:fillRef>
+        <a:effectRef idx="1">
+          <a:schemeClr val="accent1"/>
+        </a:effectRef>
+        <a:fontRef idx="minor">
+          <a:schemeClr val="tx1"/>
+        </a:fontRef>
+      </a:style>
+    </a:lnDef>
+  </a:objectDefaults>
+  <a:extraClrSchemeLst/>
+  <a:extLst>
+    <a:ext uri="{05A4C25C-085E-4340-85A3-A5531E510DB2}">
+      <thm15:themeFamily xmlns:thm15="http://schemas.microsoft.com/office/thememl/2012/main" name="Office Theme" id="{2E142A2C-CD16-42D6-873A-C26D2A0506FA}" vid="{1BDDFF52-6CD6-40A5-AB3C-68EB2F1E4D0A}"/>
+    </a:ext>
+  </a:extLst>
+</a:theme>
 </file>
</xml_diff>

<commit_message>
feat: update panels fig2
</commit_message>
<xml_diff>
--- a/figures/fig2/fig2.pptx
+++ b/figures/fig2/fig2.pptx
@@ -3609,7 +3609,7 @@
         <p:spPr>
           <a:xfrm>
             <a:off x="122357" y="1177138"/>
-            <a:ext cx="1544822" cy="1116000"/>
+            <a:ext cx="1116000" cy="1116000"/>
           </a:xfrm>
           <a:prstGeom prst="rect">
             <a:avLst/>
@@ -3744,8 +3744,8 @@
         </p:nvSpPr>
         <p:spPr>
           <a:xfrm>
-            <a:off x="2834084" y="1176788"/>
-            <a:ext cx="1548000" cy="1116000"/>
+            <a:off x="2834083" y="1176788"/>
+            <a:ext cx="1116000" cy="1116000"/>
           </a:xfrm>
           <a:prstGeom prst="rect">
             <a:avLst/>

</xml_diff>

<commit_message>
feat: bulk commit for notebooks and fig panels updates
</commit_message>
<xml_diff>
--- a/figures/fig2/fig2.pptx
+++ b/figures/fig2/fig2.pptx
@@ -3540,7 +3540,7 @@
         </p:nvSpPr>
         <p:spPr>
           <a:xfrm>
-            <a:off x="4580148" y="43982"/>
+            <a:off x="4628478" y="7982"/>
             <a:ext cx="1116000" cy="1116000"/>
           </a:xfrm>
           <a:prstGeom prst="rect">
@@ -3608,7 +3608,7 @@
         </p:nvSpPr>
         <p:spPr>
           <a:xfrm>
-            <a:off x="122357" y="1177138"/>
+            <a:off x="-1" y="1177714"/>
             <a:ext cx="1116000" cy="1116000"/>
           </a:xfrm>
           <a:prstGeom prst="rect">
@@ -3676,7 +3676,7 @@
         </p:nvSpPr>
         <p:spPr>
           <a:xfrm>
-            <a:off x="1694221" y="1177138"/>
+            <a:off x="1620631" y="1177714"/>
             <a:ext cx="1116000" cy="1116000"/>
           </a:xfrm>
           <a:prstGeom prst="rect">
@@ -3744,7 +3744,7 @@
         </p:nvSpPr>
         <p:spPr>
           <a:xfrm>
-            <a:off x="2834083" y="1176788"/>
+            <a:off x="2809261" y="1177364"/>
             <a:ext cx="1116000" cy="1116000"/>
           </a:xfrm>
           <a:prstGeom prst="rect">
@@ -3812,7 +3812,7 @@
         </p:nvSpPr>
         <p:spPr>
           <a:xfrm>
-            <a:off x="4580148" y="1174050"/>
+            <a:off x="4628478" y="1174626"/>
             <a:ext cx="1116000" cy="1116000"/>
           </a:xfrm>
           <a:prstGeom prst="rect">
@@ -3880,7 +3880,7 @@
         </p:nvSpPr>
         <p:spPr>
           <a:xfrm>
-            <a:off x="122358" y="2311739"/>
+            <a:off x="0" y="2348891"/>
             <a:ext cx="1548000" cy="1116000"/>
           </a:xfrm>
           <a:prstGeom prst="rect">
@@ -3948,7 +3948,7 @@
         </p:nvSpPr>
         <p:spPr>
           <a:xfrm>
-            <a:off x="1694221" y="2311739"/>
+            <a:off x="1620631" y="2348891"/>
             <a:ext cx="1116000" cy="1116193"/>
           </a:xfrm>
           <a:prstGeom prst="rect">
@@ -4016,7 +4016,7 @@
         </p:nvSpPr>
         <p:spPr>
           <a:xfrm>
-            <a:off x="1694221" y="3459672"/>
+            <a:off x="1620631" y="3527304"/>
             <a:ext cx="1116000" cy="1116000"/>
           </a:xfrm>
           <a:prstGeom prst="rect">
@@ -4084,7 +4084,7 @@
         </p:nvSpPr>
         <p:spPr>
           <a:xfrm>
-            <a:off x="2834084" y="2311739"/>
+            <a:off x="2809262" y="2348891"/>
             <a:ext cx="576000" cy="1116193"/>
           </a:xfrm>
           <a:prstGeom prst="rect">
@@ -4152,7 +4152,7 @@
         </p:nvSpPr>
         <p:spPr>
           <a:xfrm>
-            <a:off x="3430083" y="2311739"/>
+            <a:off x="3447933" y="2348891"/>
             <a:ext cx="1116000" cy="1116193"/>
           </a:xfrm>
           <a:prstGeom prst="rect">
@@ -4220,7 +4220,7 @@
         </p:nvSpPr>
         <p:spPr>
           <a:xfrm>
-            <a:off x="4580148" y="2311739"/>
+            <a:off x="4628478" y="2348891"/>
             <a:ext cx="1116000" cy="1116000"/>
           </a:xfrm>
           <a:prstGeom prst="rect">
@@ -4288,7 +4288,7 @@
         </p:nvSpPr>
         <p:spPr>
           <a:xfrm>
-            <a:off x="122358" y="3459672"/>
+            <a:off x="0" y="3527304"/>
             <a:ext cx="1548000" cy="1116000"/>
           </a:xfrm>
           <a:prstGeom prst="rect">
@@ -4356,7 +4356,7 @@
         </p:nvSpPr>
         <p:spPr>
           <a:xfrm>
-            <a:off x="3433893" y="43982"/>
+            <a:off x="3451743" y="7982"/>
             <a:ext cx="1116000" cy="1116000"/>
           </a:xfrm>
           <a:prstGeom prst="rect">
@@ -4424,7 +4424,7 @@
         </p:nvSpPr>
         <p:spPr>
           <a:xfrm>
-            <a:off x="2834084" y="39123"/>
+            <a:off x="2809262" y="3123"/>
             <a:ext cx="576000" cy="1116000"/>
           </a:xfrm>
           <a:prstGeom prst="rect">
@@ -4478,7 +4478,7 @@
         </p:nvSpPr>
         <p:spPr>
           <a:xfrm>
-            <a:off x="1694221" y="36000"/>
+            <a:off x="1620631" y="0"/>
             <a:ext cx="1116000" cy="1116000"/>
           </a:xfrm>
           <a:prstGeom prst="rect">
@@ -4532,7 +4532,7 @@
         </p:nvSpPr>
         <p:spPr>
           <a:xfrm>
-            <a:off x="122358" y="36000"/>
+            <a:off x="0" y="0"/>
             <a:ext cx="1548000" cy="1116000"/>
           </a:xfrm>
           <a:prstGeom prst="rect">
@@ -4592,7 +4592,7 @@
         </p:nvSpPr>
         <p:spPr>
           <a:xfrm>
-            <a:off x="2834083" y="3459672"/>
+            <a:off x="2809261" y="3527304"/>
             <a:ext cx="1548000" cy="1116000"/>
           </a:xfrm>
           <a:prstGeom prst="rect">
@@ -4660,7 +4660,7 @@
         </p:nvSpPr>
         <p:spPr>
           <a:xfrm>
-            <a:off x="4580148" y="3459672"/>
+            <a:off x="4597998" y="3527304"/>
             <a:ext cx="1116000" cy="1116000"/>
           </a:xfrm>
           <a:prstGeom prst="rect">

</xml_diff>

<commit_message>
feat: update panels O, Q and add first try for frame
</commit_message>
<xml_diff>
--- a/figures/fig2/fig2.pptx
+++ b/figures/fig2/fig2.pptx
@@ -208,7 +208,7 @@
           <a:p>
             <a:fld id="{2C601304-D772-4F92-A532-14E02F17E99D}" type="datetimeFigureOut">
               <a:rPr lang="en-US" smtClean="0"/>
-              <a:t>10/16/2026</a:t>
+              <a:t>10/17/2026</a:t>
             </a:fld>
             <a:endParaRPr lang="en-US"/>
           </a:p>
@@ -738,7 +738,7 @@
           <a:p>
             <a:fld id="{5BCAD085-E8A6-8845-BD4E-CB4CCA059FC4}" type="datetimeFigureOut">
               <a:rPr lang="en-US" smtClean="0"/>
-              <a:t>10/16/2026</a:t>
+              <a:t>10/17/2026</a:t>
             </a:fld>
             <a:endParaRPr lang="en-US"/>
           </a:p>
@@ -906,7 +906,7 @@
           <a:p>
             <a:fld id="{5BCAD085-E8A6-8845-BD4E-CB4CCA059FC4}" type="datetimeFigureOut">
               <a:rPr lang="en-US" smtClean="0"/>
-              <a:t>10/16/2026</a:t>
+              <a:t>10/17/2026</a:t>
             </a:fld>
             <a:endParaRPr lang="en-US"/>
           </a:p>
@@ -1084,7 +1084,7 @@
           <a:p>
             <a:fld id="{5BCAD085-E8A6-8845-BD4E-CB4CCA059FC4}" type="datetimeFigureOut">
               <a:rPr lang="en-US" smtClean="0"/>
-              <a:t>10/16/2026</a:t>
+              <a:t>10/17/2026</a:t>
             </a:fld>
             <a:endParaRPr lang="en-US"/>
           </a:p>
@@ -1252,7 +1252,7 @@
           <a:p>
             <a:fld id="{5BCAD085-E8A6-8845-BD4E-CB4CCA059FC4}" type="datetimeFigureOut">
               <a:rPr lang="en-US" smtClean="0"/>
-              <a:t>10/16/2026</a:t>
+              <a:t>10/17/2026</a:t>
             </a:fld>
             <a:endParaRPr lang="en-US"/>
           </a:p>
@@ -1497,7 +1497,7 @@
           <a:p>
             <a:fld id="{5BCAD085-E8A6-8845-BD4E-CB4CCA059FC4}" type="datetimeFigureOut">
               <a:rPr lang="en-US" smtClean="0"/>
-              <a:t>10/16/2026</a:t>
+              <a:t>10/17/2026</a:t>
             </a:fld>
             <a:endParaRPr lang="en-US"/>
           </a:p>
@@ -1782,7 +1782,7 @@
           <a:p>
             <a:fld id="{5BCAD085-E8A6-8845-BD4E-CB4CCA059FC4}" type="datetimeFigureOut">
               <a:rPr lang="en-US" smtClean="0"/>
-              <a:t>10/16/2026</a:t>
+              <a:t>10/17/2026</a:t>
             </a:fld>
             <a:endParaRPr lang="en-US"/>
           </a:p>
@@ -2201,7 +2201,7 @@
           <a:p>
             <a:fld id="{5BCAD085-E8A6-8845-BD4E-CB4CCA059FC4}" type="datetimeFigureOut">
               <a:rPr lang="en-US" smtClean="0"/>
-              <a:t>10/16/2026</a:t>
+              <a:t>10/17/2026</a:t>
             </a:fld>
             <a:endParaRPr lang="en-US"/>
           </a:p>
@@ -2318,7 +2318,7 @@
           <a:p>
             <a:fld id="{5BCAD085-E8A6-8845-BD4E-CB4CCA059FC4}" type="datetimeFigureOut">
               <a:rPr lang="en-US" smtClean="0"/>
-              <a:t>10/16/2026</a:t>
+              <a:t>10/17/2026</a:t>
             </a:fld>
             <a:endParaRPr lang="en-US"/>
           </a:p>
@@ -2413,7 +2413,7 @@
           <a:p>
             <a:fld id="{5BCAD085-E8A6-8845-BD4E-CB4CCA059FC4}" type="datetimeFigureOut">
               <a:rPr lang="en-US" smtClean="0"/>
-              <a:t>10/16/2026</a:t>
+              <a:t>10/17/2026</a:t>
             </a:fld>
             <a:endParaRPr lang="en-US"/>
           </a:p>
@@ -2688,7 +2688,7 @@
           <a:p>
             <a:fld id="{5BCAD085-E8A6-8845-BD4E-CB4CCA059FC4}" type="datetimeFigureOut">
               <a:rPr lang="en-US" smtClean="0"/>
-              <a:t>10/16/2026</a:t>
+              <a:t>10/17/2026</a:t>
             </a:fld>
             <a:endParaRPr lang="en-US"/>
           </a:p>
@@ -2940,7 +2940,7 @@
           <a:p>
             <a:fld id="{5BCAD085-E8A6-8845-BD4E-CB4CCA059FC4}" type="datetimeFigureOut">
               <a:rPr lang="en-US" smtClean="0"/>
-              <a:t>10/16/2026</a:t>
+              <a:t>10/17/2026</a:t>
             </a:fld>
             <a:endParaRPr lang="en-US"/>
           </a:p>
@@ -3151,7 +3151,7 @@
           <a:p>
             <a:fld id="{5BCAD085-E8A6-8845-BD4E-CB4CCA059FC4}" type="datetimeFigureOut">
               <a:rPr lang="en-US" smtClean="0"/>
-              <a:t>10/16/2026</a:t>
+              <a:t>10/17/2026</a:t>
             </a:fld>
             <a:endParaRPr lang="en-US"/>
           </a:p>
@@ -3526,6 +3526,116 @@
           <a:chExt cx="0" cy="0"/>
         </a:xfrm>
       </p:grpSpPr>
+      <p:sp>
+        <p:nvSpPr>
+          <p:cNvPr id="8" name="fig2_ZZ">
+            <a:extLst>
+              <a:ext uri="{FF2B5EF4-FFF2-40B4-BE49-F238E27FC236}">
+                <a16:creationId xmlns:a16="http://schemas.microsoft.com/office/drawing/2014/main" id="{4DC81660-84CE-9F87-754B-2F2332A3B29B}"/>
+              </a:ext>
+            </a:extLst>
+          </p:cNvPr>
+          <p:cNvSpPr/>
+          <p:nvPr/>
+        </p:nvSpPr>
+        <p:spPr>
+          <a:xfrm>
+            <a:off x="-42530" y="2348891"/>
+            <a:ext cx="5869172" cy="2386105"/>
+          </a:xfrm>
+          <a:prstGeom prst="rect">
+            <a:avLst/>
+          </a:prstGeom>
+          <a:solidFill>
+            <a:schemeClr val="tx1"/>
+          </a:solidFill>
+          <a:ln>
+            <a:solidFill>
+              <a:schemeClr val="tx1"/>
+            </a:solidFill>
+          </a:ln>
+        </p:spPr>
+        <p:style>
+          <a:lnRef idx="1">
+            <a:schemeClr val="accent1"/>
+          </a:lnRef>
+          <a:fillRef idx="3">
+            <a:schemeClr val="accent1"/>
+          </a:fillRef>
+          <a:effectRef idx="2">
+            <a:schemeClr val="accent1"/>
+          </a:effectRef>
+          <a:fontRef idx="minor">
+            <a:schemeClr val="lt1"/>
+          </a:fontRef>
+        </p:style>
+        <p:txBody>
+          <a:bodyPr rtlCol="0" anchor="ctr"/>
+          <a:lstStyle/>
+          <a:p>
+            <a:pPr algn="ctr"/>
+            <a:endParaRPr lang="en-US"/>
+          </a:p>
+        </p:txBody>
+      </p:sp>
+      <p:sp>
+        <p:nvSpPr>
+          <p:cNvPr id="4" name="fig2_Z">
+            <a:extLst>
+              <a:ext uri="{FF2B5EF4-FFF2-40B4-BE49-F238E27FC236}">
+                <a16:creationId xmlns:a16="http://schemas.microsoft.com/office/drawing/2014/main" id="{887714A9-A995-E5C7-0A97-B52896DEE30B}"/>
+              </a:ext>
+            </a:extLst>
+          </p:cNvPr>
+          <p:cNvSpPr/>
+          <p:nvPr/>
+        </p:nvSpPr>
+        <p:spPr>
+          <a:xfrm>
+            <a:off x="-42530" y="-37214"/>
+            <a:ext cx="5869172" cy="2386105"/>
+          </a:xfrm>
+          <a:prstGeom prst="rect">
+            <a:avLst/>
+          </a:prstGeom>
+          <a:solidFill>
+            <a:schemeClr val="tx1">
+              <a:lumMod val="50000"/>
+              <a:lumOff val="50000"/>
+            </a:schemeClr>
+          </a:solidFill>
+          <a:ln>
+            <a:solidFill>
+              <a:schemeClr val="tx1">
+                <a:lumMod val="50000"/>
+                <a:lumOff val="50000"/>
+              </a:schemeClr>
+            </a:solidFill>
+          </a:ln>
+        </p:spPr>
+        <p:style>
+          <a:lnRef idx="1">
+            <a:schemeClr val="accent1"/>
+          </a:lnRef>
+          <a:fillRef idx="3">
+            <a:schemeClr val="accent1"/>
+          </a:fillRef>
+          <a:effectRef idx="2">
+            <a:schemeClr val="accent1"/>
+          </a:effectRef>
+          <a:fontRef idx="minor">
+            <a:schemeClr val="lt1"/>
+          </a:fontRef>
+        </p:style>
+        <p:txBody>
+          <a:bodyPr rtlCol="0" anchor="ctr"/>
+          <a:lstStyle/>
+          <a:p>
+            <a:pPr algn="ctr"/>
+            <a:endParaRPr lang="en-US"/>
+          </a:p>
+        </p:txBody>
+      </p:sp>
       <p:sp>
         <p:nvSpPr>
           <p:cNvPr id="16" name="fig2_E">

</xml_diff>

<commit_message>
feat: make fig2 slightly shorter
</commit_message>
<xml_diff>
--- a/figures/fig2/fig2.pptx
+++ b/figures/fig2/fig2.pptx
@@ -3540,8 +3540,8 @@
         </p:nvSpPr>
         <p:spPr>
           <a:xfrm>
-            <a:off x="-42530" y="2348891"/>
-            <a:ext cx="5869172" cy="2386105"/>
+            <a:off x="-42530" y="2386105"/>
+            <a:ext cx="5869172" cy="2260323"/>
           </a:xfrm>
           <a:prstGeom prst="rect">
             <a:avLst/>
@@ -3990,7 +3990,7 @@
         </p:nvSpPr>
         <p:spPr>
           <a:xfrm>
-            <a:off x="0" y="2348891"/>
+            <a:off x="0" y="2508378"/>
             <a:ext cx="1548000" cy="1116000"/>
           </a:xfrm>
           <a:prstGeom prst="rect">
@@ -4058,7 +4058,7 @@
         </p:nvSpPr>
         <p:spPr>
           <a:xfrm>
-            <a:off x="1620631" y="2348891"/>
+            <a:off x="1620631" y="2508378"/>
             <a:ext cx="1116000" cy="1116193"/>
           </a:xfrm>
           <a:prstGeom prst="rect">
@@ -4126,7 +4126,211 @@
         </p:nvSpPr>
         <p:spPr>
           <a:xfrm>
-            <a:off x="1620631" y="3527304"/>
+            <a:off x="1620631" y="3686791"/>
+            <a:ext cx="1116000" cy="895840"/>
+          </a:xfrm>
+          <a:prstGeom prst="rect">
+            <a:avLst/>
+          </a:prstGeom>
+          <a:solidFill>
+            <a:srgbClr val="F5E8D0"/>
+          </a:solidFill>
+          <a:ln w="6350">
+            <a:solidFill>
+              <a:srgbClr val="808080"/>
+            </a:solidFill>
+          </a:ln>
+        </p:spPr>
+        <p:style>
+          <a:lnRef idx="1">
+            <a:schemeClr val="accent1"/>
+          </a:lnRef>
+          <a:fillRef idx="3">
+            <a:schemeClr val="accent1"/>
+          </a:fillRef>
+          <a:effectRef idx="2">
+            <a:schemeClr val="accent1"/>
+          </a:effectRef>
+          <a:fontRef idx="minor">
+            <a:schemeClr val="lt1"/>
+          </a:fontRef>
+        </p:style>
+        <p:txBody>
+          <a:bodyPr wrap="none" rtlCol="0" anchor="ctr"/>
+          <a:lstStyle/>
+          <a:p>
+            <a:pPr algn="ctr"/>
+            <a:r>
+              <a:rPr lang="en-US" sz="1000" b="1" dirty="0">
+                <a:solidFill>
+                  <a:srgbClr val="333333"/>
+                </a:solidFill>
+              </a:rPr>
+              <a:t>P
+</a:t>
+            </a:r>
+            <a:r>
+              <a:rPr sz="1000" b="1" dirty="0">
+                <a:solidFill>
+                  <a:srgbClr val="333333"/>
+                </a:solidFill>
+              </a:rPr>
+              <a:t>51×52 mm</a:t>
+            </a:r>
+          </a:p>
+        </p:txBody>
+      </p:sp>
+      <p:sp>
+        <p:nvSpPr>
+          <p:cNvPr id="32" name="fig2_L">
+            <a:extLst>
+              <a:ext uri="{FF2B5EF4-FFF2-40B4-BE49-F238E27FC236}">
+                <a16:creationId xmlns:a16="http://schemas.microsoft.com/office/drawing/2014/main" id="{4697FDE0-95F9-683B-0261-CD3656EB6C5F}"/>
+              </a:ext>
+            </a:extLst>
+          </p:cNvPr>
+          <p:cNvSpPr/>
+          <p:nvPr/>
+        </p:nvSpPr>
+        <p:spPr>
+          <a:xfrm>
+            <a:off x="2809262" y="2508378"/>
+            <a:ext cx="576000" cy="1116193"/>
+          </a:xfrm>
+          <a:prstGeom prst="rect">
+            <a:avLst/>
+          </a:prstGeom>
+          <a:solidFill>
+            <a:srgbClr val="F5E8D0"/>
+          </a:solidFill>
+          <a:ln w="6350">
+            <a:solidFill>
+              <a:srgbClr val="808080"/>
+            </a:solidFill>
+          </a:ln>
+        </p:spPr>
+        <p:style>
+          <a:lnRef idx="1">
+            <a:schemeClr val="accent1"/>
+          </a:lnRef>
+          <a:fillRef idx="3">
+            <a:schemeClr val="accent1"/>
+          </a:fillRef>
+          <a:effectRef idx="2">
+            <a:schemeClr val="accent1"/>
+          </a:effectRef>
+          <a:fontRef idx="minor">
+            <a:schemeClr val="lt1"/>
+          </a:fontRef>
+        </p:style>
+        <p:txBody>
+          <a:bodyPr wrap="none" rtlCol="0" anchor="ctr"/>
+          <a:lstStyle/>
+          <a:p>
+            <a:pPr algn="ctr"/>
+            <a:r>
+              <a:rPr lang="en-US" sz="1000" b="1" dirty="0">
+                <a:solidFill>
+                  <a:srgbClr val="333333"/>
+                </a:solidFill>
+              </a:rPr>
+              <a:t>L</a:t>
+            </a:r>
+            <a:r>
+              <a:rPr sz="1000" b="1" dirty="0">
+                <a:solidFill>
+                  <a:srgbClr val="333333"/>
+                </a:solidFill>
+              </a:rPr>
+              <a:t>
+51×52 mm</a:t>
+            </a:r>
+          </a:p>
+        </p:txBody>
+      </p:sp>
+      <p:sp>
+        <p:nvSpPr>
+          <p:cNvPr id="34" name="fig2_M">
+            <a:extLst>
+              <a:ext uri="{FF2B5EF4-FFF2-40B4-BE49-F238E27FC236}">
+                <a16:creationId xmlns:a16="http://schemas.microsoft.com/office/drawing/2014/main" id="{2DC4DE53-0BDF-CD07-C7F9-5FA97F0CDF3D}"/>
+              </a:ext>
+            </a:extLst>
+          </p:cNvPr>
+          <p:cNvSpPr/>
+          <p:nvPr/>
+        </p:nvSpPr>
+        <p:spPr>
+          <a:xfrm>
+            <a:off x="3447933" y="2508378"/>
+            <a:ext cx="1116000" cy="1116193"/>
+          </a:xfrm>
+          <a:prstGeom prst="rect">
+            <a:avLst/>
+          </a:prstGeom>
+          <a:solidFill>
+            <a:srgbClr val="F5E8D0"/>
+          </a:solidFill>
+          <a:ln w="6350">
+            <a:solidFill>
+              <a:srgbClr val="808080"/>
+            </a:solidFill>
+          </a:ln>
+        </p:spPr>
+        <p:style>
+          <a:lnRef idx="1">
+            <a:schemeClr val="accent1"/>
+          </a:lnRef>
+          <a:fillRef idx="3">
+            <a:schemeClr val="accent1"/>
+          </a:fillRef>
+          <a:effectRef idx="2">
+            <a:schemeClr val="accent1"/>
+          </a:effectRef>
+          <a:fontRef idx="minor">
+            <a:schemeClr val="lt1"/>
+          </a:fontRef>
+        </p:style>
+        <p:txBody>
+          <a:bodyPr wrap="none" rtlCol="0" anchor="ctr"/>
+          <a:lstStyle/>
+          <a:p>
+            <a:pPr algn="ctr"/>
+            <a:r>
+              <a:rPr lang="en-US" sz="1000" b="1" dirty="0">
+                <a:solidFill>
+                  <a:srgbClr val="333333"/>
+                </a:solidFill>
+              </a:rPr>
+              <a:t>M</a:t>
+            </a:r>
+            <a:r>
+              <a:rPr sz="1000" b="1" dirty="0">
+                <a:solidFill>
+                  <a:srgbClr val="333333"/>
+                </a:solidFill>
+              </a:rPr>
+              <a:t>
+51×52 mm</a:t>
+            </a:r>
+          </a:p>
+        </p:txBody>
+      </p:sp>
+      <p:sp>
+        <p:nvSpPr>
+          <p:cNvPr id="36" name="fig2_N">
+            <a:extLst>
+              <a:ext uri="{FF2B5EF4-FFF2-40B4-BE49-F238E27FC236}">
+                <a16:creationId xmlns:a16="http://schemas.microsoft.com/office/drawing/2014/main" id="{0F09EC13-CEF1-2761-6318-FDF663E79161}"/>
+              </a:ext>
+            </a:extLst>
+          </p:cNvPr>
+          <p:cNvSpPr/>
+          <p:nvPr/>
+        </p:nvSpPr>
+        <p:spPr>
+          <a:xfrm>
+            <a:off x="4628478" y="2508378"/>
             <a:ext cx="1116000" cy="1116000"/>
           </a:xfrm>
           <a:prstGeom prst="rect">
@@ -4166,210 +4370,6 @@
                   <a:srgbClr val="333333"/>
                 </a:solidFill>
               </a:rPr>
-              <a:t>P
-</a:t>
-            </a:r>
-            <a:r>
-              <a:rPr sz="1000" b="1" dirty="0">
-                <a:solidFill>
-                  <a:srgbClr val="333333"/>
-                </a:solidFill>
-              </a:rPr>
-              <a:t>51×52 mm</a:t>
-            </a:r>
-          </a:p>
-        </p:txBody>
-      </p:sp>
-      <p:sp>
-        <p:nvSpPr>
-          <p:cNvPr id="32" name="fig2_L">
-            <a:extLst>
-              <a:ext uri="{FF2B5EF4-FFF2-40B4-BE49-F238E27FC236}">
-                <a16:creationId xmlns:a16="http://schemas.microsoft.com/office/drawing/2014/main" id="{4697FDE0-95F9-683B-0261-CD3656EB6C5F}"/>
-              </a:ext>
-            </a:extLst>
-          </p:cNvPr>
-          <p:cNvSpPr/>
-          <p:nvPr/>
-        </p:nvSpPr>
-        <p:spPr>
-          <a:xfrm>
-            <a:off x="2809262" y="2348891"/>
-            <a:ext cx="576000" cy="1116193"/>
-          </a:xfrm>
-          <a:prstGeom prst="rect">
-            <a:avLst/>
-          </a:prstGeom>
-          <a:solidFill>
-            <a:srgbClr val="F5E8D0"/>
-          </a:solidFill>
-          <a:ln w="6350">
-            <a:solidFill>
-              <a:srgbClr val="808080"/>
-            </a:solidFill>
-          </a:ln>
-        </p:spPr>
-        <p:style>
-          <a:lnRef idx="1">
-            <a:schemeClr val="accent1"/>
-          </a:lnRef>
-          <a:fillRef idx="3">
-            <a:schemeClr val="accent1"/>
-          </a:fillRef>
-          <a:effectRef idx="2">
-            <a:schemeClr val="accent1"/>
-          </a:effectRef>
-          <a:fontRef idx="minor">
-            <a:schemeClr val="lt1"/>
-          </a:fontRef>
-        </p:style>
-        <p:txBody>
-          <a:bodyPr wrap="none" rtlCol="0" anchor="ctr"/>
-          <a:lstStyle/>
-          <a:p>
-            <a:pPr algn="ctr"/>
-            <a:r>
-              <a:rPr lang="en-US" sz="1000" b="1" dirty="0">
-                <a:solidFill>
-                  <a:srgbClr val="333333"/>
-                </a:solidFill>
-              </a:rPr>
-              <a:t>L</a:t>
-            </a:r>
-            <a:r>
-              <a:rPr sz="1000" b="1" dirty="0">
-                <a:solidFill>
-                  <a:srgbClr val="333333"/>
-                </a:solidFill>
-              </a:rPr>
-              <a:t>
-51×52 mm</a:t>
-            </a:r>
-          </a:p>
-        </p:txBody>
-      </p:sp>
-      <p:sp>
-        <p:nvSpPr>
-          <p:cNvPr id="34" name="fig2_M">
-            <a:extLst>
-              <a:ext uri="{FF2B5EF4-FFF2-40B4-BE49-F238E27FC236}">
-                <a16:creationId xmlns:a16="http://schemas.microsoft.com/office/drawing/2014/main" id="{2DC4DE53-0BDF-CD07-C7F9-5FA97F0CDF3D}"/>
-              </a:ext>
-            </a:extLst>
-          </p:cNvPr>
-          <p:cNvSpPr/>
-          <p:nvPr/>
-        </p:nvSpPr>
-        <p:spPr>
-          <a:xfrm>
-            <a:off x="3447933" y="2348891"/>
-            <a:ext cx="1116000" cy="1116193"/>
-          </a:xfrm>
-          <a:prstGeom prst="rect">
-            <a:avLst/>
-          </a:prstGeom>
-          <a:solidFill>
-            <a:srgbClr val="F5E8D0"/>
-          </a:solidFill>
-          <a:ln w="6350">
-            <a:solidFill>
-              <a:srgbClr val="808080"/>
-            </a:solidFill>
-          </a:ln>
-        </p:spPr>
-        <p:style>
-          <a:lnRef idx="1">
-            <a:schemeClr val="accent1"/>
-          </a:lnRef>
-          <a:fillRef idx="3">
-            <a:schemeClr val="accent1"/>
-          </a:fillRef>
-          <a:effectRef idx="2">
-            <a:schemeClr val="accent1"/>
-          </a:effectRef>
-          <a:fontRef idx="minor">
-            <a:schemeClr val="lt1"/>
-          </a:fontRef>
-        </p:style>
-        <p:txBody>
-          <a:bodyPr wrap="none" rtlCol="0" anchor="ctr"/>
-          <a:lstStyle/>
-          <a:p>
-            <a:pPr algn="ctr"/>
-            <a:r>
-              <a:rPr lang="en-US" sz="1000" b="1" dirty="0">
-                <a:solidFill>
-                  <a:srgbClr val="333333"/>
-                </a:solidFill>
-              </a:rPr>
-              <a:t>M</a:t>
-            </a:r>
-            <a:r>
-              <a:rPr sz="1000" b="1" dirty="0">
-                <a:solidFill>
-                  <a:srgbClr val="333333"/>
-                </a:solidFill>
-              </a:rPr>
-              <a:t>
-51×52 mm</a:t>
-            </a:r>
-          </a:p>
-        </p:txBody>
-      </p:sp>
-      <p:sp>
-        <p:nvSpPr>
-          <p:cNvPr id="36" name="fig2_N">
-            <a:extLst>
-              <a:ext uri="{FF2B5EF4-FFF2-40B4-BE49-F238E27FC236}">
-                <a16:creationId xmlns:a16="http://schemas.microsoft.com/office/drawing/2014/main" id="{0F09EC13-CEF1-2761-6318-FDF663E79161}"/>
-              </a:ext>
-            </a:extLst>
-          </p:cNvPr>
-          <p:cNvSpPr/>
-          <p:nvPr/>
-        </p:nvSpPr>
-        <p:spPr>
-          <a:xfrm>
-            <a:off x="4628478" y="2348891"/>
-            <a:ext cx="1116000" cy="1116000"/>
-          </a:xfrm>
-          <a:prstGeom prst="rect">
-            <a:avLst/>
-          </a:prstGeom>
-          <a:solidFill>
-            <a:srgbClr val="F5E8D0"/>
-          </a:solidFill>
-          <a:ln w="6350">
-            <a:solidFill>
-              <a:srgbClr val="808080"/>
-            </a:solidFill>
-          </a:ln>
-        </p:spPr>
-        <p:style>
-          <a:lnRef idx="1">
-            <a:schemeClr val="accent1"/>
-          </a:lnRef>
-          <a:fillRef idx="3">
-            <a:schemeClr val="accent1"/>
-          </a:fillRef>
-          <a:effectRef idx="2">
-            <a:schemeClr val="accent1"/>
-          </a:effectRef>
-          <a:fontRef idx="minor">
-            <a:schemeClr val="lt1"/>
-          </a:fontRef>
-        </p:style>
-        <p:txBody>
-          <a:bodyPr wrap="none" rtlCol="0" anchor="ctr"/>
-          <a:lstStyle/>
-          <a:p>
-            <a:pPr algn="ctr"/>
-            <a:r>
-              <a:rPr lang="en-US" sz="1000" b="1" dirty="0">
-                <a:solidFill>
-                  <a:srgbClr val="333333"/>
-                </a:solidFill>
-              </a:rPr>
               <a:t>N</a:t>
             </a:r>
             <a:r>
@@ -4398,8 +4398,8 @@
         </p:nvSpPr>
         <p:spPr>
           <a:xfrm>
-            <a:off x="0" y="3527304"/>
-            <a:ext cx="1548000" cy="1116000"/>
+            <a:off x="0" y="3686791"/>
+            <a:ext cx="1548000" cy="895840"/>
           </a:xfrm>
           <a:prstGeom prst="rect">
             <a:avLst/>
@@ -4702,8 +4702,8 @@
         </p:nvSpPr>
         <p:spPr>
           <a:xfrm>
-            <a:off x="2809261" y="3527304"/>
-            <a:ext cx="1548000" cy="1116000"/>
+            <a:off x="2809261" y="3686791"/>
+            <a:ext cx="1548000" cy="895840"/>
           </a:xfrm>
           <a:prstGeom prst="rect">
             <a:avLst/>
@@ -4770,8 +4770,8 @@
         </p:nvSpPr>
         <p:spPr>
           <a:xfrm>
-            <a:off x="4597998" y="3527304"/>
-            <a:ext cx="1116000" cy="1116000"/>
+            <a:off x="4597998" y="3686791"/>
+            <a:ext cx="1116000" cy="895840"/>
           </a:xfrm>
           <a:prstGeom prst="rect">
             <a:avLst/>

</xml_diff>

<commit_message>
feat: yet one more try at the panels for fig2
</commit_message>
<xml_diff>
--- a/figures/fig2/fig2.pptx
+++ b/figures/fig2/fig2.pptx
@@ -3718,7 +3718,7 @@
         </p:nvSpPr>
         <p:spPr>
           <a:xfrm>
-            <a:off x="-1" y="1177714"/>
+            <a:off x="216000" y="1177714"/>
             <a:ext cx="1116000" cy="1116000"/>
           </a:xfrm>
           <a:prstGeom prst="rect">
@@ -3854,7 +3854,7 @@
         </p:nvSpPr>
         <p:spPr>
           <a:xfrm>
-            <a:off x="2809261" y="1177364"/>
+            <a:off x="3097262" y="1172284"/>
             <a:ext cx="1116000" cy="1116000"/>
           </a:xfrm>
           <a:prstGeom prst="rect">
@@ -3991,7 +3991,7 @@
         <p:spPr>
           <a:xfrm>
             <a:off x="0" y="2508378"/>
-            <a:ext cx="1548000" cy="1116000"/>
+            <a:ext cx="1116000" cy="1116000"/>
           </a:xfrm>
           <a:prstGeom prst="rect">
             <a:avLst/>
@@ -4058,8 +4058,8 @@
         </p:nvSpPr>
         <p:spPr>
           <a:xfrm>
-            <a:off x="1620631" y="2508378"/>
-            <a:ext cx="1116000" cy="1116193"/>
+            <a:off x="1188631" y="2508378"/>
+            <a:ext cx="1548000" cy="1116193"/>
           </a:xfrm>
           <a:prstGeom prst="rect">
             <a:avLst/>
@@ -4588,8 +4588,8 @@
         </p:nvSpPr>
         <p:spPr>
           <a:xfrm>
-            <a:off x="1620631" y="0"/>
-            <a:ext cx="1116000" cy="1116000"/>
+            <a:off x="1176735" y="0"/>
+            <a:ext cx="1559896" cy="1116000"/>
           </a:xfrm>
           <a:prstGeom prst="rect">
             <a:avLst/>
@@ -4643,7 +4643,7 @@
         <p:spPr>
           <a:xfrm>
             <a:off x="0" y="0"/>
-            <a:ext cx="1548000" cy="1116000"/>
+            <a:ext cx="1116000" cy="1116000"/>
           </a:xfrm>
           <a:prstGeom prst="rect">
             <a:avLst/>

</xml_diff>

<commit_message>
feat: panels for fig2
</commit_message>
<xml_diff>
--- a/figures/fig2/fig2.pptx
+++ b/figures/fig2/fig2.pptx
@@ -3718,8 +3718,8 @@
         </p:nvSpPr>
         <p:spPr>
           <a:xfrm>
-            <a:off x="216000" y="1177714"/>
-            <a:ext cx="1116000" cy="1116000"/>
+            <a:off x="7251" y="1177714"/>
+            <a:ext cx="1108749" cy="1116000"/>
           </a:xfrm>
           <a:prstGeom prst="rect">
             <a:avLst/>
@@ -3854,7 +3854,7 @@
         </p:nvSpPr>
         <p:spPr>
           <a:xfrm>
-            <a:off x="3097262" y="1172284"/>
+            <a:off x="2809261" y="1172284"/>
             <a:ext cx="1116000" cy="1116000"/>
           </a:xfrm>
           <a:prstGeom prst="rect">

</xml_diff>

<commit_message>
ferat: update panels fig2
</commit_message>
<xml_diff>
--- a/figures/fig2/fig2.pptx
+++ b/figures/fig2/fig2.pptx
@@ -3540,7 +3540,7 @@
         </p:nvSpPr>
         <p:spPr>
           <a:xfrm>
-            <a:off x="-42530" y="2386105"/>
+            <a:off x="-42530" y="2274137"/>
             <a:ext cx="5869172" cy="2260323"/>
           </a:xfrm>
           <a:prstGeom prst="rect">
@@ -3593,7 +3593,7 @@
         <p:spPr>
           <a:xfrm>
             <a:off x="-42530" y="-37214"/>
-            <a:ext cx="5869172" cy="2386105"/>
+            <a:ext cx="5869172" cy="2277189"/>
           </a:xfrm>
           <a:prstGeom prst="rect">
             <a:avLst/>
@@ -3718,8 +3718,8 @@
         </p:nvSpPr>
         <p:spPr>
           <a:xfrm>
-            <a:off x="7251" y="1177714"/>
-            <a:ext cx="1108749" cy="1116000"/>
+            <a:off x="7251" y="1056411"/>
+            <a:ext cx="1559896" cy="1116000"/>
           </a:xfrm>
           <a:prstGeom prst="rect">
             <a:avLst/>
@@ -3786,7 +3786,7 @@
         </p:nvSpPr>
         <p:spPr>
           <a:xfrm>
-            <a:off x="1620631" y="1177714"/>
+            <a:off x="1620631" y="1056411"/>
             <a:ext cx="1116000" cy="1116000"/>
           </a:xfrm>
           <a:prstGeom prst="rect">
@@ -3854,7 +3854,75 @@
         </p:nvSpPr>
         <p:spPr>
           <a:xfrm>
-            <a:off x="2809261" y="1172284"/>
+            <a:off x="2809261" y="1050981"/>
+            <a:ext cx="1754672" cy="1116000"/>
+          </a:xfrm>
+          <a:prstGeom prst="rect">
+            <a:avLst/>
+          </a:prstGeom>
+          <a:solidFill>
+            <a:srgbClr val="F5E8D0"/>
+          </a:solidFill>
+          <a:ln w="6350">
+            <a:solidFill>
+              <a:srgbClr val="808080"/>
+            </a:solidFill>
+          </a:ln>
+        </p:spPr>
+        <p:style>
+          <a:lnRef idx="1">
+            <a:schemeClr val="accent1"/>
+          </a:lnRef>
+          <a:fillRef idx="3">
+            <a:schemeClr val="accent1"/>
+          </a:fillRef>
+          <a:effectRef idx="2">
+            <a:schemeClr val="accent1"/>
+          </a:effectRef>
+          <a:fontRef idx="minor">
+            <a:schemeClr val="lt1"/>
+          </a:fontRef>
+        </p:style>
+        <p:txBody>
+          <a:bodyPr wrap="none" rtlCol="0" anchor="ctr"/>
+          <a:lstStyle/>
+          <a:p>
+            <a:pPr algn="ctr"/>
+            <a:r>
+              <a:rPr lang="en-US" sz="1000" b="1" dirty="0">
+                <a:solidFill>
+                  <a:srgbClr val="333333"/>
+                </a:solidFill>
+              </a:rPr>
+              <a:t>H</a:t>
+            </a:r>
+            <a:r>
+              <a:rPr sz="1000" b="1" dirty="0">
+                <a:solidFill>
+                  <a:srgbClr val="333333"/>
+                </a:solidFill>
+              </a:rPr>
+              <a:t>
+51×52 mm</a:t>
+            </a:r>
+          </a:p>
+        </p:txBody>
+      </p:sp>
+      <p:sp>
+        <p:nvSpPr>
+          <p:cNvPr id="24" name="fig2_I">
+            <a:extLst>
+              <a:ext uri="{FF2B5EF4-FFF2-40B4-BE49-F238E27FC236}">
+                <a16:creationId xmlns:a16="http://schemas.microsoft.com/office/drawing/2014/main" id="{33FA2E5E-893D-E5AB-7CD8-9A095BA4F5B9}"/>
+              </a:ext>
+            </a:extLst>
+          </p:cNvPr>
+          <p:cNvSpPr/>
+          <p:nvPr/>
+        </p:nvSpPr>
+        <p:spPr>
+          <a:xfrm>
+            <a:off x="4628478" y="1053323"/>
             <a:ext cx="1116000" cy="1116000"/>
           </a:xfrm>
           <a:prstGeom prst="rect">
@@ -3894,7 +3962,7 @@
                   <a:srgbClr val="333333"/>
                 </a:solidFill>
               </a:rPr>
-              <a:t>H</a:t>
+              <a:t>I</a:t>
             </a:r>
             <a:r>
               <a:rPr sz="1000" b="1" dirty="0">
@@ -3910,10 +3978,10 @@
       </p:sp>
       <p:sp>
         <p:nvSpPr>
-          <p:cNvPr id="24" name="fig2_I">
+          <p:cNvPr id="26" name="fig2_J">
             <a:extLst>
               <a:ext uri="{FF2B5EF4-FFF2-40B4-BE49-F238E27FC236}">
-                <a16:creationId xmlns:a16="http://schemas.microsoft.com/office/drawing/2014/main" id="{33FA2E5E-893D-E5AB-7CD8-9A095BA4F5B9}"/>
+                <a16:creationId xmlns:a16="http://schemas.microsoft.com/office/drawing/2014/main" id="{91F3CB8E-0647-5B0A-623B-BAA61F0E536E}"/>
               </a:ext>
             </a:extLst>
           </p:cNvPr>
@@ -3922,7 +3990,7 @@
         </p:nvSpPr>
         <p:spPr>
           <a:xfrm>
-            <a:off x="4628478" y="1174626"/>
+            <a:off x="0" y="2396410"/>
             <a:ext cx="1116000" cy="1116000"/>
           </a:xfrm>
           <a:prstGeom prst="rect">
@@ -3962,7 +4030,7 @@
                   <a:srgbClr val="333333"/>
                 </a:solidFill>
               </a:rPr>
-              <a:t>I</a:t>
+              <a:t>J</a:t>
             </a:r>
             <a:r>
               <a:rPr sz="1000" b="1" dirty="0">
@@ -3978,10 +4046,10 @@
       </p:sp>
       <p:sp>
         <p:nvSpPr>
-          <p:cNvPr id="26" name="fig2_J">
+          <p:cNvPr id="28" name="fig2_K">
             <a:extLst>
               <a:ext uri="{FF2B5EF4-FFF2-40B4-BE49-F238E27FC236}">
-                <a16:creationId xmlns:a16="http://schemas.microsoft.com/office/drawing/2014/main" id="{91F3CB8E-0647-5B0A-623B-BAA61F0E536E}"/>
+                <a16:creationId xmlns:a16="http://schemas.microsoft.com/office/drawing/2014/main" id="{D7826737-5DF9-A565-B6D9-D613D4EDECCE}"/>
               </a:ext>
             </a:extLst>
           </p:cNvPr>
@@ -3990,7 +4058,279 @@
         </p:nvSpPr>
         <p:spPr>
           <a:xfrm>
-            <a:off x="0" y="2508378"/>
+            <a:off x="1188631" y="2396410"/>
+            <a:ext cx="1548000" cy="1116193"/>
+          </a:xfrm>
+          <a:prstGeom prst="rect">
+            <a:avLst/>
+          </a:prstGeom>
+          <a:solidFill>
+            <a:srgbClr val="F5E8D0"/>
+          </a:solidFill>
+          <a:ln w="6350">
+            <a:solidFill>
+              <a:srgbClr val="808080"/>
+            </a:solidFill>
+          </a:ln>
+        </p:spPr>
+        <p:style>
+          <a:lnRef idx="1">
+            <a:schemeClr val="accent1"/>
+          </a:lnRef>
+          <a:fillRef idx="3">
+            <a:schemeClr val="accent1"/>
+          </a:fillRef>
+          <a:effectRef idx="2">
+            <a:schemeClr val="accent1"/>
+          </a:effectRef>
+          <a:fontRef idx="minor">
+            <a:schemeClr val="lt1"/>
+          </a:fontRef>
+        </p:style>
+        <p:txBody>
+          <a:bodyPr wrap="none" rtlCol="0" anchor="ctr"/>
+          <a:lstStyle/>
+          <a:p>
+            <a:pPr algn="ctr"/>
+            <a:r>
+              <a:rPr lang="en-US" sz="1000" b="1" dirty="0">
+                <a:solidFill>
+                  <a:srgbClr val="333333"/>
+                </a:solidFill>
+              </a:rPr>
+              <a:t>K</a:t>
+            </a:r>
+            <a:r>
+              <a:rPr sz="1000" b="1" dirty="0">
+                <a:solidFill>
+                  <a:srgbClr val="333333"/>
+                </a:solidFill>
+              </a:rPr>
+              <a:t>
+51×52 mm</a:t>
+            </a:r>
+          </a:p>
+        </p:txBody>
+      </p:sp>
+      <p:sp>
+        <p:nvSpPr>
+          <p:cNvPr id="30" name="fig2_P">
+            <a:extLst>
+              <a:ext uri="{FF2B5EF4-FFF2-40B4-BE49-F238E27FC236}">
+                <a16:creationId xmlns:a16="http://schemas.microsoft.com/office/drawing/2014/main" id="{4B9BEAF1-E32B-18AC-71C5-7973920C7D76}"/>
+              </a:ext>
+            </a:extLst>
+          </p:cNvPr>
+          <p:cNvSpPr/>
+          <p:nvPr/>
+        </p:nvSpPr>
+        <p:spPr>
+          <a:xfrm>
+            <a:off x="1620631" y="3452257"/>
+            <a:ext cx="1116000" cy="895840"/>
+          </a:xfrm>
+          <a:prstGeom prst="rect">
+            <a:avLst/>
+          </a:prstGeom>
+          <a:solidFill>
+            <a:srgbClr val="F5E8D0"/>
+          </a:solidFill>
+          <a:ln w="6350">
+            <a:solidFill>
+              <a:srgbClr val="808080"/>
+            </a:solidFill>
+          </a:ln>
+        </p:spPr>
+        <p:style>
+          <a:lnRef idx="1">
+            <a:schemeClr val="accent1"/>
+          </a:lnRef>
+          <a:fillRef idx="3">
+            <a:schemeClr val="accent1"/>
+          </a:fillRef>
+          <a:effectRef idx="2">
+            <a:schemeClr val="accent1"/>
+          </a:effectRef>
+          <a:fontRef idx="minor">
+            <a:schemeClr val="lt1"/>
+          </a:fontRef>
+        </p:style>
+        <p:txBody>
+          <a:bodyPr wrap="none" rtlCol="0" anchor="ctr"/>
+          <a:lstStyle/>
+          <a:p>
+            <a:pPr algn="ctr"/>
+            <a:r>
+              <a:rPr lang="en-US" sz="1000" b="1" dirty="0">
+                <a:solidFill>
+                  <a:srgbClr val="333333"/>
+                </a:solidFill>
+              </a:rPr>
+              <a:t>P
+</a:t>
+            </a:r>
+            <a:r>
+              <a:rPr sz="1000" b="1" dirty="0">
+                <a:solidFill>
+                  <a:srgbClr val="333333"/>
+                </a:solidFill>
+              </a:rPr>
+              <a:t>51×52 mm</a:t>
+            </a:r>
+          </a:p>
+        </p:txBody>
+      </p:sp>
+      <p:sp>
+        <p:nvSpPr>
+          <p:cNvPr id="32" name="fig2_L">
+            <a:extLst>
+              <a:ext uri="{FF2B5EF4-FFF2-40B4-BE49-F238E27FC236}">
+                <a16:creationId xmlns:a16="http://schemas.microsoft.com/office/drawing/2014/main" id="{4697FDE0-95F9-683B-0261-CD3656EB6C5F}"/>
+              </a:ext>
+            </a:extLst>
+          </p:cNvPr>
+          <p:cNvSpPr/>
+          <p:nvPr/>
+        </p:nvSpPr>
+        <p:spPr>
+          <a:xfrm>
+            <a:off x="2809262" y="2396410"/>
+            <a:ext cx="576000" cy="1116193"/>
+          </a:xfrm>
+          <a:prstGeom prst="rect">
+            <a:avLst/>
+          </a:prstGeom>
+          <a:solidFill>
+            <a:srgbClr val="F5E8D0"/>
+          </a:solidFill>
+          <a:ln w="6350">
+            <a:solidFill>
+              <a:srgbClr val="808080"/>
+            </a:solidFill>
+          </a:ln>
+        </p:spPr>
+        <p:style>
+          <a:lnRef idx="1">
+            <a:schemeClr val="accent1"/>
+          </a:lnRef>
+          <a:fillRef idx="3">
+            <a:schemeClr val="accent1"/>
+          </a:fillRef>
+          <a:effectRef idx="2">
+            <a:schemeClr val="accent1"/>
+          </a:effectRef>
+          <a:fontRef idx="minor">
+            <a:schemeClr val="lt1"/>
+          </a:fontRef>
+        </p:style>
+        <p:txBody>
+          <a:bodyPr wrap="none" rtlCol="0" anchor="ctr"/>
+          <a:lstStyle/>
+          <a:p>
+            <a:pPr algn="ctr"/>
+            <a:r>
+              <a:rPr lang="en-US" sz="1000" b="1" dirty="0">
+                <a:solidFill>
+                  <a:srgbClr val="333333"/>
+                </a:solidFill>
+              </a:rPr>
+              <a:t>L</a:t>
+            </a:r>
+            <a:r>
+              <a:rPr sz="1000" b="1" dirty="0">
+                <a:solidFill>
+                  <a:srgbClr val="333333"/>
+                </a:solidFill>
+              </a:rPr>
+              <a:t>
+51×52 mm</a:t>
+            </a:r>
+          </a:p>
+        </p:txBody>
+      </p:sp>
+      <p:sp>
+        <p:nvSpPr>
+          <p:cNvPr id="34" name="fig2_M">
+            <a:extLst>
+              <a:ext uri="{FF2B5EF4-FFF2-40B4-BE49-F238E27FC236}">
+                <a16:creationId xmlns:a16="http://schemas.microsoft.com/office/drawing/2014/main" id="{2DC4DE53-0BDF-CD07-C7F9-5FA97F0CDF3D}"/>
+              </a:ext>
+            </a:extLst>
+          </p:cNvPr>
+          <p:cNvSpPr/>
+          <p:nvPr/>
+        </p:nvSpPr>
+        <p:spPr>
+          <a:xfrm>
+            <a:off x="3447933" y="2396410"/>
+            <a:ext cx="1116000" cy="1116193"/>
+          </a:xfrm>
+          <a:prstGeom prst="rect">
+            <a:avLst/>
+          </a:prstGeom>
+          <a:solidFill>
+            <a:srgbClr val="F5E8D0"/>
+          </a:solidFill>
+          <a:ln w="6350">
+            <a:solidFill>
+              <a:srgbClr val="808080"/>
+            </a:solidFill>
+          </a:ln>
+        </p:spPr>
+        <p:style>
+          <a:lnRef idx="1">
+            <a:schemeClr val="accent1"/>
+          </a:lnRef>
+          <a:fillRef idx="3">
+            <a:schemeClr val="accent1"/>
+          </a:fillRef>
+          <a:effectRef idx="2">
+            <a:schemeClr val="accent1"/>
+          </a:effectRef>
+          <a:fontRef idx="minor">
+            <a:schemeClr val="lt1"/>
+          </a:fontRef>
+        </p:style>
+        <p:txBody>
+          <a:bodyPr wrap="none" rtlCol="0" anchor="ctr"/>
+          <a:lstStyle/>
+          <a:p>
+            <a:pPr algn="ctr"/>
+            <a:r>
+              <a:rPr lang="en-US" sz="1000" b="1" dirty="0">
+                <a:solidFill>
+                  <a:srgbClr val="333333"/>
+                </a:solidFill>
+              </a:rPr>
+              <a:t>M</a:t>
+            </a:r>
+            <a:r>
+              <a:rPr sz="1000" b="1" dirty="0">
+                <a:solidFill>
+                  <a:srgbClr val="333333"/>
+                </a:solidFill>
+              </a:rPr>
+              <a:t>
+51×52 mm</a:t>
+            </a:r>
+          </a:p>
+        </p:txBody>
+      </p:sp>
+      <p:sp>
+        <p:nvSpPr>
+          <p:cNvPr id="36" name="fig2_N">
+            <a:extLst>
+              <a:ext uri="{FF2B5EF4-FFF2-40B4-BE49-F238E27FC236}">
+                <a16:creationId xmlns:a16="http://schemas.microsoft.com/office/drawing/2014/main" id="{0F09EC13-CEF1-2761-6318-FDF663E79161}"/>
+              </a:ext>
+            </a:extLst>
+          </p:cNvPr>
+          <p:cNvSpPr/>
+          <p:nvPr/>
+        </p:nvSpPr>
+        <p:spPr>
+          <a:xfrm>
+            <a:off x="4628478" y="2396410"/>
             <a:ext cx="1116000" cy="1116000"/>
           </a:xfrm>
           <a:prstGeom prst="rect">
@@ -4030,346 +4370,6 @@
                   <a:srgbClr val="333333"/>
                 </a:solidFill>
               </a:rPr>
-              <a:t>J</a:t>
-            </a:r>
-            <a:r>
-              <a:rPr sz="1000" b="1" dirty="0">
-                <a:solidFill>
-                  <a:srgbClr val="333333"/>
-                </a:solidFill>
-              </a:rPr>
-              <a:t>
-51×52 mm</a:t>
-            </a:r>
-          </a:p>
-        </p:txBody>
-      </p:sp>
-      <p:sp>
-        <p:nvSpPr>
-          <p:cNvPr id="28" name="fig2_K">
-            <a:extLst>
-              <a:ext uri="{FF2B5EF4-FFF2-40B4-BE49-F238E27FC236}">
-                <a16:creationId xmlns:a16="http://schemas.microsoft.com/office/drawing/2014/main" id="{D7826737-5DF9-A565-B6D9-D613D4EDECCE}"/>
-              </a:ext>
-            </a:extLst>
-          </p:cNvPr>
-          <p:cNvSpPr/>
-          <p:nvPr/>
-        </p:nvSpPr>
-        <p:spPr>
-          <a:xfrm>
-            <a:off x="1188631" y="2508378"/>
-            <a:ext cx="1548000" cy="1116193"/>
-          </a:xfrm>
-          <a:prstGeom prst="rect">
-            <a:avLst/>
-          </a:prstGeom>
-          <a:solidFill>
-            <a:srgbClr val="F5E8D0"/>
-          </a:solidFill>
-          <a:ln w="6350">
-            <a:solidFill>
-              <a:srgbClr val="808080"/>
-            </a:solidFill>
-          </a:ln>
-        </p:spPr>
-        <p:style>
-          <a:lnRef idx="1">
-            <a:schemeClr val="accent1"/>
-          </a:lnRef>
-          <a:fillRef idx="3">
-            <a:schemeClr val="accent1"/>
-          </a:fillRef>
-          <a:effectRef idx="2">
-            <a:schemeClr val="accent1"/>
-          </a:effectRef>
-          <a:fontRef idx="minor">
-            <a:schemeClr val="lt1"/>
-          </a:fontRef>
-        </p:style>
-        <p:txBody>
-          <a:bodyPr wrap="none" rtlCol="0" anchor="ctr"/>
-          <a:lstStyle/>
-          <a:p>
-            <a:pPr algn="ctr"/>
-            <a:r>
-              <a:rPr lang="en-US" sz="1000" b="1" dirty="0">
-                <a:solidFill>
-                  <a:srgbClr val="333333"/>
-                </a:solidFill>
-              </a:rPr>
-              <a:t>K</a:t>
-            </a:r>
-            <a:r>
-              <a:rPr sz="1000" b="1" dirty="0">
-                <a:solidFill>
-                  <a:srgbClr val="333333"/>
-                </a:solidFill>
-              </a:rPr>
-              <a:t>
-51×52 mm</a:t>
-            </a:r>
-          </a:p>
-        </p:txBody>
-      </p:sp>
-      <p:sp>
-        <p:nvSpPr>
-          <p:cNvPr id="30" name="fig2_P">
-            <a:extLst>
-              <a:ext uri="{FF2B5EF4-FFF2-40B4-BE49-F238E27FC236}">
-                <a16:creationId xmlns:a16="http://schemas.microsoft.com/office/drawing/2014/main" id="{4B9BEAF1-E32B-18AC-71C5-7973920C7D76}"/>
-              </a:ext>
-            </a:extLst>
-          </p:cNvPr>
-          <p:cNvSpPr/>
-          <p:nvPr/>
-        </p:nvSpPr>
-        <p:spPr>
-          <a:xfrm>
-            <a:off x="1620631" y="3610880"/>
-            <a:ext cx="1116000" cy="895840"/>
-          </a:xfrm>
-          <a:prstGeom prst="rect">
-            <a:avLst/>
-          </a:prstGeom>
-          <a:solidFill>
-            <a:srgbClr val="F5E8D0"/>
-          </a:solidFill>
-          <a:ln w="6350">
-            <a:solidFill>
-              <a:srgbClr val="808080"/>
-            </a:solidFill>
-          </a:ln>
-        </p:spPr>
-        <p:style>
-          <a:lnRef idx="1">
-            <a:schemeClr val="accent1"/>
-          </a:lnRef>
-          <a:fillRef idx="3">
-            <a:schemeClr val="accent1"/>
-          </a:fillRef>
-          <a:effectRef idx="2">
-            <a:schemeClr val="accent1"/>
-          </a:effectRef>
-          <a:fontRef idx="minor">
-            <a:schemeClr val="lt1"/>
-          </a:fontRef>
-        </p:style>
-        <p:txBody>
-          <a:bodyPr wrap="none" rtlCol="0" anchor="ctr"/>
-          <a:lstStyle/>
-          <a:p>
-            <a:pPr algn="ctr"/>
-            <a:r>
-              <a:rPr lang="en-US" sz="1000" b="1" dirty="0">
-                <a:solidFill>
-                  <a:srgbClr val="333333"/>
-                </a:solidFill>
-              </a:rPr>
-              <a:t>P
-</a:t>
-            </a:r>
-            <a:r>
-              <a:rPr sz="1000" b="1" dirty="0">
-                <a:solidFill>
-                  <a:srgbClr val="333333"/>
-                </a:solidFill>
-              </a:rPr>
-              <a:t>51×52 mm</a:t>
-            </a:r>
-          </a:p>
-        </p:txBody>
-      </p:sp>
-      <p:sp>
-        <p:nvSpPr>
-          <p:cNvPr id="32" name="fig2_L">
-            <a:extLst>
-              <a:ext uri="{FF2B5EF4-FFF2-40B4-BE49-F238E27FC236}">
-                <a16:creationId xmlns:a16="http://schemas.microsoft.com/office/drawing/2014/main" id="{4697FDE0-95F9-683B-0261-CD3656EB6C5F}"/>
-              </a:ext>
-            </a:extLst>
-          </p:cNvPr>
-          <p:cNvSpPr/>
-          <p:nvPr/>
-        </p:nvSpPr>
-        <p:spPr>
-          <a:xfrm>
-            <a:off x="2809262" y="2508378"/>
-            <a:ext cx="576000" cy="1116193"/>
-          </a:xfrm>
-          <a:prstGeom prst="rect">
-            <a:avLst/>
-          </a:prstGeom>
-          <a:solidFill>
-            <a:srgbClr val="F5E8D0"/>
-          </a:solidFill>
-          <a:ln w="6350">
-            <a:solidFill>
-              <a:srgbClr val="808080"/>
-            </a:solidFill>
-          </a:ln>
-        </p:spPr>
-        <p:style>
-          <a:lnRef idx="1">
-            <a:schemeClr val="accent1"/>
-          </a:lnRef>
-          <a:fillRef idx="3">
-            <a:schemeClr val="accent1"/>
-          </a:fillRef>
-          <a:effectRef idx="2">
-            <a:schemeClr val="accent1"/>
-          </a:effectRef>
-          <a:fontRef idx="minor">
-            <a:schemeClr val="lt1"/>
-          </a:fontRef>
-        </p:style>
-        <p:txBody>
-          <a:bodyPr wrap="none" rtlCol="0" anchor="ctr"/>
-          <a:lstStyle/>
-          <a:p>
-            <a:pPr algn="ctr"/>
-            <a:r>
-              <a:rPr lang="en-US" sz="1000" b="1" dirty="0">
-                <a:solidFill>
-                  <a:srgbClr val="333333"/>
-                </a:solidFill>
-              </a:rPr>
-              <a:t>L</a:t>
-            </a:r>
-            <a:r>
-              <a:rPr sz="1000" b="1" dirty="0">
-                <a:solidFill>
-                  <a:srgbClr val="333333"/>
-                </a:solidFill>
-              </a:rPr>
-              <a:t>
-51×52 mm</a:t>
-            </a:r>
-          </a:p>
-        </p:txBody>
-      </p:sp>
-      <p:sp>
-        <p:nvSpPr>
-          <p:cNvPr id="34" name="fig2_M">
-            <a:extLst>
-              <a:ext uri="{FF2B5EF4-FFF2-40B4-BE49-F238E27FC236}">
-                <a16:creationId xmlns:a16="http://schemas.microsoft.com/office/drawing/2014/main" id="{2DC4DE53-0BDF-CD07-C7F9-5FA97F0CDF3D}"/>
-              </a:ext>
-            </a:extLst>
-          </p:cNvPr>
-          <p:cNvSpPr/>
-          <p:nvPr/>
-        </p:nvSpPr>
-        <p:spPr>
-          <a:xfrm>
-            <a:off x="3447933" y="2508378"/>
-            <a:ext cx="1116000" cy="1116193"/>
-          </a:xfrm>
-          <a:prstGeom prst="rect">
-            <a:avLst/>
-          </a:prstGeom>
-          <a:solidFill>
-            <a:srgbClr val="F5E8D0"/>
-          </a:solidFill>
-          <a:ln w="6350">
-            <a:solidFill>
-              <a:srgbClr val="808080"/>
-            </a:solidFill>
-          </a:ln>
-        </p:spPr>
-        <p:style>
-          <a:lnRef idx="1">
-            <a:schemeClr val="accent1"/>
-          </a:lnRef>
-          <a:fillRef idx="3">
-            <a:schemeClr val="accent1"/>
-          </a:fillRef>
-          <a:effectRef idx="2">
-            <a:schemeClr val="accent1"/>
-          </a:effectRef>
-          <a:fontRef idx="minor">
-            <a:schemeClr val="lt1"/>
-          </a:fontRef>
-        </p:style>
-        <p:txBody>
-          <a:bodyPr wrap="none" rtlCol="0" anchor="ctr"/>
-          <a:lstStyle/>
-          <a:p>
-            <a:pPr algn="ctr"/>
-            <a:r>
-              <a:rPr lang="en-US" sz="1000" b="1" dirty="0">
-                <a:solidFill>
-                  <a:srgbClr val="333333"/>
-                </a:solidFill>
-              </a:rPr>
-              <a:t>M</a:t>
-            </a:r>
-            <a:r>
-              <a:rPr sz="1000" b="1" dirty="0">
-                <a:solidFill>
-                  <a:srgbClr val="333333"/>
-                </a:solidFill>
-              </a:rPr>
-              <a:t>
-51×52 mm</a:t>
-            </a:r>
-          </a:p>
-        </p:txBody>
-      </p:sp>
-      <p:sp>
-        <p:nvSpPr>
-          <p:cNvPr id="36" name="fig2_N">
-            <a:extLst>
-              <a:ext uri="{FF2B5EF4-FFF2-40B4-BE49-F238E27FC236}">
-                <a16:creationId xmlns:a16="http://schemas.microsoft.com/office/drawing/2014/main" id="{0F09EC13-CEF1-2761-6318-FDF663E79161}"/>
-              </a:ext>
-            </a:extLst>
-          </p:cNvPr>
-          <p:cNvSpPr/>
-          <p:nvPr/>
-        </p:nvSpPr>
-        <p:spPr>
-          <a:xfrm>
-            <a:off x="4628478" y="2508378"/>
-            <a:ext cx="1116000" cy="1116000"/>
-          </a:xfrm>
-          <a:prstGeom prst="rect">
-            <a:avLst/>
-          </a:prstGeom>
-          <a:solidFill>
-            <a:srgbClr val="F5E8D0"/>
-          </a:solidFill>
-          <a:ln w="6350">
-            <a:solidFill>
-              <a:srgbClr val="808080"/>
-            </a:solidFill>
-          </a:ln>
-        </p:spPr>
-        <p:style>
-          <a:lnRef idx="1">
-            <a:schemeClr val="accent1"/>
-          </a:lnRef>
-          <a:fillRef idx="3">
-            <a:schemeClr val="accent1"/>
-          </a:fillRef>
-          <a:effectRef idx="2">
-            <a:schemeClr val="accent1"/>
-          </a:effectRef>
-          <a:fontRef idx="minor">
-            <a:schemeClr val="lt1"/>
-          </a:fontRef>
-        </p:style>
-        <p:txBody>
-          <a:bodyPr wrap="none" rtlCol="0" anchor="ctr"/>
-          <a:lstStyle/>
-          <a:p>
-            <a:pPr algn="ctr"/>
-            <a:r>
-              <a:rPr lang="en-US" sz="1000" b="1" dirty="0">
-                <a:solidFill>
-                  <a:srgbClr val="333333"/>
-                </a:solidFill>
-              </a:rPr>
               <a:t>N</a:t>
             </a:r>
             <a:r>
@@ -4398,7 +4398,7 @@
         </p:nvSpPr>
         <p:spPr>
           <a:xfrm>
-            <a:off x="0" y="3615528"/>
+            <a:off x="0" y="3456905"/>
             <a:ext cx="1548000" cy="809152"/>
           </a:xfrm>
           <a:prstGeom prst="rect">
@@ -4702,7 +4702,7 @@
         </p:nvSpPr>
         <p:spPr>
           <a:xfrm>
-            <a:off x="2809262" y="3615528"/>
+            <a:off x="2809262" y="3456905"/>
             <a:ext cx="1548000" cy="809152"/>
           </a:xfrm>
           <a:prstGeom prst="rect">
@@ -4770,7 +4770,7 @@
         </p:nvSpPr>
         <p:spPr>
           <a:xfrm>
-            <a:off x="4624854" y="3610880"/>
+            <a:off x="4624854" y="3452257"/>
             <a:ext cx="1116000" cy="895840"/>
           </a:xfrm>
           <a:prstGeom prst="rect">

</xml_diff>

<commit_message>
change fig 2 and fig3
</commit_message>
<xml_diff>
--- a/figures/fig2/fig2.pptx
+++ b/figures/fig2/fig2.pptx
@@ -10,7 +10,7 @@
   <p:sldIdLst>
     <p:sldId id="256" r:id="rId2"/>
   </p:sldIdLst>
-  <p:sldSz cx="5940425" cy="8135938"/>
+  <p:sldSz cx="7272338" cy="8135938"/>
   <p:notesSz cx="6858000" cy="9144000"/>
   <p:defaultTextStyle>
     <a:defPPr>
@@ -110,12 +110,12 @@
   <p:extLst>
     <p:ext uri="{EFAFB233-063F-42B5-8137-9DF3F51BA10A}">
       <p15:sldGuideLst xmlns:p15="http://schemas.microsoft.com/office/powerpoint/2012/main">
-        <p15:guide id="1" orient="horz" pos="2160">
+        <p15:guide id="1" orient="horz" pos="2160" userDrawn="1">
           <p15:clr>
             <a:srgbClr val="A4A3A4"/>
           </p15:clr>
         </p15:guide>
-        <p15:guide id="2" pos="2880">
+        <p15:guide id="2" pos="3526" userDrawn="1">
           <p15:clr>
             <a:srgbClr val="A4A3A4"/>
           </p15:clr>
@@ -226,8 +226,8 @@
         </p:nvSpPr>
         <p:spPr>
           <a:xfrm>
-            <a:off x="2301875" y="1143000"/>
-            <a:ext cx="2254250" cy="3086100"/>
+            <a:off x="2051050" y="1143000"/>
+            <a:ext cx="2755900" cy="3086100"/>
           </a:xfrm>
           <a:prstGeom prst="rect">
             <a:avLst/>
@@ -502,7 +502,12 @@
             <p:ph type="sldImg"/>
           </p:nvPr>
         </p:nvSpPr>
-        <p:spPr/>
+        <p:spPr>
+          <a:xfrm>
+            <a:off x="2051050" y="1143000"/>
+            <a:ext cx="2755900" cy="3086100"/>
+          </a:xfrm>
+        </p:spPr>
       </p:sp>
       <p:sp>
         <p:nvSpPr>
@@ -588,8 +593,8 @@
         </p:nvSpPr>
         <p:spPr>
           <a:xfrm>
-            <a:off x="685800" y="2130425"/>
-            <a:ext cx="7772400" cy="1470025"/>
+            <a:off x="839565" y="2130426"/>
+            <a:ext cx="9515063" cy="1470025"/>
           </a:xfrm>
         </p:spPr>
         <p:txBody>
@@ -615,8 +620,8 @@
         </p:nvSpPr>
         <p:spPr>
           <a:xfrm>
-            <a:off x="1371600" y="3886200"/>
-            <a:ext cx="6400800" cy="1752600"/>
+            <a:off x="1679129" y="3886200"/>
+            <a:ext cx="7835934" cy="1752600"/>
           </a:xfrm>
         </p:spPr>
         <p:txBody>
@@ -632,7 +637,7 @@
                 </a:solidFill>
               </a:defRPr>
             </a:lvl1pPr>
-            <a:lvl2pPr marL="457200" indent="0" algn="ctr">
+            <a:lvl2pPr marL="559704" indent="0" algn="ctr">
               <a:buNone/>
               <a:defRPr>
                 <a:solidFill>
@@ -642,7 +647,7 @@
                 </a:solidFill>
               </a:defRPr>
             </a:lvl2pPr>
-            <a:lvl3pPr marL="914400" indent="0" algn="ctr">
+            <a:lvl3pPr marL="1119408" indent="0" algn="ctr">
               <a:buNone/>
               <a:defRPr>
                 <a:solidFill>
@@ -652,7 +657,7 @@
                 </a:solidFill>
               </a:defRPr>
             </a:lvl3pPr>
-            <a:lvl4pPr marL="1371600" indent="0" algn="ctr">
+            <a:lvl4pPr marL="1679113" indent="0" algn="ctr">
               <a:buNone/>
               <a:defRPr>
                 <a:solidFill>
@@ -662,7 +667,7 @@
                 </a:solidFill>
               </a:defRPr>
             </a:lvl4pPr>
-            <a:lvl5pPr marL="1828800" indent="0" algn="ctr">
+            <a:lvl5pPr marL="2238817" indent="0" algn="ctr">
               <a:buNone/>
               <a:defRPr>
                 <a:solidFill>
@@ -672,7 +677,7 @@
                 </a:solidFill>
               </a:defRPr>
             </a:lvl5pPr>
-            <a:lvl6pPr marL="2286000" indent="0" algn="ctr">
+            <a:lvl6pPr marL="2798521" indent="0" algn="ctr">
               <a:buNone/>
               <a:defRPr>
                 <a:solidFill>
@@ -682,7 +687,7 @@
                 </a:solidFill>
               </a:defRPr>
             </a:lvl6pPr>
-            <a:lvl7pPr marL="2743200" indent="0" algn="ctr">
+            <a:lvl7pPr marL="3358225" indent="0" algn="ctr">
               <a:buNone/>
               <a:defRPr>
                 <a:solidFill>
@@ -692,7 +697,7 @@
                 </a:solidFill>
               </a:defRPr>
             </a:lvl7pPr>
-            <a:lvl8pPr marL="3200400" indent="0" algn="ctr">
+            <a:lvl8pPr marL="3917930" indent="0" algn="ctr">
               <a:buNone/>
               <a:defRPr>
                 <a:solidFill>
@@ -702,7 +707,7 @@
                 </a:solidFill>
               </a:defRPr>
             </a:lvl8pPr>
-            <a:lvl9pPr marL="3657600" indent="0" algn="ctr">
+            <a:lvl9pPr marL="4477634" indent="0" algn="ctr">
               <a:buNone/>
               <a:defRPr>
                 <a:solidFill>
@@ -996,8 +1001,8 @@
         </p:nvSpPr>
         <p:spPr>
           <a:xfrm>
-            <a:off x="6629400" y="274638"/>
-            <a:ext cx="2057400" cy="5851525"/>
+            <a:off x="8115789" y="274639"/>
+            <a:ext cx="2518693" cy="5851525"/>
           </a:xfrm>
         </p:spPr>
         <p:txBody>
@@ -1023,8 +1028,8 @@
         </p:nvSpPr>
         <p:spPr>
           <a:xfrm>
-            <a:off x="457200" y="274638"/>
-            <a:ext cx="6019800" cy="5851525"/>
+            <a:off x="559710" y="274639"/>
+            <a:ext cx="7369510" cy="5851525"/>
           </a:xfrm>
         </p:spPr>
         <p:txBody>
@@ -1342,15 +1347,15 @@
         </p:nvSpPr>
         <p:spPr>
           <a:xfrm>
-            <a:off x="722313" y="4406900"/>
-            <a:ext cx="7772400" cy="1362075"/>
+            <a:off x="884264" y="4406901"/>
+            <a:ext cx="9515063" cy="1362075"/>
           </a:xfrm>
         </p:spPr>
         <p:txBody>
           <a:bodyPr anchor="t"/>
           <a:lstStyle>
             <a:lvl1pPr algn="l">
-              <a:defRPr sz="4000" b="1" cap="all"/>
+              <a:defRPr sz="4897" b="1" cap="all"/>
             </a:lvl1pPr>
           </a:lstStyle>
           <a:p>
@@ -1373,8 +1378,8 @@
         </p:nvSpPr>
         <p:spPr>
           <a:xfrm>
-            <a:off x="722313" y="2906713"/>
-            <a:ext cx="7772400" cy="1500187"/>
+            <a:off x="884264" y="2906714"/>
+            <a:ext cx="9515063" cy="1500187"/>
           </a:xfrm>
         </p:spPr>
         <p:txBody>
@@ -1382,7 +1387,7 @@
           <a:lstStyle>
             <a:lvl1pPr marL="0" indent="0">
               <a:buNone/>
-              <a:defRPr sz="2000">
+              <a:defRPr sz="2448">
                 <a:solidFill>
                   <a:schemeClr val="tx1">
                     <a:tint val="75000"/>
@@ -1390,9 +1395,9 @@
                 </a:solidFill>
               </a:defRPr>
             </a:lvl1pPr>
-            <a:lvl2pPr marL="457200" indent="0">
-              <a:buNone/>
-              <a:defRPr sz="1800">
+            <a:lvl2pPr marL="559704" indent="0">
+              <a:buNone/>
+              <a:defRPr sz="2204">
                 <a:solidFill>
                   <a:schemeClr val="tx1">
                     <a:tint val="75000"/>
@@ -1400,9 +1405,9 @@
                 </a:solidFill>
               </a:defRPr>
             </a:lvl2pPr>
-            <a:lvl3pPr marL="914400" indent="0">
-              <a:buNone/>
-              <a:defRPr sz="1600">
+            <a:lvl3pPr marL="1119408" indent="0">
+              <a:buNone/>
+              <a:defRPr sz="1959">
                 <a:solidFill>
                   <a:schemeClr val="tx1">
                     <a:tint val="75000"/>
@@ -1410,9 +1415,9 @@
                 </a:solidFill>
               </a:defRPr>
             </a:lvl3pPr>
-            <a:lvl4pPr marL="1371600" indent="0">
-              <a:buNone/>
-              <a:defRPr sz="1400">
+            <a:lvl4pPr marL="1679113" indent="0">
+              <a:buNone/>
+              <a:defRPr sz="1714">
                 <a:solidFill>
                   <a:schemeClr val="tx1">
                     <a:tint val="75000"/>
@@ -1420,9 +1425,9 @@
                 </a:solidFill>
               </a:defRPr>
             </a:lvl4pPr>
-            <a:lvl5pPr marL="1828800" indent="0">
-              <a:buNone/>
-              <a:defRPr sz="1400">
+            <a:lvl5pPr marL="2238817" indent="0">
+              <a:buNone/>
+              <a:defRPr sz="1714">
                 <a:solidFill>
                   <a:schemeClr val="tx1">
                     <a:tint val="75000"/>
@@ -1430,9 +1435,9 @@
                 </a:solidFill>
               </a:defRPr>
             </a:lvl5pPr>
-            <a:lvl6pPr marL="2286000" indent="0">
-              <a:buNone/>
-              <a:defRPr sz="1400">
+            <a:lvl6pPr marL="2798521" indent="0">
+              <a:buNone/>
+              <a:defRPr sz="1714">
                 <a:solidFill>
                   <a:schemeClr val="tx1">
                     <a:tint val="75000"/>
@@ -1440,9 +1445,9 @@
                 </a:solidFill>
               </a:defRPr>
             </a:lvl6pPr>
-            <a:lvl7pPr marL="2743200" indent="0">
-              <a:buNone/>
-              <a:defRPr sz="1400">
+            <a:lvl7pPr marL="3358225" indent="0">
+              <a:buNone/>
+              <a:defRPr sz="1714">
                 <a:solidFill>
                   <a:schemeClr val="tx1">
                     <a:tint val="75000"/>
@@ -1450,9 +1455,9 @@
                 </a:solidFill>
               </a:defRPr>
             </a:lvl7pPr>
-            <a:lvl8pPr marL="3200400" indent="0">
-              <a:buNone/>
-              <a:defRPr sz="1400">
+            <a:lvl8pPr marL="3917930" indent="0">
+              <a:buNone/>
+              <a:defRPr sz="1714">
                 <a:solidFill>
                   <a:schemeClr val="tx1">
                     <a:tint val="75000"/>
@@ -1460,9 +1465,9 @@
                 </a:solidFill>
               </a:defRPr>
             </a:lvl8pPr>
-            <a:lvl9pPr marL="3657600" indent="0">
-              <a:buNone/>
-              <a:defRPr sz="1400">
+            <a:lvl9pPr marL="4477634" indent="0">
+              <a:buNone/>
+              <a:defRPr sz="1714">
                 <a:solidFill>
                   <a:schemeClr val="tx1">
                     <a:tint val="75000"/>
@@ -1609,39 +1614,39 @@
         </p:nvSpPr>
         <p:spPr>
           <a:xfrm>
-            <a:off x="457200" y="1600200"/>
-            <a:ext cx="4038600" cy="4525963"/>
+            <a:off x="559709" y="1600201"/>
+            <a:ext cx="4944102" cy="4525963"/>
           </a:xfrm>
         </p:spPr>
         <p:txBody>
           <a:bodyPr/>
           <a:lstStyle>
             <a:lvl1pPr>
-              <a:defRPr sz="2800"/>
+              <a:defRPr sz="3428"/>
             </a:lvl1pPr>
             <a:lvl2pPr>
-              <a:defRPr sz="2400"/>
+              <a:defRPr sz="2938"/>
             </a:lvl2pPr>
             <a:lvl3pPr>
-              <a:defRPr sz="2000"/>
+              <a:defRPr sz="2448"/>
             </a:lvl3pPr>
             <a:lvl4pPr>
-              <a:defRPr sz="1800"/>
+              <a:defRPr sz="2204"/>
             </a:lvl4pPr>
             <a:lvl5pPr>
-              <a:defRPr sz="1800"/>
+              <a:defRPr sz="2204"/>
             </a:lvl5pPr>
             <a:lvl6pPr>
-              <a:defRPr sz="1800"/>
+              <a:defRPr sz="2204"/>
             </a:lvl6pPr>
             <a:lvl7pPr>
-              <a:defRPr sz="1800"/>
+              <a:defRPr sz="2204"/>
             </a:lvl7pPr>
             <a:lvl8pPr>
-              <a:defRPr sz="1800"/>
+              <a:defRPr sz="2204"/>
             </a:lvl8pPr>
             <a:lvl9pPr>
-              <a:defRPr sz="1800"/>
+              <a:defRPr sz="2204"/>
             </a:lvl9pPr>
           </a:lstStyle>
           <a:p>
@@ -1693,39 +1698,39 @@
         </p:nvSpPr>
         <p:spPr>
           <a:xfrm>
-            <a:off x="4648200" y="1600200"/>
-            <a:ext cx="4038600" cy="4525963"/>
+            <a:off x="5690381" y="1600201"/>
+            <a:ext cx="4944102" cy="4525963"/>
           </a:xfrm>
         </p:spPr>
         <p:txBody>
           <a:bodyPr/>
           <a:lstStyle>
             <a:lvl1pPr>
-              <a:defRPr sz="2800"/>
+              <a:defRPr sz="3428"/>
             </a:lvl1pPr>
             <a:lvl2pPr>
-              <a:defRPr sz="2400"/>
+              <a:defRPr sz="2938"/>
             </a:lvl2pPr>
             <a:lvl3pPr>
-              <a:defRPr sz="2000"/>
+              <a:defRPr sz="2448"/>
             </a:lvl3pPr>
             <a:lvl4pPr>
-              <a:defRPr sz="1800"/>
+              <a:defRPr sz="2204"/>
             </a:lvl4pPr>
             <a:lvl5pPr>
-              <a:defRPr sz="1800"/>
+              <a:defRPr sz="2204"/>
             </a:lvl5pPr>
             <a:lvl6pPr>
-              <a:defRPr sz="1800"/>
+              <a:defRPr sz="2204"/>
             </a:lvl6pPr>
             <a:lvl7pPr>
-              <a:defRPr sz="1800"/>
+              <a:defRPr sz="2204"/>
             </a:lvl7pPr>
             <a:lvl8pPr>
-              <a:defRPr sz="1800"/>
+              <a:defRPr sz="2204"/>
             </a:lvl8pPr>
             <a:lvl9pPr>
-              <a:defRPr sz="1800"/>
+              <a:defRPr sz="2204"/>
             </a:lvl9pPr>
           </a:lstStyle>
           <a:p>
@@ -1898,8 +1903,8 @@
         </p:nvSpPr>
         <p:spPr>
           <a:xfrm>
-            <a:off x="457200" y="1535113"/>
-            <a:ext cx="4040188" cy="639762"/>
+            <a:off x="559709" y="1535113"/>
+            <a:ext cx="4946046" cy="639762"/>
           </a:xfrm>
         </p:spPr>
         <p:txBody>
@@ -1907,39 +1912,39 @@
           <a:lstStyle>
             <a:lvl1pPr marL="0" indent="0">
               <a:buNone/>
-              <a:defRPr sz="2400" b="1"/>
+              <a:defRPr sz="2938" b="1"/>
             </a:lvl1pPr>
-            <a:lvl2pPr marL="457200" indent="0">
-              <a:buNone/>
-              <a:defRPr sz="2000" b="1"/>
+            <a:lvl2pPr marL="559704" indent="0">
+              <a:buNone/>
+              <a:defRPr sz="2448" b="1"/>
             </a:lvl2pPr>
-            <a:lvl3pPr marL="914400" indent="0">
-              <a:buNone/>
-              <a:defRPr sz="1800" b="1"/>
+            <a:lvl3pPr marL="1119408" indent="0">
+              <a:buNone/>
+              <a:defRPr sz="2204" b="1"/>
             </a:lvl3pPr>
-            <a:lvl4pPr marL="1371600" indent="0">
-              <a:buNone/>
-              <a:defRPr sz="1600" b="1"/>
+            <a:lvl4pPr marL="1679113" indent="0">
+              <a:buNone/>
+              <a:defRPr sz="1959" b="1"/>
             </a:lvl4pPr>
-            <a:lvl5pPr marL="1828800" indent="0">
-              <a:buNone/>
-              <a:defRPr sz="1600" b="1"/>
+            <a:lvl5pPr marL="2238817" indent="0">
+              <a:buNone/>
+              <a:defRPr sz="1959" b="1"/>
             </a:lvl5pPr>
-            <a:lvl6pPr marL="2286000" indent="0">
-              <a:buNone/>
-              <a:defRPr sz="1600" b="1"/>
+            <a:lvl6pPr marL="2798521" indent="0">
+              <a:buNone/>
+              <a:defRPr sz="1959" b="1"/>
             </a:lvl6pPr>
-            <a:lvl7pPr marL="2743200" indent="0">
-              <a:buNone/>
-              <a:defRPr sz="1600" b="1"/>
+            <a:lvl7pPr marL="3358225" indent="0">
+              <a:buNone/>
+              <a:defRPr sz="1959" b="1"/>
             </a:lvl7pPr>
-            <a:lvl8pPr marL="3200400" indent="0">
-              <a:buNone/>
-              <a:defRPr sz="1600" b="1"/>
+            <a:lvl8pPr marL="3917930" indent="0">
+              <a:buNone/>
+              <a:defRPr sz="1959" b="1"/>
             </a:lvl8pPr>
-            <a:lvl9pPr marL="3657600" indent="0">
-              <a:buNone/>
-              <a:defRPr sz="1600" b="1"/>
+            <a:lvl9pPr marL="4477634" indent="0">
+              <a:buNone/>
+              <a:defRPr sz="1959" b="1"/>
             </a:lvl9pPr>
           </a:lstStyle>
           <a:p>
@@ -1963,39 +1968,39 @@
         </p:nvSpPr>
         <p:spPr>
           <a:xfrm>
-            <a:off x="457200" y="2174875"/>
-            <a:ext cx="4040188" cy="3951288"/>
+            <a:off x="559709" y="2174875"/>
+            <a:ext cx="4946046" cy="3951288"/>
           </a:xfrm>
         </p:spPr>
         <p:txBody>
           <a:bodyPr/>
           <a:lstStyle>
             <a:lvl1pPr>
-              <a:defRPr sz="2400"/>
+              <a:defRPr sz="2938"/>
             </a:lvl1pPr>
             <a:lvl2pPr>
-              <a:defRPr sz="2000"/>
+              <a:defRPr sz="2448"/>
             </a:lvl2pPr>
             <a:lvl3pPr>
-              <a:defRPr sz="1800"/>
+              <a:defRPr sz="2204"/>
             </a:lvl3pPr>
             <a:lvl4pPr>
-              <a:defRPr sz="1600"/>
+              <a:defRPr sz="1959"/>
             </a:lvl4pPr>
             <a:lvl5pPr>
-              <a:defRPr sz="1600"/>
+              <a:defRPr sz="1959"/>
             </a:lvl5pPr>
             <a:lvl6pPr>
-              <a:defRPr sz="1600"/>
+              <a:defRPr sz="1959"/>
             </a:lvl6pPr>
             <a:lvl7pPr>
-              <a:defRPr sz="1600"/>
+              <a:defRPr sz="1959"/>
             </a:lvl7pPr>
             <a:lvl8pPr>
-              <a:defRPr sz="1600"/>
+              <a:defRPr sz="1959"/>
             </a:lvl8pPr>
             <a:lvl9pPr>
-              <a:defRPr sz="1600"/>
+              <a:defRPr sz="1959"/>
             </a:lvl9pPr>
           </a:lstStyle>
           <a:p>
@@ -2047,8 +2052,8 @@
         </p:nvSpPr>
         <p:spPr>
           <a:xfrm>
-            <a:off x="4645025" y="1535113"/>
-            <a:ext cx="4041775" cy="639762"/>
+            <a:off x="5686495" y="1535113"/>
+            <a:ext cx="4947988" cy="639762"/>
           </a:xfrm>
         </p:spPr>
         <p:txBody>
@@ -2056,39 +2061,39 @@
           <a:lstStyle>
             <a:lvl1pPr marL="0" indent="0">
               <a:buNone/>
-              <a:defRPr sz="2400" b="1"/>
+              <a:defRPr sz="2938" b="1"/>
             </a:lvl1pPr>
-            <a:lvl2pPr marL="457200" indent="0">
-              <a:buNone/>
-              <a:defRPr sz="2000" b="1"/>
+            <a:lvl2pPr marL="559704" indent="0">
+              <a:buNone/>
+              <a:defRPr sz="2448" b="1"/>
             </a:lvl2pPr>
-            <a:lvl3pPr marL="914400" indent="0">
-              <a:buNone/>
-              <a:defRPr sz="1800" b="1"/>
+            <a:lvl3pPr marL="1119408" indent="0">
+              <a:buNone/>
+              <a:defRPr sz="2204" b="1"/>
             </a:lvl3pPr>
-            <a:lvl4pPr marL="1371600" indent="0">
-              <a:buNone/>
-              <a:defRPr sz="1600" b="1"/>
+            <a:lvl4pPr marL="1679113" indent="0">
+              <a:buNone/>
+              <a:defRPr sz="1959" b="1"/>
             </a:lvl4pPr>
-            <a:lvl5pPr marL="1828800" indent="0">
-              <a:buNone/>
-              <a:defRPr sz="1600" b="1"/>
+            <a:lvl5pPr marL="2238817" indent="0">
+              <a:buNone/>
+              <a:defRPr sz="1959" b="1"/>
             </a:lvl5pPr>
-            <a:lvl6pPr marL="2286000" indent="0">
-              <a:buNone/>
-              <a:defRPr sz="1600" b="1"/>
+            <a:lvl6pPr marL="2798521" indent="0">
+              <a:buNone/>
+              <a:defRPr sz="1959" b="1"/>
             </a:lvl6pPr>
-            <a:lvl7pPr marL="2743200" indent="0">
-              <a:buNone/>
-              <a:defRPr sz="1600" b="1"/>
+            <a:lvl7pPr marL="3358225" indent="0">
+              <a:buNone/>
+              <a:defRPr sz="1959" b="1"/>
             </a:lvl7pPr>
-            <a:lvl8pPr marL="3200400" indent="0">
-              <a:buNone/>
-              <a:defRPr sz="1600" b="1"/>
+            <a:lvl8pPr marL="3917930" indent="0">
+              <a:buNone/>
+              <a:defRPr sz="1959" b="1"/>
             </a:lvl8pPr>
-            <a:lvl9pPr marL="3657600" indent="0">
-              <a:buNone/>
-              <a:defRPr sz="1600" b="1"/>
+            <a:lvl9pPr marL="4477634" indent="0">
+              <a:buNone/>
+              <a:defRPr sz="1959" b="1"/>
             </a:lvl9pPr>
           </a:lstStyle>
           <a:p>
@@ -2112,39 +2117,39 @@
         </p:nvSpPr>
         <p:spPr>
           <a:xfrm>
-            <a:off x="4645025" y="2174875"/>
-            <a:ext cx="4041775" cy="3951288"/>
+            <a:off x="5686495" y="2174875"/>
+            <a:ext cx="4947988" cy="3951288"/>
           </a:xfrm>
         </p:spPr>
         <p:txBody>
           <a:bodyPr/>
           <a:lstStyle>
             <a:lvl1pPr>
-              <a:defRPr sz="2400"/>
+              <a:defRPr sz="2938"/>
             </a:lvl1pPr>
             <a:lvl2pPr>
-              <a:defRPr sz="2000"/>
+              <a:defRPr sz="2448"/>
             </a:lvl2pPr>
             <a:lvl3pPr>
-              <a:defRPr sz="1800"/>
+              <a:defRPr sz="2204"/>
             </a:lvl3pPr>
             <a:lvl4pPr>
-              <a:defRPr sz="1600"/>
+              <a:defRPr sz="1959"/>
             </a:lvl4pPr>
             <a:lvl5pPr>
-              <a:defRPr sz="1600"/>
+              <a:defRPr sz="1959"/>
             </a:lvl5pPr>
             <a:lvl6pPr>
-              <a:defRPr sz="1600"/>
+              <a:defRPr sz="1959"/>
             </a:lvl6pPr>
             <a:lvl7pPr>
-              <a:defRPr sz="1600"/>
+              <a:defRPr sz="1959"/>
             </a:lvl7pPr>
             <a:lvl8pPr>
-              <a:defRPr sz="1600"/>
+              <a:defRPr sz="1959"/>
             </a:lvl8pPr>
             <a:lvl9pPr>
-              <a:defRPr sz="1600"/>
+              <a:defRPr sz="1959"/>
             </a:lvl9pPr>
           </a:lstStyle>
           <a:p>
@@ -2503,15 +2508,15 @@
         </p:nvSpPr>
         <p:spPr>
           <a:xfrm>
-            <a:off x="457200" y="273050"/>
-            <a:ext cx="3008313" cy="1162050"/>
+            <a:off x="559710" y="273050"/>
+            <a:ext cx="3682812" cy="1162050"/>
           </a:xfrm>
         </p:spPr>
         <p:txBody>
           <a:bodyPr anchor="b"/>
           <a:lstStyle>
             <a:lvl1pPr algn="l">
-              <a:defRPr sz="2000" b="1"/>
+              <a:defRPr sz="2448" b="1"/>
             </a:lvl1pPr>
           </a:lstStyle>
           <a:p>
@@ -2534,39 +2539,39 @@
         </p:nvSpPr>
         <p:spPr>
           <a:xfrm>
-            <a:off x="3575050" y="273050"/>
-            <a:ext cx="5111750" cy="5853113"/>
+            <a:off x="4376618" y="273051"/>
+            <a:ext cx="6257864" cy="5853113"/>
           </a:xfrm>
         </p:spPr>
         <p:txBody>
           <a:bodyPr/>
           <a:lstStyle>
             <a:lvl1pPr>
-              <a:defRPr sz="3200"/>
+              <a:defRPr sz="3917"/>
             </a:lvl1pPr>
             <a:lvl2pPr>
-              <a:defRPr sz="2800"/>
+              <a:defRPr sz="3428"/>
             </a:lvl2pPr>
             <a:lvl3pPr>
-              <a:defRPr sz="2400"/>
+              <a:defRPr sz="2938"/>
             </a:lvl3pPr>
             <a:lvl4pPr>
-              <a:defRPr sz="2000"/>
+              <a:defRPr sz="2448"/>
             </a:lvl4pPr>
             <a:lvl5pPr>
-              <a:defRPr sz="2000"/>
+              <a:defRPr sz="2448"/>
             </a:lvl5pPr>
             <a:lvl6pPr>
-              <a:defRPr sz="2000"/>
+              <a:defRPr sz="2448"/>
             </a:lvl6pPr>
             <a:lvl7pPr>
-              <a:defRPr sz="2000"/>
+              <a:defRPr sz="2448"/>
             </a:lvl7pPr>
             <a:lvl8pPr>
-              <a:defRPr sz="2000"/>
+              <a:defRPr sz="2448"/>
             </a:lvl8pPr>
             <a:lvl9pPr>
-              <a:defRPr sz="2000"/>
+              <a:defRPr sz="2448"/>
             </a:lvl9pPr>
           </a:lstStyle>
           <a:p>
@@ -2618,8 +2623,8 @@
         </p:nvSpPr>
         <p:spPr>
           <a:xfrm>
-            <a:off x="457200" y="1435100"/>
-            <a:ext cx="3008313" cy="4691063"/>
+            <a:off x="559710" y="1435101"/>
+            <a:ext cx="3682812" cy="4691063"/>
           </a:xfrm>
         </p:spPr>
         <p:txBody>
@@ -2627,39 +2632,39 @@
           <a:lstStyle>
             <a:lvl1pPr marL="0" indent="0">
               <a:buNone/>
-              <a:defRPr sz="1400"/>
+              <a:defRPr sz="1714"/>
             </a:lvl1pPr>
-            <a:lvl2pPr marL="457200" indent="0">
-              <a:buNone/>
-              <a:defRPr sz="1200"/>
+            <a:lvl2pPr marL="559704" indent="0">
+              <a:buNone/>
+              <a:defRPr sz="1469"/>
             </a:lvl2pPr>
-            <a:lvl3pPr marL="914400" indent="0">
-              <a:buNone/>
-              <a:defRPr sz="1000"/>
+            <a:lvl3pPr marL="1119408" indent="0">
+              <a:buNone/>
+              <a:defRPr sz="1224"/>
             </a:lvl3pPr>
-            <a:lvl4pPr marL="1371600" indent="0">
-              <a:buNone/>
-              <a:defRPr sz="900"/>
+            <a:lvl4pPr marL="1679113" indent="0">
+              <a:buNone/>
+              <a:defRPr sz="1102"/>
             </a:lvl4pPr>
-            <a:lvl5pPr marL="1828800" indent="0">
-              <a:buNone/>
-              <a:defRPr sz="900"/>
+            <a:lvl5pPr marL="2238817" indent="0">
+              <a:buNone/>
+              <a:defRPr sz="1102"/>
             </a:lvl5pPr>
-            <a:lvl6pPr marL="2286000" indent="0">
-              <a:buNone/>
-              <a:defRPr sz="900"/>
+            <a:lvl6pPr marL="2798521" indent="0">
+              <a:buNone/>
+              <a:defRPr sz="1102"/>
             </a:lvl6pPr>
-            <a:lvl7pPr marL="2743200" indent="0">
-              <a:buNone/>
-              <a:defRPr sz="900"/>
+            <a:lvl7pPr marL="3358225" indent="0">
+              <a:buNone/>
+              <a:defRPr sz="1102"/>
             </a:lvl7pPr>
-            <a:lvl8pPr marL="3200400" indent="0">
-              <a:buNone/>
-              <a:defRPr sz="900"/>
+            <a:lvl8pPr marL="3917930" indent="0">
+              <a:buNone/>
+              <a:defRPr sz="1102"/>
             </a:lvl8pPr>
-            <a:lvl9pPr marL="3657600" indent="0">
-              <a:buNone/>
-              <a:defRPr sz="900"/>
+            <a:lvl9pPr marL="4477634" indent="0">
+              <a:buNone/>
+              <a:defRPr sz="1102"/>
             </a:lvl9pPr>
           </a:lstStyle>
           <a:p>
@@ -2778,15 +2783,15 @@
         </p:nvSpPr>
         <p:spPr>
           <a:xfrm>
-            <a:off x="1792288" y="4800600"/>
-            <a:ext cx="5486400" cy="566738"/>
+            <a:off x="2194140" y="4800600"/>
+            <a:ext cx="6716515" cy="566738"/>
           </a:xfrm>
         </p:spPr>
         <p:txBody>
           <a:bodyPr anchor="b"/>
           <a:lstStyle>
             <a:lvl1pPr algn="l">
-              <a:defRPr sz="2000" b="1"/>
+              <a:defRPr sz="2448" b="1"/>
             </a:lvl1pPr>
           </a:lstStyle>
           <a:p>
@@ -2809,8 +2814,8 @@
         </p:nvSpPr>
         <p:spPr>
           <a:xfrm>
-            <a:off x="1792288" y="612775"/>
-            <a:ext cx="5486400" cy="4114800"/>
+            <a:off x="2194140" y="612775"/>
+            <a:ext cx="6716515" cy="4114800"/>
           </a:xfrm>
         </p:spPr>
         <p:txBody>
@@ -2818,39 +2823,39 @@
           <a:lstStyle>
             <a:lvl1pPr marL="0" indent="0">
               <a:buNone/>
-              <a:defRPr sz="3200"/>
+              <a:defRPr sz="3917"/>
             </a:lvl1pPr>
-            <a:lvl2pPr marL="457200" indent="0">
-              <a:buNone/>
-              <a:defRPr sz="2800"/>
+            <a:lvl2pPr marL="559704" indent="0">
+              <a:buNone/>
+              <a:defRPr sz="3428"/>
             </a:lvl2pPr>
-            <a:lvl3pPr marL="914400" indent="0">
-              <a:buNone/>
-              <a:defRPr sz="2400"/>
+            <a:lvl3pPr marL="1119408" indent="0">
+              <a:buNone/>
+              <a:defRPr sz="2938"/>
             </a:lvl3pPr>
-            <a:lvl4pPr marL="1371600" indent="0">
-              <a:buNone/>
-              <a:defRPr sz="2000"/>
+            <a:lvl4pPr marL="1679113" indent="0">
+              <a:buNone/>
+              <a:defRPr sz="2448"/>
             </a:lvl4pPr>
-            <a:lvl5pPr marL="1828800" indent="0">
-              <a:buNone/>
-              <a:defRPr sz="2000"/>
+            <a:lvl5pPr marL="2238817" indent="0">
+              <a:buNone/>
+              <a:defRPr sz="2448"/>
             </a:lvl5pPr>
-            <a:lvl6pPr marL="2286000" indent="0">
-              <a:buNone/>
-              <a:defRPr sz="2000"/>
+            <a:lvl6pPr marL="2798521" indent="0">
+              <a:buNone/>
+              <a:defRPr sz="2448"/>
             </a:lvl6pPr>
-            <a:lvl7pPr marL="2743200" indent="0">
-              <a:buNone/>
-              <a:defRPr sz="2000"/>
+            <a:lvl7pPr marL="3358225" indent="0">
+              <a:buNone/>
+              <a:defRPr sz="2448"/>
             </a:lvl7pPr>
-            <a:lvl8pPr marL="3200400" indent="0">
-              <a:buNone/>
-              <a:defRPr sz="2000"/>
+            <a:lvl8pPr marL="3917930" indent="0">
+              <a:buNone/>
+              <a:defRPr sz="2448"/>
             </a:lvl8pPr>
-            <a:lvl9pPr marL="3657600" indent="0">
-              <a:buNone/>
-              <a:defRPr sz="2000"/>
+            <a:lvl9pPr marL="4477634" indent="0">
+              <a:buNone/>
+              <a:defRPr sz="2448"/>
             </a:lvl9pPr>
           </a:lstStyle>
           <a:p>
@@ -2870,8 +2875,8 @@
         </p:nvSpPr>
         <p:spPr>
           <a:xfrm>
-            <a:off x="1792288" y="5367338"/>
-            <a:ext cx="5486400" cy="804862"/>
+            <a:off x="2194140" y="5367338"/>
+            <a:ext cx="6716515" cy="804862"/>
           </a:xfrm>
         </p:spPr>
         <p:txBody>
@@ -2879,39 +2884,39 @@
           <a:lstStyle>
             <a:lvl1pPr marL="0" indent="0">
               <a:buNone/>
-              <a:defRPr sz="1400"/>
+              <a:defRPr sz="1714"/>
             </a:lvl1pPr>
-            <a:lvl2pPr marL="457200" indent="0">
-              <a:buNone/>
-              <a:defRPr sz="1200"/>
+            <a:lvl2pPr marL="559704" indent="0">
+              <a:buNone/>
+              <a:defRPr sz="1469"/>
             </a:lvl2pPr>
-            <a:lvl3pPr marL="914400" indent="0">
-              <a:buNone/>
-              <a:defRPr sz="1000"/>
+            <a:lvl3pPr marL="1119408" indent="0">
+              <a:buNone/>
+              <a:defRPr sz="1224"/>
             </a:lvl3pPr>
-            <a:lvl4pPr marL="1371600" indent="0">
-              <a:buNone/>
-              <a:defRPr sz="900"/>
+            <a:lvl4pPr marL="1679113" indent="0">
+              <a:buNone/>
+              <a:defRPr sz="1102"/>
             </a:lvl4pPr>
-            <a:lvl5pPr marL="1828800" indent="0">
-              <a:buNone/>
-              <a:defRPr sz="900"/>
+            <a:lvl5pPr marL="2238817" indent="0">
+              <a:buNone/>
+              <a:defRPr sz="1102"/>
             </a:lvl5pPr>
-            <a:lvl6pPr marL="2286000" indent="0">
-              <a:buNone/>
-              <a:defRPr sz="900"/>
+            <a:lvl6pPr marL="2798521" indent="0">
+              <a:buNone/>
+              <a:defRPr sz="1102"/>
             </a:lvl6pPr>
-            <a:lvl7pPr marL="2743200" indent="0">
-              <a:buNone/>
-              <a:defRPr sz="900"/>
+            <a:lvl7pPr marL="3358225" indent="0">
+              <a:buNone/>
+              <a:defRPr sz="1102"/>
             </a:lvl7pPr>
-            <a:lvl8pPr marL="3200400" indent="0">
-              <a:buNone/>
-              <a:defRPr sz="900"/>
+            <a:lvl8pPr marL="3917930" indent="0">
+              <a:buNone/>
+              <a:defRPr sz="1102"/>
             </a:lvl8pPr>
-            <a:lvl9pPr marL="3657600" indent="0">
-              <a:buNone/>
-              <a:defRPr sz="900"/>
+            <a:lvl9pPr marL="4477634" indent="0">
+              <a:buNone/>
+              <a:defRPr sz="1102"/>
             </a:lvl9pPr>
           </a:lstStyle>
           <a:p>
@@ -3035,8 +3040,8 @@
         </p:nvSpPr>
         <p:spPr>
           <a:xfrm>
-            <a:off x="457200" y="274638"/>
-            <a:ext cx="8229600" cy="1143000"/>
+            <a:off x="559710" y="274638"/>
+            <a:ext cx="10074773" cy="1143000"/>
           </a:xfrm>
           <a:prstGeom prst="rect">
             <a:avLst/>
@@ -3067,8 +3072,8 @@
         </p:nvSpPr>
         <p:spPr>
           <a:xfrm>
-            <a:off x="457200" y="1600200"/>
-            <a:ext cx="8229600" cy="4525963"/>
+            <a:off x="559710" y="1600201"/>
+            <a:ext cx="10074773" cy="4525963"/>
           </a:xfrm>
           <a:prstGeom prst="rect">
             <a:avLst/>
@@ -3128,8 +3133,8 @@
         </p:nvSpPr>
         <p:spPr>
           <a:xfrm>
-            <a:off x="457200" y="6356350"/>
-            <a:ext cx="2133600" cy="365125"/>
+            <a:off x="559710" y="6356351"/>
+            <a:ext cx="2611978" cy="365125"/>
           </a:xfrm>
           <a:prstGeom prst="rect">
             <a:avLst/>
@@ -3139,7 +3144,7 @@
           <a:bodyPr vert="horz" lIns="91440" tIns="45720" rIns="91440" bIns="45720" rtlCol="0" anchor="ctr"/>
           <a:lstStyle>
             <a:lvl1pPr algn="l">
-              <a:defRPr sz="1200">
+              <a:defRPr sz="1469">
                 <a:solidFill>
                   <a:schemeClr val="tx1">
                     <a:tint val="75000"/>
@@ -3169,8 +3174,8 @@
         </p:nvSpPr>
         <p:spPr>
           <a:xfrm>
-            <a:off x="3124200" y="6356350"/>
-            <a:ext cx="2895600" cy="365125"/>
+            <a:off x="3824682" y="6356351"/>
+            <a:ext cx="3544828" cy="365125"/>
           </a:xfrm>
           <a:prstGeom prst="rect">
             <a:avLst/>
@@ -3180,7 +3185,7 @@
           <a:bodyPr vert="horz" lIns="91440" tIns="45720" rIns="91440" bIns="45720" rtlCol="0" anchor="ctr"/>
           <a:lstStyle>
             <a:lvl1pPr algn="ctr">
-              <a:defRPr sz="1200">
+              <a:defRPr sz="1469">
                 <a:solidFill>
                   <a:schemeClr val="tx1">
                     <a:tint val="75000"/>
@@ -3206,8 +3211,8 @@
         </p:nvSpPr>
         <p:spPr>
           <a:xfrm>
-            <a:off x="6553200" y="6356350"/>
-            <a:ext cx="2133600" cy="365125"/>
+            <a:off x="8022504" y="6356351"/>
+            <a:ext cx="2611978" cy="365125"/>
           </a:xfrm>
           <a:prstGeom prst="rect">
             <a:avLst/>
@@ -3217,7 +3222,7 @@
           <a:bodyPr vert="horz" lIns="91440" tIns="45720" rIns="91440" bIns="45720" rtlCol="0" anchor="ctr"/>
           <a:lstStyle>
             <a:lvl1pPr algn="r">
-              <a:defRPr sz="1200">
+              <a:defRPr sz="1469">
                 <a:solidFill>
                   <a:schemeClr val="tx1">
                     <a:tint val="75000"/>
@@ -3258,12 +3263,12 @@
   </p:sldLayoutIdLst>
   <p:txStyles>
     <p:titleStyle>
-      <a:lvl1pPr algn="ctr" defTabSz="457200" rtl="0" eaLnBrk="1" latinLnBrk="0" hangingPunct="1">
+      <a:lvl1pPr algn="ctr" defTabSz="559704" rtl="0" eaLnBrk="1" latinLnBrk="0" hangingPunct="1">
         <a:spcBef>
           <a:spcPct val="0"/>
         </a:spcBef>
         <a:buNone/>
-        <a:defRPr sz="4400" kern="1200">
+        <a:defRPr sz="5386" kern="1200">
           <a:solidFill>
             <a:schemeClr val="tx1"/>
           </a:solidFill>
@@ -3274,13 +3279,13 @@
       </a:lvl1pPr>
     </p:titleStyle>
     <p:bodyStyle>
-      <a:lvl1pPr marL="342900" indent="-342900" algn="l" defTabSz="457200" rtl="0" eaLnBrk="1" latinLnBrk="0" hangingPunct="1">
+      <a:lvl1pPr marL="419778" indent="-419778" algn="l" defTabSz="559704" rtl="0" eaLnBrk="1" latinLnBrk="0" hangingPunct="1">
         <a:spcBef>
           <a:spcPct val="20000"/>
         </a:spcBef>
         <a:buFont typeface="Arial"/>
         <a:buChar char="•"/>
-        <a:defRPr sz="3200" kern="1200">
+        <a:defRPr sz="3917" kern="1200">
           <a:solidFill>
             <a:schemeClr val="tx1"/>
           </a:solidFill>
@@ -3289,13 +3294,13 @@
           <a:cs typeface="+mn-cs"/>
         </a:defRPr>
       </a:lvl1pPr>
-      <a:lvl2pPr marL="742950" indent="-285750" algn="l" defTabSz="457200" rtl="0" eaLnBrk="1" latinLnBrk="0" hangingPunct="1">
+      <a:lvl2pPr marL="909519" indent="-349815" algn="l" defTabSz="559704" rtl="0" eaLnBrk="1" latinLnBrk="0" hangingPunct="1">
         <a:spcBef>
           <a:spcPct val="20000"/>
         </a:spcBef>
         <a:buFont typeface="Arial"/>
         <a:buChar char="–"/>
-        <a:defRPr sz="2800" kern="1200">
+        <a:defRPr sz="3428" kern="1200">
           <a:solidFill>
             <a:schemeClr val="tx1"/>
           </a:solidFill>
@@ -3304,13 +3309,13 @@
           <a:cs typeface="+mn-cs"/>
         </a:defRPr>
       </a:lvl2pPr>
-      <a:lvl3pPr marL="1143000" indent="-228600" algn="l" defTabSz="457200" rtl="0" eaLnBrk="1" latinLnBrk="0" hangingPunct="1">
+      <a:lvl3pPr marL="1399261" indent="-279852" algn="l" defTabSz="559704" rtl="0" eaLnBrk="1" latinLnBrk="0" hangingPunct="1">
         <a:spcBef>
           <a:spcPct val="20000"/>
         </a:spcBef>
         <a:buFont typeface="Arial"/>
         <a:buChar char="•"/>
-        <a:defRPr sz="2400" kern="1200">
+        <a:defRPr sz="2938" kern="1200">
           <a:solidFill>
             <a:schemeClr val="tx1"/>
           </a:solidFill>
@@ -3319,13 +3324,13 @@
           <a:cs typeface="+mn-cs"/>
         </a:defRPr>
       </a:lvl3pPr>
-      <a:lvl4pPr marL="1600200" indent="-228600" algn="l" defTabSz="457200" rtl="0" eaLnBrk="1" latinLnBrk="0" hangingPunct="1">
+      <a:lvl4pPr marL="1958965" indent="-279852" algn="l" defTabSz="559704" rtl="0" eaLnBrk="1" latinLnBrk="0" hangingPunct="1">
         <a:spcBef>
           <a:spcPct val="20000"/>
         </a:spcBef>
         <a:buFont typeface="Arial"/>
         <a:buChar char="–"/>
-        <a:defRPr sz="2000" kern="1200">
+        <a:defRPr sz="2448" kern="1200">
           <a:solidFill>
             <a:schemeClr val="tx1"/>
           </a:solidFill>
@@ -3334,13 +3339,13 @@
           <a:cs typeface="+mn-cs"/>
         </a:defRPr>
       </a:lvl4pPr>
-      <a:lvl5pPr marL="2057400" indent="-228600" algn="l" defTabSz="457200" rtl="0" eaLnBrk="1" latinLnBrk="0" hangingPunct="1">
+      <a:lvl5pPr marL="2518669" indent="-279852" algn="l" defTabSz="559704" rtl="0" eaLnBrk="1" latinLnBrk="0" hangingPunct="1">
         <a:spcBef>
           <a:spcPct val="20000"/>
         </a:spcBef>
         <a:buFont typeface="Arial"/>
         <a:buChar char="»"/>
-        <a:defRPr sz="2000" kern="1200">
+        <a:defRPr sz="2448" kern="1200">
           <a:solidFill>
             <a:schemeClr val="tx1"/>
           </a:solidFill>
@@ -3349,13 +3354,13 @@
           <a:cs typeface="+mn-cs"/>
         </a:defRPr>
       </a:lvl5pPr>
-      <a:lvl6pPr marL="2514600" indent="-228600" algn="l" defTabSz="457200" rtl="0" eaLnBrk="1" latinLnBrk="0" hangingPunct="1">
+      <a:lvl6pPr marL="3078373" indent="-279852" algn="l" defTabSz="559704" rtl="0" eaLnBrk="1" latinLnBrk="0" hangingPunct="1">
         <a:spcBef>
           <a:spcPct val="20000"/>
         </a:spcBef>
         <a:buFont typeface="Arial"/>
         <a:buChar char="•"/>
-        <a:defRPr sz="2000" kern="1200">
+        <a:defRPr sz="2448" kern="1200">
           <a:solidFill>
             <a:schemeClr val="tx1"/>
           </a:solidFill>
@@ -3364,13 +3369,13 @@
           <a:cs typeface="+mn-cs"/>
         </a:defRPr>
       </a:lvl6pPr>
-      <a:lvl7pPr marL="2971800" indent="-228600" algn="l" defTabSz="457200" rtl="0" eaLnBrk="1" latinLnBrk="0" hangingPunct="1">
+      <a:lvl7pPr marL="3638078" indent="-279852" algn="l" defTabSz="559704" rtl="0" eaLnBrk="1" latinLnBrk="0" hangingPunct="1">
         <a:spcBef>
           <a:spcPct val="20000"/>
         </a:spcBef>
         <a:buFont typeface="Arial"/>
         <a:buChar char="•"/>
-        <a:defRPr sz="2000" kern="1200">
+        <a:defRPr sz="2448" kern="1200">
           <a:solidFill>
             <a:schemeClr val="tx1"/>
           </a:solidFill>
@@ -3379,13 +3384,13 @@
           <a:cs typeface="+mn-cs"/>
         </a:defRPr>
       </a:lvl7pPr>
-      <a:lvl8pPr marL="3429000" indent="-228600" algn="l" defTabSz="457200" rtl="0" eaLnBrk="1" latinLnBrk="0" hangingPunct="1">
+      <a:lvl8pPr marL="4197782" indent="-279852" algn="l" defTabSz="559704" rtl="0" eaLnBrk="1" latinLnBrk="0" hangingPunct="1">
         <a:spcBef>
           <a:spcPct val="20000"/>
         </a:spcBef>
         <a:buFont typeface="Arial"/>
         <a:buChar char="•"/>
-        <a:defRPr sz="2000" kern="1200">
+        <a:defRPr sz="2448" kern="1200">
           <a:solidFill>
             <a:schemeClr val="tx1"/>
           </a:solidFill>
@@ -3394,13 +3399,13 @@
           <a:cs typeface="+mn-cs"/>
         </a:defRPr>
       </a:lvl8pPr>
-      <a:lvl9pPr marL="3886200" indent="-228600" algn="l" defTabSz="457200" rtl="0" eaLnBrk="1" latinLnBrk="0" hangingPunct="1">
+      <a:lvl9pPr marL="4757486" indent="-279852" algn="l" defTabSz="559704" rtl="0" eaLnBrk="1" latinLnBrk="0" hangingPunct="1">
         <a:spcBef>
           <a:spcPct val="20000"/>
         </a:spcBef>
         <a:buFont typeface="Arial"/>
         <a:buChar char="•"/>
-        <a:defRPr sz="2000" kern="1200">
+        <a:defRPr sz="2448" kern="1200">
           <a:solidFill>
             <a:schemeClr val="tx1"/>
           </a:solidFill>
@@ -3414,8 +3419,8 @@
       <a:defPPr>
         <a:defRPr lang="en-US"/>
       </a:defPPr>
-      <a:lvl1pPr marL="0" algn="l" defTabSz="457200" rtl="0" eaLnBrk="1" latinLnBrk="0" hangingPunct="1">
-        <a:defRPr sz="1800" kern="1200">
+      <a:lvl1pPr marL="0" algn="l" defTabSz="559704" rtl="0" eaLnBrk="1" latinLnBrk="0" hangingPunct="1">
+        <a:defRPr sz="2204" kern="1200">
           <a:solidFill>
             <a:schemeClr val="tx1"/>
           </a:solidFill>
@@ -3424,8 +3429,8 @@
           <a:cs typeface="+mn-cs"/>
         </a:defRPr>
       </a:lvl1pPr>
-      <a:lvl2pPr marL="457200" algn="l" defTabSz="457200" rtl="0" eaLnBrk="1" latinLnBrk="0" hangingPunct="1">
-        <a:defRPr sz="1800" kern="1200">
+      <a:lvl2pPr marL="559704" algn="l" defTabSz="559704" rtl="0" eaLnBrk="1" latinLnBrk="0" hangingPunct="1">
+        <a:defRPr sz="2204" kern="1200">
           <a:solidFill>
             <a:schemeClr val="tx1"/>
           </a:solidFill>
@@ -3434,8 +3439,8 @@
           <a:cs typeface="+mn-cs"/>
         </a:defRPr>
       </a:lvl2pPr>
-      <a:lvl3pPr marL="914400" algn="l" defTabSz="457200" rtl="0" eaLnBrk="1" latinLnBrk="0" hangingPunct="1">
-        <a:defRPr sz="1800" kern="1200">
+      <a:lvl3pPr marL="1119408" algn="l" defTabSz="559704" rtl="0" eaLnBrk="1" latinLnBrk="0" hangingPunct="1">
+        <a:defRPr sz="2204" kern="1200">
           <a:solidFill>
             <a:schemeClr val="tx1"/>
           </a:solidFill>
@@ -3444,8 +3449,8 @@
           <a:cs typeface="+mn-cs"/>
         </a:defRPr>
       </a:lvl3pPr>
-      <a:lvl4pPr marL="1371600" algn="l" defTabSz="457200" rtl="0" eaLnBrk="1" latinLnBrk="0" hangingPunct="1">
-        <a:defRPr sz="1800" kern="1200">
+      <a:lvl4pPr marL="1679113" algn="l" defTabSz="559704" rtl="0" eaLnBrk="1" latinLnBrk="0" hangingPunct="1">
+        <a:defRPr sz="2204" kern="1200">
           <a:solidFill>
             <a:schemeClr val="tx1"/>
           </a:solidFill>
@@ -3454,8 +3459,8 @@
           <a:cs typeface="+mn-cs"/>
         </a:defRPr>
       </a:lvl4pPr>
-      <a:lvl5pPr marL="1828800" algn="l" defTabSz="457200" rtl="0" eaLnBrk="1" latinLnBrk="0" hangingPunct="1">
-        <a:defRPr sz="1800" kern="1200">
+      <a:lvl5pPr marL="2238817" algn="l" defTabSz="559704" rtl="0" eaLnBrk="1" latinLnBrk="0" hangingPunct="1">
+        <a:defRPr sz="2204" kern="1200">
           <a:solidFill>
             <a:schemeClr val="tx1"/>
           </a:solidFill>
@@ -3464,8 +3469,8 @@
           <a:cs typeface="+mn-cs"/>
         </a:defRPr>
       </a:lvl5pPr>
-      <a:lvl6pPr marL="2286000" algn="l" defTabSz="457200" rtl="0" eaLnBrk="1" latinLnBrk="0" hangingPunct="1">
-        <a:defRPr sz="1800" kern="1200">
+      <a:lvl6pPr marL="2798521" algn="l" defTabSz="559704" rtl="0" eaLnBrk="1" latinLnBrk="0" hangingPunct="1">
+        <a:defRPr sz="2204" kern="1200">
           <a:solidFill>
             <a:schemeClr val="tx1"/>
           </a:solidFill>
@@ -3474,8 +3479,8 @@
           <a:cs typeface="+mn-cs"/>
         </a:defRPr>
       </a:lvl6pPr>
-      <a:lvl7pPr marL="2743200" algn="l" defTabSz="457200" rtl="0" eaLnBrk="1" latinLnBrk="0" hangingPunct="1">
-        <a:defRPr sz="1800" kern="1200">
+      <a:lvl7pPr marL="3358225" algn="l" defTabSz="559704" rtl="0" eaLnBrk="1" latinLnBrk="0" hangingPunct="1">
+        <a:defRPr sz="2204" kern="1200">
           <a:solidFill>
             <a:schemeClr val="tx1"/>
           </a:solidFill>
@@ -3484,8 +3489,8 @@
           <a:cs typeface="+mn-cs"/>
         </a:defRPr>
       </a:lvl7pPr>
-      <a:lvl8pPr marL="3200400" algn="l" defTabSz="457200" rtl="0" eaLnBrk="1" latinLnBrk="0" hangingPunct="1">
-        <a:defRPr sz="1800" kern="1200">
+      <a:lvl8pPr marL="3917930" algn="l" defTabSz="559704" rtl="0" eaLnBrk="1" latinLnBrk="0" hangingPunct="1">
+        <a:defRPr sz="2204" kern="1200">
           <a:solidFill>
             <a:schemeClr val="tx1"/>
           </a:solidFill>
@@ -3494,8 +3499,8 @@
           <a:cs typeface="+mn-cs"/>
         </a:defRPr>
       </a:lvl8pPr>
-      <a:lvl9pPr marL="3657600" algn="l" defTabSz="457200" rtl="0" eaLnBrk="1" latinLnBrk="0" hangingPunct="1">
-        <a:defRPr sz="1800" kern="1200">
+      <a:lvl9pPr marL="4477634" algn="l" defTabSz="559704" rtl="0" eaLnBrk="1" latinLnBrk="0" hangingPunct="1">
+        <a:defRPr sz="2204" kern="1200">
           <a:solidFill>
             <a:schemeClr val="tx1"/>
           </a:solidFill>
@@ -3528,1122 +3533,14 @@
       </p:grpSpPr>
       <p:sp>
         <p:nvSpPr>
-          <p:cNvPr id="8" name="fig2_ZZ">
-            <a:extLst>
-              <a:ext uri="{FF2B5EF4-FFF2-40B4-BE49-F238E27FC236}">
-                <a16:creationId xmlns:a16="http://schemas.microsoft.com/office/drawing/2014/main" id="{4DC81660-84CE-9F87-754B-2F2332A3B29B}"/>
-              </a:ext>
-            </a:extLst>
-          </p:cNvPr>
-          <p:cNvSpPr/>
-          <p:nvPr/>
-        </p:nvSpPr>
-        <p:spPr>
-          <a:xfrm>
-            <a:off x="-44130" y="2104914"/>
-            <a:ext cx="5869172" cy="1887276"/>
-          </a:xfrm>
-          <a:prstGeom prst="rect">
-            <a:avLst/>
-          </a:prstGeom>
-          <a:solidFill>
-            <a:schemeClr val="tx1"/>
-          </a:solidFill>
-          <a:ln>
-            <a:solidFill>
-              <a:schemeClr val="tx1"/>
-            </a:solidFill>
-          </a:ln>
-        </p:spPr>
-        <p:style>
-          <a:lnRef idx="1">
-            <a:schemeClr val="accent1"/>
-          </a:lnRef>
-          <a:fillRef idx="3">
-            <a:schemeClr val="accent1"/>
-          </a:fillRef>
-          <a:effectRef idx="2">
-            <a:schemeClr val="accent1"/>
-          </a:effectRef>
-          <a:fontRef idx="minor">
-            <a:schemeClr val="lt1"/>
-          </a:fontRef>
-        </p:style>
-        <p:txBody>
-          <a:bodyPr rtlCol="0" anchor="ctr"/>
-          <a:lstStyle/>
-          <a:p>
-            <a:pPr algn="ctr"/>
-            <a:endParaRPr lang="en-US"/>
-          </a:p>
-        </p:txBody>
-      </p:sp>
-      <p:sp>
-        <p:nvSpPr>
-          <p:cNvPr id="4" name="fig2_Z">
-            <a:extLst>
-              <a:ext uri="{FF2B5EF4-FFF2-40B4-BE49-F238E27FC236}">
-                <a16:creationId xmlns:a16="http://schemas.microsoft.com/office/drawing/2014/main" id="{887714A9-A995-E5C7-0A97-B52896DEE30B}"/>
-              </a:ext>
-            </a:extLst>
-          </p:cNvPr>
-          <p:cNvSpPr/>
-          <p:nvPr/>
-        </p:nvSpPr>
-        <p:spPr>
-          <a:xfrm>
-            <a:off x="-42530" y="-37213"/>
-            <a:ext cx="5869172" cy="2138618"/>
-          </a:xfrm>
-          <a:prstGeom prst="rect">
-            <a:avLst/>
-          </a:prstGeom>
-          <a:solidFill>
-            <a:schemeClr val="tx1">
-              <a:lumMod val="50000"/>
-              <a:lumOff val="50000"/>
-            </a:schemeClr>
-          </a:solidFill>
-          <a:ln>
-            <a:solidFill>
-              <a:schemeClr val="tx1">
-                <a:lumMod val="50000"/>
-                <a:lumOff val="50000"/>
-              </a:schemeClr>
-            </a:solidFill>
-          </a:ln>
-        </p:spPr>
-        <p:style>
-          <a:lnRef idx="1">
-            <a:schemeClr val="accent1"/>
-          </a:lnRef>
-          <a:fillRef idx="3">
-            <a:schemeClr val="accent1"/>
-          </a:fillRef>
-          <a:effectRef idx="2">
-            <a:schemeClr val="accent1"/>
-          </a:effectRef>
-          <a:fontRef idx="minor">
-            <a:schemeClr val="lt1"/>
-          </a:fontRef>
-        </p:style>
-        <p:txBody>
-          <a:bodyPr rtlCol="0" anchor="ctr"/>
-          <a:lstStyle/>
-          <a:p>
-            <a:pPr algn="ctr"/>
-            <a:endParaRPr lang="en-US"/>
-          </a:p>
-        </p:txBody>
-      </p:sp>
-      <p:sp>
-        <p:nvSpPr>
-          <p:cNvPr id="16" name="fig2_E">
-            <a:extLst>
-              <a:ext uri="{FF2B5EF4-FFF2-40B4-BE49-F238E27FC236}">
-                <a16:creationId xmlns:a16="http://schemas.microsoft.com/office/drawing/2014/main" id="{CA95EF0E-DF3A-1A8B-009B-6C4C8C120264}"/>
-              </a:ext>
-            </a:extLst>
-          </p:cNvPr>
-          <p:cNvSpPr/>
-          <p:nvPr/>
-        </p:nvSpPr>
-        <p:spPr>
-          <a:xfrm>
-            <a:off x="4628478" y="7982"/>
-            <a:ext cx="1116000" cy="1032929"/>
-          </a:xfrm>
-          <a:prstGeom prst="rect">
-            <a:avLst/>
-          </a:prstGeom>
-          <a:solidFill>
-            <a:srgbClr val="F5E8D0"/>
-          </a:solidFill>
-          <a:ln w="6350">
-            <a:solidFill>
-              <a:srgbClr val="808080"/>
-            </a:solidFill>
-          </a:ln>
-        </p:spPr>
-        <p:style>
-          <a:lnRef idx="1">
-            <a:schemeClr val="accent1"/>
-          </a:lnRef>
-          <a:fillRef idx="3">
-            <a:schemeClr val="accent1"/>
-          </a:fillRef>
-          <a:effectRef idx="2">
-            <a:schemeClr val="accent1"/>
-          </a:effectRef>
-          <a:fontRef idx="minor">
-            <a:schemeClr val="lt1"/>
-          </a:fontRef>
-        </p:style>
-        <p:txBody>
-          <a:bodyPr wrap="none" rtlCol="0" anchor="ctr"/>
-          <a:lstStyle/>
-          <a:p>
-            <a:pPr algn="ctr"/>
-            <a:r>
-              <a:rPr lang="en-US" sz="1000" b="1" dirty="0">
-                <a:solidFill>
-                  <a:srgbClr val="333333"/>
-                </a:solidFill>
-              </a:rPr>
-              <a:t>E</a:t>
-            </a:r>
-            <a:r>
-              <a:rPr sz="1000" b="1" dirty="0">
-                <a:solidFill>
-                  <a:srgbClr val="333333"/>
-                </a:solidFill>
-              </a:rPr>
-              <a:t>
-51×52 mm</a:t>
-            </a:r>
-          </a:p>
-        </p:txBody>
-      </p:sp>
-      <p:sp>
-        <p:nvSpPr>
-          <p:cNvPr id="18" name="fig2_F">
-            <a:extLst>
-              <a:ext uri="{FF2B5EF4-FFF2-40B4-BE49-F238E27FC236}">
-                <a16:creationId xmlns:a16="http://schemas.microsoft.com/office/drawing/2014/main" id="{4A3AC555-CC08-7C9F-5508-2473A4703C7C}"/>
-              </a:ext>
-            </a:extLst>
-          </p:cNvPr>
-          <p:cNvSpPr/>
-          <p:nvPr/>
-        </p:nvSpPr>
-        <p:spPr>
-          <a:xfrm>
-            <a:off x="7251" y="1075073"/>
-            <a:ext cx="1559896" cy="1026332"/>
-          </a:xfrm>
-          <a:prstGeom prst="rect">
-            <a:avLst/>
-          </a:prstGeom>
-          <a:solidFill>
-            <a:srgbClr val="F5E8D0"/>
-          </a:solidFill>
-          <a:ln w="6350">
-            <a:solidFill>
-              <a:srgbClr val="808080"/>
-            </a:solidFill>
-          </a:ln>
-        </p:spPr>
-        <p:style>
-          <a:lnRef idx="1">
-            <a:schemeClr val="accent1"/>
-          </a:lnRef>
-          <a:fillRef idx="3">
-            <a:schemeClr val="accent1"/>
-          </a:fillRef>
-          <a:effectRef idx="2">
-            <a:schemeClr val="accent1"/>
-          </a:effectRef>
-          <a:fontRef idx="minor">
-            <a:schemeClr val="lt1"/>
-          </a:fontRef>
-        </p:style>
-        <p:txBody>
-          <a:bodyPr wrap="none" rtlCol="0" anchor="ctr"/>
-          <a:lstStyle/>
-          <a:p>
-            <a:pPr algn="ctr"/>
-            <a:r>
-              <a:rPr lang="en-US" sz="1000" b="1" dirty="0">
-                <a:solidFill>
-                  <a:srgbClr val="333333"/>
-                </a:solidFill>
-              </a:rPr>
-              <a:t>F</a:t>
-            </a:r>
-            <a:r>
-              <a:rPr sz="1000" b="1" dirty="0">
-                <a:solidFill>
-                  <a:srgbClr val="333333"/>
-                </a:solidFill>
-              </a:rPr>
-              <a:t>
-51×52 mm</a:t>
-            </a:r>
-          </a:p>
-        </p:txBody>
-      </p:sp>
-      <p:sp>
-        <p:nvSpPr>
-          <p:cNvPr id="20" name="fig2_G">
-            <a:extLst>
-              <a:ext uri="{FF2B5EF4-FFF2-40B4-BE49-F238E27FC236}">
-                <a16:creationId xmlns:a16="http://schemas.microsoft.com/office/drawing/2014/main" id="{0CA36138-F1FC-0BC1-8EEB-DBBEE0088383}"/>
-              </a:ext>
-            </a:extLst>
-          </p:cNvPr>
-          <p:cNvSpPr/>
-          <p:nvPr/>
-        </p:nvSpPr>
-        <p:spPr>
-          <a:xfrm>
-            <a:off x="1620631" y="1075072"/>
-            <a:ext cx="1116000" cy="1029841"/>
-          </a:xfrm>
-          <a:prstGeom prst="rect">
-            <a:avLst/>
-          </a:prstGeom>
-          <a:solidFill>
-            <a:srgbClr val="F5E8D0"/>
-          </a:solidFill>
-          <a:ln w="6350">
-            <a:solidFill>
-              <a:srgbClr val="808080"/>
-            </a:solidFill>
-          </a:ln>
-        </p:spPr>
-        <p:style>
-          <a:lnRef idx="1">
-            <a:schemeClr val="accent1"/>
-          </a:lnRef>
-          <a:fillRef idx="3">
-            <a:schemeClr val="accent1"/>
-          </a:fillRef>
-          <a:effectRef idx="2">
-            <a:schemeClr val="accent1"/>
-          </a:effectRef>
-          <a:fontRef idx="minor">
-            <a:schemeClr val="lt1"/>
-          </a:fontRef>
-        </p:style>
-        <p:txBody>
-          <a:bodyPr wrap="none" rtlCol="0" anchor="ctr"/>
-          <a:lstStyle/>
-          <a:p>
-            <a:pPr algn="ctr"/>
-            <a:r>
-              <a:rPr lang="en-US" sz="1000" b="1" dirty="0">
-                <a:solidFill>
-                  <a:srgbClr val="333333"/>
-                </a:solidFill>
-              </a:rPr>
-              <a:t>G</a:t>
-            </a:r>
-            <a:r>
-              <a:rPr sz="1000" b="1" dirty="0">
-                <a:solidFill>
-                  <a:srgbClr val="333333"/>
-                </a:solidFill>
-              </a:rPr>
-              <a:t>
-51×52 mm</a:t>
-            </a:r>
-          </a:p>
-        </p:txBody>
-      </p:sp>
-      <p:sp>
-        <p:nvSpPr>
-          <p:cNvPr id="22" name="fig2_H">
-            <a:extLst>
-              <a:ext uri="{FF2B5EF4-FFF2-40B4-BE49-F238E27FC236}">
-                <a16:creationId xmlns:a16="http://schemas.microsoft.com/office/drawing/2014/main" id="{112CC553-7965-2DB1-9C5A-02B00F3F9A86}"/>
-              </a:ext>
-            </a:extLst>
-          </p:cNvPr>
-          <p:cNvSpPr/>
-          <p:nvPr/>
-        </p:nvSpPr>
-        <p:spPr>
-          <a:xfrm>
-            <a:off x="2809261" y="1069643"/>
-            <a:ext cx="1559896" cy="1035271"/>
-          </a:xfrm>
-          <a:prstGeom prst="rect">
-            <a:avLst/>
-          </a:prstGeom>
-          <a:solidFill>
-            <a:srgbClr val="F5E8D0"/>
-          </a:solidFill>
-          <a:ln w="6350">
-            <a:solidFill>
-              <a:srgbClr val="808080"/>
-            </a:solidFill>
-          </a:ln>
-        </p:spPr>
-        <p:style>
-          <a:lnRef idx="1">
-            <a:schemeClr val="accent1"/>
-          </a:lnRef>
-          <a:fillRef idx="3">
-            <a:schemeClr val="accent1"/>
-          </a:fillRef>
-          <a:effectRef idx="2">
-            <a:schemeClr val="accent1"/>
-          </a:effectRef>
-          <a:fontRef idx="minor">
-            <a:schemeClr val="lt1"/>
-          </a:fontRef>
-        </p:style>
-        <p:txBody>
-          <a:bodyPr wrap="none" rtlCol="0" anchor="ctr"/>
-          <a:lstStyle/>
-          <a:p>
-            <a:pPr algn="ctr"/>
-            <a:r>
-              <a:rPr lang="en-US" sz="1000" b="1" dirty="0">
-                <a:solidFill>
-                  <a:srgbClr val="333333"/>
-                </a:solidFill>
-              </a:rPr>
-              <a:t>H</a:t>
-            </a:r>
-            <a:r>
-              <a:rPr sz="1000" b="1" dirty="0">
-                <a:solidFill>
-                  <a:srgbClr val="333333"/>
-                </a:solidFill>
-              </a:rPr>
-              <a:t>
-51×52 mm</a:t>
-            </a:r>
-          </a:p>
-        </p:txBody>
-      </p:sp>
-      <p:sp>
-        <p:nvSpPr>
-          <p:cNvPr id="24" name="fig2_I">
-            <a:extLst>
-              <a:ext uri="{FF2B5EF4-FFF2-40B4-BE49-F238E27FC236}">
-                <a16:creationId xmlns:a16="http://schemas.microsoft.com/office/drawing/2014/main" id="{33FA2E5E-893D-E5AB-7CD8-9A095BA4F5B9}"/>
-              </a:ext>
-            </a:extLst>
-          </p:cNvPr>
-          <p:cNvSpPr/>
-          <p:nvPr/>
-        </p:nvSpPr>
-        <p:spPr>
-          <a:xfrm>
-            <a:off x="4619147" y="1071985"/>
-            <a:ext cx="1116000" cy="1032929"/>
-          </a:xfrm>
-          <a:prstGeom prst="rect">
-            <a:avLst/>
-          </a:prstGeom>
-          <a:solidFill>
-            <a:srgbClr val="F5E8D0"/>
-          </a:solidFill>
-          <a:ln w="6350">
-            <a:solidFill>
-              <a:srgbClr val="808080"/>
-            </a:solidFill>
-          </a:ln>
-        </p:spPr>
-        <p:style>
-          <a:lnRef idx="1">
-            <a:schemeClr val="accent1"/>
-          </a:lnRef>
-          <a:fillRef idx="3">
-            <a:schemeClr val="accent1"/>
-          </a:fillRef>
-          <a:effectRef idx="2">
-            <a:schemeClr val="accent1"/>
-          </a:effectRef>
-          <a:fontRef idx="minor">
-            <a:schemeClr val="lt1"/>
-          </a:fontRef>
-        </p:style>
-        <p:txBody>
-          <a:bodyPr wrap="none" rtlCol="0" anchor="ctr"/>
-          <a:lstStyle/>
-          <a:p>
-            <a:pPr algn="ctr"/>
-            <a:r>
-              <a:rPr lang="en-US" sz="1000" b="1" dirty="0">
-                <a:solidFill>
-                  <a:srgbClr val="333333"/>
-                </a:solidFill>
-              </a:rPr>
-              <a:t>I</a:t>
-            </a:r>
-            <a:r>
-              <a:rPr sz="1000" b="1" dirty="0">
-                <a:solidFill>
-                  <a:srgbClr val="333333"/>
-                </a:solidFill>
-              </a:rPr>
-              <a:t>
-51×52 mm</a:t>
-            </a:r>
-          </a:p>
-        </p:txBody>
-      </p:sp>
-      <p:sp>
-        <p:nvSpPr>
-          <p:cNvPr id="26" name="fig2_J">
-            <a:extLst>
-              <a:ext uri="{FF2B5EF4-FFF2-40B4-BE49-F238E27FC236}">
-                <a16:creationId xmlns:a16="http://schemas.microsoft.com/office/drawing/2014/main" id="{91F3CB8E-0647-5B0A-623B-BAA61F0E536E}"/>
-              </a:ext>
-            </a:extLst>
-          </p:cNvPr>
-          <p:cNvSpPr/>
-          <p:nvPr/>
-        </p:nvSpPr>
-        <p:spPr>
-          <a:xfrm>
-            <a:off x="-1600" y="2161146"/>
-            <a:ext cx="1116000" cy="1080764"/>
-          </a:xfrm>
-          <a:prstGeom prst="rect">
-            <a:avLst/>
-          </a:prstGeom>
-          <a:solidFill>
-            <a:srgbClr val="F5E8D0"/>
-          </a:solidFill>
-          <a:ln w="6350">
-            <a:solidFill>
-              <a:srgbClr val="808080"/>
-            </a:solidFill>
-          </a:ln>
-        </p:spPr>
-        <p:style>
-          <a:lnRef idx="1">
-            <a:schemeClr val="accent1"/>
-          </a:lnRef>
-          <a:fillRef idx="3">
-            <a:schemeClr val="accent1"/>
-          </a:fillRef>
-          <a:effectRef idx="2">
-            <a:schemeClr val="accent1"/>
-          </a:effectRef>
-          <a:fontRef idx="minor">
-            <a:schemeClr val="lt1"/>
-          </a:fontRef>
-        </p:style>
-        <p:txBody>
-          <a:bodyPr wrap="none" rtlCol="0" anchor="ctr"/>
-          <a:lstStyle/>
-          <a:p>
-            <a:pPr algn="ctr"/>
-            <a:r>
-              <a:rPr lang="en-US" sz="1000" b="1" dirty="0">
-                <a:solidFill>
-                  <a:srgbClr val="333333"/>
-                </a:solidFill>
-              </a:rPr>
-              <a:t>J</a:t>
-            </a:r>
-            <a:r>
-              <a:rPr sz="1000" b="1" dirty="0">
-                <a:solidFill>
-                  <a:srgbClr val="333333"/>
-                </a:solidFill>
-              </a:rPr>
-              <a:t>
-51×52 mm</a:t>
-            </a:r>
-          </a:p>
-        </p:txBody>
-      </p:sp>
-      <p:sp>
-        <p:nvSpPr>
-          <p:cNvPr id="28" name="fig2_K">
-            <a:extLst>
-              <a:ext uri="{FF2B5EF4-FFF2-40B4-BE49-F238E27FC236}">
-                <a16:creationId xmlns:a16="http://schemas.microsoft.com/office/drawing/2014/main" id="{D7826737-5DF9-A565-B6D9-D613D4EDECCE}"/>
-              </a:ext>
-            </a:extLst>
-          </p:cNvPr>
-          <p:cNvSpPr/>
-          <p:nvPr/>
-        </p:nvSpPr>
-        <p:spPr>
-          <a:xfrm>
-            <a:off x="1187031" y="2166227"/>
-            <a:ext cx="1548000" cy="994321"/>
-          </a:xfrm>
-          <a:prstGeom prst="rect">
-            <a:avLst/>
-          </a:prstGeom>
-          <a:solidFill>
-            <a:srgbClr val="F5E8D0"/>
-          </a:solidFill>
-          <a:ln w="6350">
-            <a:solidFill>
-              <a:srgbClr val="808080"/>
-            </a:solidFill>
-          </a:ln>
-        </p:spPr>
-        <p:style>
-          <a:lnRef idx="1">
-            <a:schemeClr val="accent1"/>
-          </a:lnRef>
-          <a:fillRef idx="3">
-            <a:schemeClr val="accent1"/>
-          </a:fillRef>
-          <a:effectRef idx="2">
-            <a:schemeClr val="accent1"/>
-          </a:effectRef>
-          <a:fontRef idx="minor">
-            <a:schemeClr val="lt1"/>
-          </a:fontRef>
-        </p:style>
-        <p:txBody>
-          <a:bodyPr wrap="none" rtlCol="0" anchor="ctr"/>
-          <a:lstStyle/>
-          <a:p>
-            <a:pPr algn="ctr"/>
-            <a:r>
-              <a:rPr lang="en-US" sz="1000" b="1" dirty="0">
-                <a:solidFill>
-                  <a:srgbClr val="333333"/>
-                </a:solidFill>
-              </a:rPr>
-              <a:t>K</a:t>
-            </a:r>
-            <a:r>
-              <a:rPr sz="1000" b="1" dirty="0">
-                <a:solidFill>
-                  <a:srgbClr val="333333"/>
-                </a:solidFill>
-              </a:rPr>
-              <a:t>
-51×52 mm</a:t>
-            </a:r>
-          </a:p>
-        </p:txBody>
-      </p:sp>
-      <p:sp>
-        <p:nvSpPr>
-          <p:cNvPr id="30" name="fig2_P">
-            <a:extLst>
-              <a:ext uri="{FF2B5EF4-FFF2-40B4-BE49-F238E27FC236}">
-                <a16:creationId xmlns:a16="http://schemas.microsoft.com/office/drawing/2014/main" id="{4B9BEAF1-E32B-18AC-71C5-7973920C7D76}"/>
-              </a:ext>
-            </a:extLst>
-          </p:cNvPr>
-          <p:cNvSpPr/>
-          <p:nvPr/>
-        </p:nvSpPr>
-        <p:spPr>
-          <a:xfrm>
-            <a:off x="1620630" y="3168915"/>
-            <a:ext cx="1116000" cy="823274"/>
-          </a:xfrm>
-          <a:prstGeom prst="rect">
-            <a:avLst/>
-          </a:prstGeom>
-          <a:solidFill>
-            <a:srgbClr val="F5E8D0"/>
-          </a:solidFill>
-          <a:ln w="6350">
-            <a:solidFill>
-              <a:srgbClr val="808080"/>
-            </a:solidFill>
-          </a:ln>
-        </p:spPr>
-        <p:style>
-          <a:lnRef idx="1">
-            <a:schemeClr val="accent1"/>
-          </a:lnRef>
-          <a:fillRef idx="3">
-            <a:schemeClr val="accent1"/>
-          </a:fillRef>
-          <a:effectRef idx="2">
-            <a:schemeClr val="accent1"/>
-          </a:effectRef>
-          <a:fontRef idx="minor">
-            <a:schemeClr val="lt1"/>
-          </a:fontRef>
-        </p:style>
-        <p:txBody>
-          <a:bodyPr wrap="none" rtlCol="0" anchor="ctr"/>
-          <a:lstStyle/>
-          <a:p>
-            <a:pPr algn="ctr"/>
-            <a:r>
-              <a:rPr lang="en-US" sz="1000" b="1" dirty="0">
-                <a:solidFill>
-                  <a:srgbClr val="333333"/>
-                </a:solidFill>
-              </a:rPr>
-              <a:t>P
-</a:t>
-            </a:r>
-            <a:r>
-              <a:rPr sz="1000" b="1" dirty="0">
-                <a:solidFill>
-                  <a:srgbClr val="333333"/>
-                </a:solidFill>
-              </a:rPr>
-              <a:t>51×52 mm</a:t>
-            </a:r>
-          </a:p>
-        </p:txBody>
-      </p:sp>
-      <p:sp>
-        <p:nvSpPr>
-          <p:cNvPr id="32" name="fig2_L">
-            <a:extLst>
-              <a:ext uri="{FF2B5EF4-FFF2-40B4-BE49-F238E27FC236}">
-                <a16:creationId xmlns:a16="http://schemas.microsoft.com/office/drawing/2014/main" id="{4697FDE0-95F9-683B-0261-CD3656EB6C5F}"/>
-              </a:ext>
-            </a:extLst>
-          </p:cNvPr>
-          <p:cNvSpPr/>
-          <p:nvPr/>
-        </p:nvSpPr>
-        <p:spPr>
-          <a:xfrm>
-            <a:off x="2807662" y="2166227"/>
-            <a:ext cx="576000" cy="994321"/>
-          </a:xfrm>
-          <a:prstGeom prst="rect">
-            <a:avLst/>
-          </a:prstGeom>
-          <a:solidFill>
-            <a:srgbClr val="F5E8D0"/>
-          </a:solidFill>
-          <a:ln w="6350">
-            <a:solidFill>
-              <a:srgbClr val="808080"/>
-            </a:solidFill>
-          </a:ln>
-        </p:spPr>
-        <p:style>
-          <a:lnRef idx="1">
-            <a:schemeClr val="accent1"/>
-          </a:lnRef>
-          <a:fillRef idx="3">
-            <a:schemeClr val="accent1"/>
-          </a:fillRef>
-          <a:effectRef idx="2">
-            <a:schemeClr val="accent1"/>
-          </a:effectRef>
-          <a:fontRef idx="minor">
-            <a:schemeClr val="lt1"/>
-          </a:fontRef>
-        </p:style>
-        <p:txBody>
-          <a:bodyPr wrap="none" rtlCol="0" anchor="ctr"/>
-          <a:lstStyle/>
-          <a:p>
-            <a:pPr algn="ctr"/>
-            <a:r>
-              <a:rPr lang="en-US" sz="1000" b="1" dirty="0">
-                <a:solidFill>
-                  <a:srgbClr val="333333"/>
-                </a:solidFill>
-              </a:rPr>
-              <a:t>L</a:t>
-            </a:r>
-            <a:r>
-              <a:rPr sz="1000" b="1" dirty="0">
-                <a:solidFill>
-                  <a:srgbClr val="333333"/>
-                </a:solidFill>
-              </a:rPr>
-              <a:t>
-51×52 mm</a:t>
-            </a:r>
-          </a:p>
-        </p:txBody>
-      </p:sp>
-      <p:sp>
-        <p:nvSpPr>
-          <p:cNvPr id="34" name="fig2_M">
-            <a:extLst>
-              <a:ext uri="{FF2B5EF4-FFF2-40B4-BE49-F238E27FC236}">
-                <a16:creationId xmlns:a16="http://schemas.microsoft.com/office/drawing/2014/main" id="{2DC4DE53-0BDF-CD07-C7F9-5FA97F0CDF3D}"/>
-              </a:ext>
-            </a:extLst>
-          </p:cNvPr>
-          <p:cNvSpPr/>
-          <p:nvPr/>
-        </p:nvSpPr>
-        <p:spPr>
-          <a:xfrm>
-            <a:off x="3443646" y="2171489"/>
-            <a:ext cx="1116000" cy="997428"/>
-          </a:xfrm>
-          <a:prstGeom prst="rect">
-            <a:avLst/>
-          </a:prstGeom>
-          <a:solidFill>
-            <a:srgbClr val="F5E8D0"/>
-          </a:solidFill>
-          <a:ln w="6350">
-            <a:solidFill>
-              <a:srgbClr val="808080"/>
-            </a:solidFill>
-          </a:ln>
-        </p:spPr>
-        <p:style>
-          <a:lnRef idx="1">
-            <a:schemeClr val="accent1"/>
-          </a:lnRef>
-          <a:fillRef idx="3">
-            <a:schemeClr val="accent1"/>
-          </a:fillRef>
-          <a:effectRef idx="2">
-            <a:schemeClr val="accent1"/>
-          </a:effectRef>
-          <a:fontRef idx="minor">
-            <a:schemeClr val="lt1"/>
-          </a:fontRef>
-        </p:style>
-        <p:txBody>
-          <a:bodyPr wrap="none" rtlCol="0" anchor="ctr"/>
-          <a:lstStyle/>
-          <a:p>
-            <a:pPr algn="ctr"/>
-            <a:r>
-              <a:rPr lang="en-US" sz="1000" b="1" dirty="0">
-                <a:solidFill>
-                  <a:srgbClr val="333333"/>
-                </a:solidFill>
-              </a:rPr>
-              <a:t>M</a:t>
-            </a:r>
-            <a:r>
-              <a:rPr sz="1000" b="1" dirty="0">
-                <a:solidFill>
-                  <a:srgbClr val="333333"/>
-                </a:solidFill>
-              </a:rPr>
-              <a:t>
-51×52 mm</a:t>
-            </a:r>
-          </a:p>
-        </p:txBody>
-      </p:sp>
-      <p:sp>
-        <p:nvSpPr>
-          <p:cNvPr id="36" name="fig2_N">
-            <a:extLst>
-              <a:ext uri="{FF2B5EF4-FFF2-40B4-BE49-F238E27FC236}">
-                <a16:creationId xmlns:a16="http://schemas.microsoft.com/office/drawing/2014/main" id="{0F09EC13-CEF1-2761-6318-FDF663E79161}"/>
-              </a:ext>
-            </a:extLst>
-          </p:cNvPr>
-          <p:cNvSpPr/>
-          <p:nvPr/>
-        </p:nvSpPr>
-        <p:spPr>
-          <a:xfrm>
-            <a:off x="4628478" y="2166227"/>
-            <a:ext cx="1116000" cy="1002690"/>
-          </a:xfrm>
-          <a:prstGeom prst="rect">
-            <a:avLst/>
-          </a:prstGeom>
-          <a:solidFill>
-            <a:srgbClr val="F5E8D0"/>
-          </a:solidFill>
-          <a:ln w="6350">
-            <a:solidFill>
-              <a:srgbClr val="808080"/>
-            </a:solidFill>
-          </a:ln>
-        </p:spPr>
-        <p:style>
-          <a:lnRef idx="1">
-            <a:schemeClr val="accent1"/>
-          </a:lnRef>
-          <a:fillRef idx="3">
-            <a:schemeClr val="accent1"/>
-          </a:fillRef>
-          <a:effectRef idx="2">
-            <a:schemeClr val="accent1"/>
-          </a:effectRef>
-          <a:fontRef idx="minor">
-            <a:schemeClr val="lt1"/>
-          </a:fontRef>
-        </p:style>
-        <p:txBody>
-          <a:bodyPr wrap="none" rtlCol="0" anchor="ctr"/>
-          <a:lstStyle/>
-          <a:p>
-            <a:pPr algn="ctr"/>
-            <a:r>
-              <a:rPr lang="en-US" sz="1000" b="1" dirty="0">
-                <a:solidFill>
-                  <a:srgbClr val="333333"/>
-                </a:solidFill>
-              </a:rPr>
-              <a:t>N</a:t>
-            </a:r>
-            <a:r>
-              <a:rPr sz="1000" b="1" dirty="0">
-                <a:solidFill>
-                  <a:srgbClr val="333333"/>
-                </a:solidFill>
-              </a:rPr>
-              <a:t>
-51×52 mm</a:t>
-            </a:r>
-          </a:p>
-        </p:txBody>
-      </p:sp>
-      <p:sp>
-        <p:nvSpPr>
-          <p:cNvPr id="38" name="fig2_O">
-            <a:extLst>
-              <a:ext uri="{FF2B5EF4-FFF2-40B4-BE49-F238E27FC236}">
-                <a16:creationId xmlns:a16="http://schemas.microsoft.com/office/drawing/2014/main" id="{E73FA2B4-191E-3521-7B6F-6569D721D403}"/>
-              </a:ext>
-            </a:extLst>
-          </p:cNvPr>
-          <p:cNvSpPr/>
-          <p:nvPr/>
-        </p:nvSpPr>
-        <p:spPr>
-          <a:xfrm>
-            <a:off x="-3200" y="3183037"/>
-            <a:ext cx="1548000" cy="809152"/>
-          </a:xfrm>
-          <a:prstGeom prst="rect">
-            <a:avLst/>
-          </a:prstGeom>
-          <a:solidFill>
-            <a:srgbClr val="F5E8D0"/>
-          </a:solidFill>
-          <a:ln w="6350">
-            <a:solidFill>
-              <a:srgbClr val="808080"/>
-            </a:solidFill>
-          </a:ln>
-        </p:spPr>
-        <p:style>
-          <a:lnRef idx="1">
-            <a:schemeClr val="accent1"/>
-          </a:lnRef>
-          <a:fillRef idx="3">
-            <a:schemeClr val="accent1"/>
-          </a:fillRef>
-          <a:effectRef idx="2">
-            <a:schemeClr val="accent1"/>
-          </a:effectRef>
-          <a:fontRef idx="minor">
-            <a:schemeClr val="lt1"/>
-          </a:fontRef>
-        </p:style>
-        <p:txBody>
-          <a:bodyPr wrap="none" rtlCol="0" anchor="ctr"/>
-          <a:lstStyle/>
-          <a:p>
-            <a:pPr algn="ctr"/>
-            <a:r>
-              <a:rPr lang="en-US" sz="1000" b="1" dirty="0">
-                <a:solidFill>
-                  <a:srgbClr val="333333"/>
-                </a:solidFill>
-              </a:rPr>
-              <a:t>O
-</a:t>
-            </a:r>
-            <a:r>
-              <a:rPr sz="1000" b="1" dirty="0">
-                <a:solidFill>
-                  <a:srgbClr val="333333"/>
-                </a:solidFill>
-              </a:rPr>
-              <a:t>51×52 mm</a:t>
-            </a:r>
-          </a:p>
-        </p:txBody>
-      </p:sp>
-      <p:sp>
-        <p:nvSpPr>
-          <p:cNvPr id="14" name="fig2_D">
-            <a:extLst>
-              <a:ext uri="{FF2B5EF4-FFF2-40B4-BE49-F238E27FC236}">
-                <a16:creationId xmlns:a16="http://schemas.microsoft.com/office/drawing/2014/main" id="{79992732-9DF7-35AE-2F1C-B7DDCF062859}"/>
-              </a:ext>
-            </a:extLst>
-          </p:cNvPr>
-          <p:cNvSpPr/>
-          <p:nvPr/>
-        </p:nvSpPr>
-        <p:spPr>
-          <a:xfrm>
-            <a:off x="3451743" y="7982"/>
-            <a:ext cx="1116000" cy="1037788"/>
-          </a:xfrm>
-          <a:prstGeom prst="rect">
-            <a:avLst/>
-          </a:prstGeom>
-          <a:solidFill>
-            <a:srgbClr val="F5E8D0"/>
-          </a:solidFill>
-          <a:ln w="6350">
-            <a:solidFill>
-              <a:srgbClr val="808080"/>
-            </a:solidFill>
-          </a:ln>
-        </p:spPr>
-        <p:style>
-          <a:lnRef idx="1">
-            <a:schemeClr val="accent1"/>
-          </a:lnRef>
-          <a:fillRef idx="3">
-            <a:schemeClr val="accent1"/>
-          </a:fillRef>
-          <a:effectRef idx="2">
-            <a:schemeClr val="accent1"/>
-          </a:effectRef>
-          <a:fontRef idx="minor">
-            <a:schemeClr val="lt1"/>
-          </a:fontRef>
-        </p:style>
-        <p:txBody>
-          <a:bodyPr wrap="none" rtlCol="0" anchor="ctr"/>
-          <a:lstStyle/>
-          <a:p>
-            <a:pPr algn="ctr"/>
-            <a:r>
-              <a:rPr lang="en-US" sz="1000" b="1" dirty="0">
-                <a:solidFill>
-                  <a:srgbClr val="333333"/>
-                </a:solidFill>
-              </a:rPr>
-              <a:t>D</a:t>
-            </a:r>
-            <a:r>
-              <a:rPr sz="1000" b="1" dirty="0">
-                <a:solidFill>
-                  <a:srgbClr val="333333"/>
-                </a:solidFill>
-              </a:rPr>
-              <a:t>
-51×52 mm</a:t>
-            </a:r>
-          </a:p>
-        </p:txBody>
-      </p:sp>
-      <p:sp>
-        <p:nvSpPr>
-          <p:cNvPr id="12" name="fig2_C">
-            <a:extLst>
-              <a:ext uri="{FF2B5EF4-FFF2-40B4-BE49-F238E27FC236}">
-                <a16:creationId xmlns:a16="http://schemas.microsoft.com/office/drawing/2014/main" id="{CAA566B7-B833-6B71-2A3B-8EA11E44DBF6}"/>
-              </a:ext>
-            </a:extLst>
-          </p:cNvPr>
-          <p:cNvSpPr/>
-          <p:nvPr/>
-        </p:nvSpPr>
-        <p:spPr>
-          <a:xfrm>
-            <a:off x="2809262" y="3123"/>
-            <a:ext cx="576000" cy="1037788"/>
-          </a:xfrm>
-          <a:prstGeom prst="rect">
-            <a:avLst/>
-          </a:prstGeom>
-          <a:solidFill>
-            <a:srgbClr val="F5E8D0"/>
-          </a:solidFill>
-          <a:ln w="6350">
-            <a:solidFill>
-              <a:srgbClr val="808080"/>
-            </a:solidFill>
-          </a:ln>
-        </p:spPr>
-        <p:style>
-          <a:lnRef idx="1">
-            <a:schemeClr val="accent1"/>
-          </a:lnRef>
-          <a:fillRef idx="3">
-            <a:schemeClr val="accent1"/>
-          </a:fillRef>
-          <a:effectRef idx="2">
-            <a:schemeClr val="accent1"/>
-          </a:effectRef>
-          <a:fontRef idx="minor">
-            <a:schemeClr val="lt1"/>
-          </a:fontRef>
-        </p:style>
-        <p:txBody>
-          <a:bodyPr wrap="none" rtlCol="0" anchor="ctr"/>
-          <a:lstStyle/>
-          <a:p>
-            <a:pPr algn="ctr"/>
-            <a:r>
-              <a:rPr sz="1000" b="1" dirty="0">
-                <a:solidFill>
-                  <a:srgbClr val="333333"/>
-                </a:solidFill>
-              </a:rPr>
-              <a:t>C
-51×52 mm</a:t>
-            </a:r>
-          </a:p>
-        </p:txBody>
-      </p:sp>
-      <p:sp>
-        <p:nvSpPr>
-          <p:cNvPr id="3" name="fig2_B"/>
-          <p:cNvSpPr/>
-          <p:nvPr/>
-        </p:nvSpPr>
-        <p:spPr>
-          <a:xfrm>
-            <a:off x="1176735" y="0"/>
-            <a:ext cx="1559896" cy="1040911"/>
-          </a:xfrm>
-          <a:prstGeom prst="rect">
-            <a:avLst/>
-          </a:prstGeom>
-          <a:solidFill>
-            <a:srgbClr val="D0F0E0"/>
-          </a:solidFill>
-          <a:ln w="6350">
-            <a:solidFill>
-              <a:srgbClr val="808080"/>
-            </a:solidFill>
-          </a:ln>
-        </p:spPr>
-        <p:style>
-          <a:lnRef idx="1">
-            <a:schemeClr val="accent1"/>
-          </a:lnRef>
-          <a:fillRef idx="3">
-            <a:schemeClr val="accent1"/>
-          </a:fillRef>
-          <a:effectRef idx="2">
-            <a:schemeClr val="accent1"/>
-          </a:effectRef>
-          <a:fontRef idx="minor">
-            <a:schemeClr val="lt1"/>
-          </a:fontRef>
-        </p:style>
-        <p:txBody>
-          <a:bodyPr wrap="none" rtlCol="0" anchor="ctr"/>
-          <a:lstStyle/>
-          <a:p>
-            <a:pPr algn="ctr"/>
-            <a:r>
-              <a:rPr sz="1000" b="1" dirty="0">
-                <a:solidFill>
-                  <a:srgbClr val="333333"/>
-                </a:solidFill>
-              </a:rPr>
-              <a:t>B
-52×52 mm</a:t>
-            </a:r>
-          </a:p>
-        </p:txBody>
-      </p:sp>
-      <p:sp>
-        <p:nvSpPr>
           <p:cNvPr id="2" name="fig2_A"/>
           <p:cNvSpPr/>
           <p:nvPr/>
         </p:nvSpPr>
         <p:spPr>
           <a:xfrm>
-            <a:off x="0" y="0"/>
-            <a:ext cx="1116000" cy="1040911"/>
+            <a:off x="139848" y="-912086"/>
+            <a:ext cx="6992636" cy="3081695"/>
           </a:xfrm>
           <a:prstGeom prst="rect">
             <a:avLst/>
@@ -4677,149 +3574,13 @@
           <a:p>
             <a:pPr algn="ctr"/>
             <a:r>
-              <a:rPr sz="1000" b="1" dirty="0">
+              <a:rPr sz="1224" b="1" dirty="0">
                 <a:solidFill>
                   <a:srgbClr val="333333"/>
                 </a:solidFill>
               </a:rPr>
               <a:t>A
 52×52 mm</a:t>
-            </a:r>
-          </a:p>
-        </p:txBody>
-      </p:sp>
-      <p:sp>
-        <p:nvSpPr>
-          <p:cNvPr id="5" name="fig2_Q">
-            <a:extLst>
-              <a:ext uri="{FF2B5EF4-FFF2-40B4-BE49-F238E27FC236}">
-                <a16:creationId xmlns:a16="http://schemas.microsoft.com/office/drawing/2014/main" id="{6282A2EC-B6E0-9DEB-A898-7D27C466D0B7}"/>
-              </a:ext>
-            </a:extLst>
-          </p:cNvPr>
-          <p:cNvSpPr/>
-          <p:nvPr/>
-        </p:nvSpPr>
-        <p:spPr>
-          <a:xfrm>
-            <a:off x="2815209" y="3175976"/>
-            <a:ext cx="1548000" cy="809152"/>
-          </a:xfrm>
-          <a:prstGeom prst="rect">
-            <a:avLst/>
-          </a:prstGeom>
-          <a:solidFill>
-            <a:srgbClr val="F5E8D0"/>
-          </a:solidFill>
-          <a:ln w="6350">
-            <a:solidFill>
-              <a:srgbClr val="808080"/>
-            </a:solidFill>
-          </a:ln>
-        </p:spPr>
-        <p:style>
-          <a:lnRef idx="1">
-            <a:schemeClr val="accent1"/>
-          </a:lnRef>
-          <a:fillRef idx="3">
-            <a:schemeClr val="accent1"/>
-          </a:fillRef>
-          <a:effectRef idx="2">
-            <a:schemeClr val="accent1"/>
-          </a:effectRef>
-          <a:fontRef idx="minor">
-            <a:schemeClr val="lt1"/>
-          </a:fontRef>
-        </p:style>
-        <p:txBody>
-          <a:bodyPr wrap="none" rtlCol="0" anchor="ctr"/>
-          <a:lstStyle/>
-          <a:p>
-            <a:pPr algn="ctr"/>
-            <a:r>
-              <a:rPr lang="en-US" sz="1000" b="1" dirty="0">
-                <a:solidFill>
-                  <a:srgbClr val="333333"/>
-                </a:solidFill>
-              </a:rPr>
-              <a:t>Q</a:t>
-            </a:r>
-            <a:r>
-              <a:rPr sz="1000" b="1" dirty="0">
-                <a:solidFill>
-                  <a:srgbClr val="333333"/>
-                </a:solidFill>
-              </a:rPr>
-              <a:t>
-51×52 mm</a:t>
-            </a:r>
-          </a:p>
-        </p:txBody>
-      </p:sp>
-      <p:sp>
-        <p:nvSpPr>
-          <p:cNvPr id="7" name="fig2_R">
-            <a:extLst>
-              <a:ext uri="{FF2B5EF4-FFF2-40B4-BE49-F238E27FC236}">
-                <a16:creationId xmlns:a16="http://schemas.microsoft.com/office/drawing/2014/main" id="{CC47702C-B2D9-29E2-3969-B426BF1240A8}"/>
-              </a:ext>
-            </a:extLst>
-          </p:cNvPr>
-          <p:cNvSpPr/>
-          <p:nvPr/>
-        </p:nvSpPr>
-        <p:spPr>
-          <a:xfrm>
-            <a:off x="4628478" y="3167899"/>
-            <a:ext cx="1116000" cy="824290"/>
-          </a:xfrm>
-          <a:prstGeom prst="rect">
-            <a:avLst/>
-          </a:prstGeom>
-          <a:solidFill>
-            <a:srgbClr val="F5E8D0"/>
-          </a:solidFill>
-          <a:ln w="6350">
-            <a:solidFill>
-              <a:srgbClr val="808080"/>
-            </a:solidFill>
-          </a:ln>
-        </p:spPr>
-        <p:style>
-          <a:lnRef idx="1">
-            <a:schemeClr val="accent1"/>
-          </a:lnRef>
-          <a:fillRef idx="3">
-            <a:schemeClr val="accent1"/>
-          </a:fillRef>
-          <a:effectRef idx="2">
-            <a:schemeClr val="accent1"/>
-          </a:effectRef>
-          <a:fontRef idx="minor">
-            <a:schemeClr val="lt1"/>
-          </a:fontRef>
-        </p:style>
-        <p:txBody>
-          <a:bodyPr wrap="none" rtlCol="0" anchor="ctr"/>
-          <a:lstStyle/>
-          <a:p>
-            <a:pPr algn="ctr"/>
-            <a:r>
-              <a:rPr lang="en-US" sz="1000" b="1" dirty="0">
-                <a:solidFill>
-                  <a:srgbClr val="333333"/>
-                </a:solidFill>
-              </a:rPr>
-              <a:t>R</a:t>
-            </a:r>
-            <a:r>
-              <a:rPr sz="1000" b="1" dirty="0">
-                <a:solidFill>
-                  <a:srgbClr val="333333"/>
-                </a:solidFill>
-              </a:rPr>
-              <a:t>
-51×52 mm</a:t>
             </a:r>
           </a:p>
         </p:txBody>

</xml_diff>